<commit_message>
update files in repo
</commit_message>
<xml_diff>
--- a/docs/coursework/review-2026-10-25/FixProof - Video V - Final Evidence Checkpoint.pptx
+++ b/docs/coursework/review-2026-10-25/FixProof - Video V - Final Evidence Checkpoint.pptx
@@ -196,9 +196,9 @@
             </a:lvl1pPr>
           </a:lstStyle>
           <a:p>
-            <a:fld id="{CFD53246-E1E7-4527-8A96-D1074CE9BE37}" type="datetimeFigureOut">
+            <a:fld id="{A2364B4C-33B9-49A2-B432-804A0D97B09B}" type="datetimeFigureOut">
               <a:rPr lang="en-US" smtClean="0"/>
-              <a:t>10/25/2026</a:t>
+              <a:t>10/26/2026</a:t>
             </a:fld>
             <a:endParaRPr lang="en-US"/>
           </a:p>
@@ -354,7 +354,7 @@
             </a:lvl1pPr>
           </a:lstStyle>
           <a:p>
-            <a:fld id="{D4D7A741-FF3E-44AA-8FD4-C21ACB24A822}" type="slidenum">
+            <a:fld id="{E410771D-F7DF-4012-AF9B-BAAA5866C217}" type="slidenum">
               <a:rPr lang="en-US" smtClean="0"/>
               <a:t>‹#›</a:t>
             </a:fld>
@@ -365,7 +365,7 @@
     </p:spTree>
     <p:extLst>
       <p:ext uri="{BB962C8B-B14F-4D97-AF65-F5344CB8AC3E}">
-        <p14:creationId xmlns:p14="http://schemas.microsoft.com/office/powerpoint/2010/main" val="602156936"/>
+        <p14:creationId xmlns:p14="http://schemas.microsoft.com/office/powerpoint/2010/main" val="435148115"/>
       </p:ext>
     </p:extLst>
   </p:cSld>
@@ -535,7 +535,7 @@
           <a:bodyPr/>
           <a:lstStyle/>
           <a:p>
-            <a:fld id="{D4D7A741-FF3E-44AA-8FD4-C21ACB24A822}" type="slidenum">
+            <a:fld id="{E410771D-F7DF-4012-AF9B-BAAA5866C217}" type="slidenum">
               <a:rPr lang="en-US" smtClean="0"/>
               <a:t>1</a:t>
             </a:fld>
@@ -546,7 +546,7 @@
     </p:spTree>
     <p:extLst>
       <p:ext uri="{BB962C8B-B14F-4D97-AF65-F5344CB8AC3E}">
-        <p14:creationId xmlns:p14="http://schemas.microsoft.com/office/powerpoint/2010/main" val="3442854714"/>
+        <p14:creationId xmlns:p14="http://schemas.microsoft.com/office/powerpoint/2010/main" val="545623572"/>
       </p:ext>
     </p:extLst>
   </p:cSld>
@@ -627,7 +627,7 @@
           <a:bodyPr/>
           <a:lstStyle/>
           <a:p>
-            <a:fld id="{D4D7A741-FF3E-44AA-8FD4-C21ACB24A822}" type="slidenum">
+            <a:fld id="{E410771D-F7DF-4012-AF9B-BAAA5866C217}" type="slidenum">
               <a:rPr lang="en-US" smtClean="0"/>
               <a:t>2</a:t>
             </a:fld>
@@ -638,7 +638,7 @@
     </p:spTree>
     <p:extLst>
       <p:ext uri="{BB962C8B-B14F-4D97-AF65-F5344CB8AC3E}">
-        <p14:creationId xmlns:p14="http://schemas.microsoft.com/office/powerpoint/2010/main" val="3765395797"/>
+        <p14:creationId xmlns:p14="http://schemas.microsoft.com/office/powerpoint/2010/main" val="1941846277"/>
       </p:ext>
     </p:extLst>
   </p:cSld>
@@ -721,7 +721,7 @@
           <a:bodyPr/>
           <a:lstStyle/>
           <a:p>
-            <a:fld id="{D4D7A741-FF3E-44AA-8FD4-C21ACB24A822}" type="slidenum">
+            <a:fld id="{E410771D-F7DF-4012-AF9B-BAAA5866C217}" type="slidenum">
               <a:rPr lang="en-US" smtClean="0"/>
               <a:t>3</a:t>
             </a:fld>
@@ -732,7 +732,7 @@
     </p:spTree>
     <p:extLst>
       <p:ext uri="{BB962C8B-B14F-4D97-AF65-F5344CB8AC3E}">
-        <p14:creationId xmlns:p14="http://schemas.microsoft.com/office/powerpoint/2010/main" val="2353698704"/>
+        <p14:creationId xmlns:p14="http://schemas.microsoft.com/office/powerpoint/2010/main" val="3274328110"/>
       </p:ext>
     </p:extLst>
   </p:cSld>
@@ -815,7 +815,7 @@
           <a:bodyPr/>
           <a:lstStyle/>
           <a:p>
-            <a:fld id="{D4D7A741-FF3E-44AA-8FD4-C21ACB24A822}" type="slidenum">
+            <a:fld id="{E410771D-F7DF-4012-AF9B-BAAA5866C217}" type="slidenum">
               <a:rPr lang="en-US" smtClean="0"/>
               <a:t>4</a:t>
             </a:fld>
@@ -826,7 +826,7 @@
     </p:spTree>
     <p:extLst>
       <p:ext uri="{BB962C8B-B14F-4D97-AF65-F5344CB8AC3E}">
-        <p14:creationId xmlns:p14="http://schemas.microsoft.com/office/powerpoint/2010/main" val="2711933203"/>
+        <p14:creationId xmlns:p14="http://schemas.microsoft.com/office/powerpoint/2010/main" val="1312246236"/>
       </p:ext>
     </p:extLst>
   </p:cSld>
@@ -909,7 +909,7 @@
           <a:bodyPr/>
           <a:lstStyle/>
           <a:p>
-            <a:fld id="{D4D7A741-FF3E-44AA-8FD4-C21ACB24A822}" type="slidenum">
+            <a:fld id="{E410771D-F7DF-4012-AF9B-BAAA5866C217}" type="slidenum">
               <a:rPr lang="en-US" smtClean="0"/>
               <a:t>5</a:t>
             </a:fld>
@@ -920,7 +920,7 @@
     </p:spTree>
     <p:extLst>
       <p:ext uri="{BB962C8B-B14F-4D97-AF65-F5344CB8AC3E}">
-        <p14:creationId xmlns:p14="http://schemas.microsoft.com/office/powerpoint/2010/main" val="1563388904"/>
+        <p14:creationId xmlns:p14="http://schemas.microsoft.com/office/powerpoint/2010/main" val="3067958529"/>
       </p:ext>
     </p:extLst>
   </p:cSld>
@@ -1001,7 +1001,7 @@
           <a:bodyPr/>
           <a:lstStyle/>
           <a:p>
-            <a:fld id="{D4D7A741-FF3E-44AA-8FD4-C21ACB24A822}" type="slidenum">
+            <a:fld id="{E410771D-F7DF-4012-AF9B-BAAA5866C217}" type="slidenum">
               <a:rPr lang="en-US" smtClean="0"/>
               <a:t>6</a:t>
             </a:fld>
@@ -1012,7 +1012,7 @@
     </p:spTree>
     <p:extLst>
       <p:ext uri="{BB962C8B-B14F-4D97-AF65-F5344CB8AC3E}">
-        <p14:creationId xmlns:p14="http://schemas.microsoft.com/office/powerpoint/2010/main" val="133846045"/>
+        <p14:creationId xmlns:p14="http://schemas.microsoft.com/office/powerpoint/2010/main" val="655428287"/>
       </p:ext>
     </p:extLst>
   </p:cSld>
@@ -1070,11 +1070,12 @@
               <a:rPr lang="en-US">
                 <a:latin typeface="Aptos" panose="020B0004020202020204" pitchFamily="34" charset="0"/>
               </a:rPr>
-              <a:t>My bounded conclusion is that FixProof exposed disagreements, regressions, and
-later qualifications in three controlled Express fixtures. It does not estimate
-production repair reliability. Next, I will synthesize peer feedback, finish
-the final report, generate the release manifest and checksums, and rehearse the
-final presentation.
+              <a:t>FixProof exposed disagreements, regressions, and later qualifications in three
+controlled Express fixtures—not production repair reliability. Video IV
+feedback split: one reviewer favored a second fixture, and another favored an
+independent rerun. I retained the requested audit trail, recorded a second
+fixture as future work, and do not call my clean rehearsal independent. Next
+are the final report, manifest and checksums, and final presentation.
 Is one candidate example enough to explain the separation between validators,
 policy, and human judgment?
 ChatGPT and Codex assisted development, testing, documentation, and drafting. I
@@ -1098,7 +1099,7 @@
           <a:bodyPr/>
           <a:lstStyle/>
           <a:p>
-            <a:fld id="{D4D7A741-FF3E-44AA-8FD4-C21ACB24A822}" type="slidenum">
+            <a:fld id="{E410771D-F7DF-4012-AF9B-BAAA5866C217}" type="slidenum">
               <a:rPr lang="en-US" smtClean="0"/>
               <a:t>7</a:t>
             </a:fld>
@@ -1109,7 +1110,7 @@
     </p:spTree>
     <p:extLst>
       <p:ext uri="{BB962C8B-B14F-4D97-AF65-F5344CB8AC3E}">
-        <p14:creationId xmlns:p14="http://schemas.microsoft.com/office/powerpoint/2010/main" val="1270293319"/>
+        <p14:creationId xmlns:p14="http://schemas.microsoft.com/office/powerpoint/2010/main" val="895358902"/>
       </p:ext>
     </p:extLst>
   </p:cSld>
@@ -1141,7 +1142,7 @@
           <p:cNvPr id="2" name="Title 1">
             <a:extLst>
               <a:ext uri="{FF2B5EF4-FFF2-40B4-BE49-F238E27FC236}">
-                <a16:creationId xmlns:a16="http://schemas.microsoft.com/office/drawing/2014/main" id="{547E9600-0E63-63E8-0202-F95B104B902E}"/>
+                <a16:creationId xmlns:a16="http://schemas.microsoft.com/office/drawing/2014/main" id="{775EBE3A-74C0-C7F5-C229-5989BF55C9F0}"/>
               </a:ext>
             </a:extLst>
           </p:cNvPr>
@@ -1178,7 +1179,7 @@
           <p:cNvPr id="3" name="Subtitle 2">
             <a:extLst>
               <a:ext uri="{FF2B5EF4-FFF2-40B4-BE49-F238E27FC236}">
-                <a16:creationId xmlns:a16="http://schemas.microsoft.com/office/drawing/2014/main" id="{E67A9352-34FD-0FB3-7357-FBA69B1825CA}"/>
+                <a16:creationId xmlns:a16="http://schemas.microsoft.com/office/drawing/2014/main" id="{69DB0136-AD34-6B4F-2F14-BFB396103B0B}"/>
               </a:ext>
             </a:extLst>
           </p:cNvPr>
@@ -1248,7 +1249,7 @@
           <p:cNvPr id="4" name="Date Placeholder 3">
             <a:extLst>
               <a:ext uri="{FF2B5EF4-FFF2-40B4-BE49-F238E27FC236}">
-                <a16:creationId xmlns:a16="http://schemas.microsoft.com/office/drawing/2014/main" id="{05F51292-0648-4D61-8DB0-2C82BFD0CD55}"/>
+                <a16:creationId xmlns:a16="http://schemas.microsoft.com/office/drawing/2014/main" id="{3FCA9DF3-A6D3-C839-7698-3A8CEC040951}"/>
               </a:ext>
             </a:extLst>
           </p:cNvPr>
@@ -1264,9 +1265,9 @@
           <a:bodyPr/>
           <a:lstStyle/>
           <a:p>
-            <a:fld id="{30B9F9EB-CD4E-4874-BAC5-1330E7B57B4B}" type="datetimeFigureOut">
+            <a:fld id="{2060D58E-3E2B-44B0-91AF-436A738F3104}" type="datetimeFigureOut">
               <a:rPr lang="en-US" smtClean="0"/>
-              <a:t>10/25/2026</a:t>
+              <a:t>10/26/2026</a:t>
             </a:fld>
             <a:endParaRPr lang="en-US"/>
           </a:p>
@@ -1277,7 +1278,7 @@
           <p:cNvPr id="5" name="Footer Placeholder 4">
             <a:extLst>
               <a:ext uri="{FF2B5EF4-FFF2-40B4-BE49-F238E27FC236}">
-                <a16:creationId xmlns:a16="http://schemas.microsoft.com/office/drawing/2014/main" id="{095AF8D5-F78C-8983-089A-AE41CA36CEE2}"/>
+                <a16:creationId xmlns:a16="http://schemas.microsoft.com/office/drawing/2014/main" id="{BEF59C13-F50C-3B03-021B-933ED6801DE2}"/>
               </a:ext>
             </a:extLst>
           </p:cNvPr>
@@ -1302,7 +1303,7 @@
           <p:cNvPr id="6" name="Slide Number Placeholder 5">
             <a:extLst>
               <a:ext uri="{FF2B5EF4-FFF2-40B4-BE49-F238E27FC236}">
-                <a16:creationId xmlns:a16="http://schemas.microsoft.com/office/drawing/2014/main" id="{2AC0C1FD-7159-9255-29FB-3228D55B6CCF}"/>
+                <a16:creationId xmlns:a16="http://schemas.microsoft.com/office/drawing/2014/main" id="{8061E13A-9ABD-360A-818C-39A840B87A74}"/>
               </a:ext>
             </a:extLst>
           </p:cNvPr>
@@ -1318,7 +1319,7 @@
           <a:bodyPr/>
           <a:lstStyle/>
           <a:p>
-            <a:fld id="{5408F11F-CBAB-4656-9671-9344DA70DEC6}" type="slidenum">
+            <a:fld id="{8C34E1F9-BFB2-47D3-BC8B-67B8C7F4FD80}" type="slidenum">
               <a:rPr lang="en-US" smtClean="0"/>
               <a:t>‹#›</a:t>
             </a:fld>
@@ -1329,7 +1330,7 @@
     </p:spTree>
     <p:extLst>
       <p:ext uri="{BB962C8B-B14F-4D97-AF65-F5344CB8AC3E}">
-        <p14:creationId xmlns:p14="http://schemas.microsoft.com/office/powerpoint/2010/main" val="4157808913"/>
+        <p14:creationId xmlns:p14="http://schemas.microsoft.com/office/powerpoint/2010/main" val="3648024764"/>
       </p:ext>
     </p:extLst>
   </p:cSld>
@@ -1361,7 +1362,7 @@
           <p:cNvPr id="2" name="Title 1">
             <a:extLst>
               <a:ext uri="{FF2B5EF4-FFF2-40B4-BE49-F238E27FC236}">
-                <a16:creationId xmlns:a16="http://schemas.microsoft.com/office/drawing/2014/main" id="{49DB2D68-D571-0A5A-DC8F-397C06647106}"/>
+                <a16:creationId xmlns:a16="http://schemas.microsoft.com/office/drawing/2014/main" id="{06A4C94C-F4FA-4ED7-E0BC-43C28D17F503}"/>
               </a:ext>
             </a:extLst>
           </p:cNvPr>
@@ -1389,7 +1390,7 @@
           <p:cNvPr id="3" name="Vertical Text Placeholder 2">
             <a:extLst>
               <a:ext uri="{FF2B5EF4-FFF2-40B4-BE49-F238E27FC236}">
-                <a16:creationId xmlns:a16="http://schemas.microsoft.com/office/drawing/2014/main" id="{B66C7DB9-09AB-E27D-A235-F06B5FDCAC43}"/>
+                <a16:creationId xmlns:a16="http://schemas.microsoft.com/office/drawing/2014/main" id="{BC002845-D048-1279-1EAC-C0F913489869}"/>
               </a:ext>
             </a:extLst>
           </p:cNvPr>
@@ -1446,7 +1447,7 @@
           <p:cNvPr id="4" name="Date Placeholder 3">
             <a:extLst>
               <a:ext uri="{FF2B5EF4-FFF2-40B4-BE49-F238E27FC236}">
-                <a16:creationId xmlns:a16="http://schemas.microsoft.com/office/drawing/2014/main" id="{647DEF9E-531E-30F2-6BFF-AEEBF7EC431A}"/>
+                <a16:creationId xmlns:a16="http://schemas.microsoft.com/office/drawing/2014/main" id="{22A5A3CD-42FA-18CE-7D11-767C754320EA}"/>
               </a:ext>
             </a:extLst>
           </p:cNvPr>
@@ -1462,9 +1463,9 @@
           <a:bodyPr/>
           <a:lstStyle/>
           <a:p>
-            <a:fld id="{30B9F9EB-CD4E-4874-BAC5-1330E7B57B4B}" type="datetimeFigureOut">
+            <a:fld id="{2060D58E-3E2B-44B0-91AF-436A738F3104}" type="datetimeFigureOut">
               <a:rPr lang="en-US" smtClean="0"/>
-              <a:t>10/25/2026</a:t>
+              <a:t>10/26/2026</a:t>
             </a:fld>
             <a:endParaRPr lang="en-US"/>
           </a:p>
@@ -1475,7 +1476,7 @@
           <p:cNvPr id="5" name="Footer Placeholder 4">
             <a:extLst>
               <a:ext uri="{FF2B5EF4-FFF2-40B4-BE49-F238E27FC236}">
-                <a16:creationId xmlns:a16="http://schemas.microsoft.com/office/drawing/2014/main" id="{2E7AD7C6-C657-4447-520F-184F2BF87E9D}"/>
+                <a16:creationId xmlns:a16="http://schemas.microsoft.com/office/drawing/2014/main" id="{198DB0DB-9505-668B-035C-8494AACE84D9}"/>
               </a:ext>
             </a:extLst>
           </p:cNvPr>
@@ -1500,7 +1501,7 @@
           <p:cNvPr id="6" name="Slide Number Placeholder 5">
             <a:extLst>
               <a:ext uri="{FF2B5EF4-FFF2-40B4-BE49-F238E27FC236}">
-                <a16:creationId xmlns:a16="http://schemas.microsoft.com/office/drawing/2014/main" id="{5472D983-E802-3F04-DACB-2F02843E8697}"/>
+                <a16:creationId xmlns:a16="http://schemas.microsoft.com/office/drawing/2014/main" id="{9970B004-C00D-4B71-D32A-200DADB32C0A}"/>
               </a:ext>
             </a:extLst>
           </p:cNvPr>
@@ -1516,7 +1517,7 @@
           <a:bodyPr/>
           <a:lstStyle/>
           <a:p>
-            <a:fld id="{5408F11F-CBAB-4656-9671-9344DA70DEC6}" type="slidenum">
+            <a:fld id="{8C34E1F9-BFB2-47D3-BC8B-67B8C7F4FD80}" type="slidenum">
               <a:rPr lang="en-US" smtClean="0"/>
               <a:t>‹#›</a:t>
             </a:fld>
@@ -1527,7 +1528,7 @@
     </p:spTree>
     <p:extLst>
       <p:ext uri="{BB962C8B-B14F-4D97-AF65-F5344CB8AC3E}">
-        <p14:creationId xmlns:p14="http://schemas.microsoft.com/office/powerpoint/2010/main" val="1770253685"/>
+        <p14:creationId xmlns:p14="http://schemas.microsoft.com/office/powerpoint/2010/main" val="783402688"/>
       </p:ext>
     </p:extLst>
   </p:cSld>
@@ -1559,7 +1560,7 @@
           <p:cNvPr id="2" name="Vertical Title 1">
             <a:extLst>
               <a:ext uri="{FF2B5EF4-FFF2-40B4-BE49-F238E27FC236}">
-                <a16:creationId xmlns:a16="http://schemas.microsoft.com/office/drawing/2014/main" id="{C008C6F8-D01E-B3F0-B2AB-29BB78335AFB}"/>
+                <a16:creationId xmlns:a16="http://schemas.microsoft.com/office/drawing/2014/main" id="{18619008-76A1-BE82-AD44-2B46FA5370AD}"/>
               </a:ext>
             </a:extLst>
           </p:cNvPr>
@@ -1592,7 +1593,7 @@
           <p:cNvPr id="3" name="Vertical Text Placeholder 2">
             <a:extLst>
               <a:ext uri="{FF2B5EF4-FFF2-40B4-BE49-F238E27FC236}">
-                <a16:creationId xmlns:a16="http://schemas.microsoft.com/office/drawing/2014/main" id="{37BAF02A-C20E-D4B2-1330-23B78808785A}"/>
+                <a16:creationId xmlns:a16="http://schemas.microsoft.com/office/drawing/2014/main" id="{09C4C487-12ED-F8C5-E06E-80735F591FCE}"/>
               </a:ext>
             </a:extLst>
           </p:cNvPr>
@@ -1654,7 +1655,7 @@
           <p:cNvPr id="4" name="Date Placeholder 3">
             <a:extLst>
               <a:ext uri="{FF2B5EF4-FFF2-40B4-BE49-F238E27FC236}">
-                <a16:creationId xmlns:a16="http://schemas.microsoft.com/office/drawing/2014/main" id="{F07C587D-F016-A142-CC7A-C18F69A3DBC6}"/>
+                <a16:creationId xmlns:a16="http://schemas.microsoft.com/office/drawing/2014/main" id="{7D8379D5-0426-F5FC-D9D7-363B50AA2E1D}"/>
               </a:ext>
             </a:extLst>
           </p:cNvPr>
@@ -1670,9 +1671,9 @@
           <a:bodyPr/>
           <a:lstStyle/>
           <a:p>
-            <a:fld id="{30B9F9EB-CD4E-4874-BAC5-1330E7B57B4B}" type="datetimeFigureOut">
+            <a:fld id="{2060D58E-3E2B-44B0-91AF-436A738F3104}" type="datetimeFigureOut">
               <a:rPr lang="en-US" smtClean="0"/>
-              <a:t>10/25/2026</a:t>
+              <a:t>10/26/2026</a:t>
             </a:fld>
             <a:endParaRPr lang="en-US"/>
           </a:p>
@@ -1683,7 +1684,7 @@
           <p:cNvPr id="5" name="Footer Placeholder 4">
             <a:extLst>
               <a:ext uri="{FF2B5EF4-FFF2-40B4-BE49-F238E27FC236}">
-                <a16:creationId xmlns:a16="http://schemas.microsoft.com/office/drawing/2014/main" id="{8EA97A3F-F7AD-F3C9-C5A5-2476969750B3}"/>
+                <a16:creationId xmlns:a16="http://schemas.microsoft.com/office/drawing/2014/main" id="{8187FCB9-670E-F957-7D9C-20ACD11C1FA6}"/>
               </a:ext>
             </a:extLst>
           </p:cNvPr>
@@ -1708,7 +1709,7 @@
           <p:cNvPr id="6" name="Slide Number Placeholder 5">
             <a:extLst>
               <a:ext uri="{FF2B5EF4-FFF2-40B4-BE49-F238E27FC236}">
-                <a16:creationId xmlns:a16="http://schemas.microsoft.com/office/drawing/2014/main" id="{CA922428-C7CD-3822-92D5-2E7A78F7376E}"/>
+                <a16:creationId xmlns:a16="http://schemas.microsoft.com/office/drawing/2014/main" id="{3544B740-609E-6C94-978A-82416E7AE49F}"/>
               </a:ext>
             </a:extLst>
           </p:cNvPr>
@@ -1724,7 +1725,7 @@
           <a:bodyPr/>
           <a:lstStyle/>
           <a:p>
-            <a:fld id="{5408F11F-CBAB-4656-9671-9344DA70DEC6}" type="slidenum">
+            <a:fld id="{8C34E1F9-BFB2-47D3-BC8B-67B8C7F4FD80}" type="slidenum">
               <a:rPr lang="en-US" smtClean="0"/>
               <a:t>‹#›</a:t>
             </a:fld>
@@ -1735,7 +1736,7 @@
     </p:spTree>
     <p:extLst>
       <p:ext uri="{BB962C8B-B14F-4D97-AF65-F5344CB8AC3E}">
-        <p14:creationId xmlns:p14="http://schemas.microsoft.com/office/powerpoint/2010/main" val="3476840802"/>
+        <p14:creationId xmlns:p14="http://schemas.microsoft.com/office/powerpoint/2010/main" val="2305696422"/>
       </p:ext>
     </p:extLst>
   </p:cSld>
@@ -1767,7 +1768,7 @@
           <p:cNvPr id="2" name="Title 1">
             <a:extLst>
               <a:ext uri="{FF2B5EF4-FFF2-40B4-BE49-F238E27FC236}">
-                <a16:creationId xmlns:a16="http://schemas.microsoft.com/office/drawing/2014/main" id="{71196C16-41F4-7779-D8E2-CEACE977A324}"/>
+                <a16:creationId xmlns:a16="http://schemas.microsoft.com/office/drawing/2014/main" id="{1A0EA10F-FFF2-A32A-6267-14E5DE330527}"/>
               </a:ext>
             </a:extLst>
           </p:cNvPr>
@@ -1795,7 +1796,7 @@
           <p:cNvPr id="3" name="Content Placeholder 2">
             <a:extLst>
               <a:ext uri="{FF2B5EF4-FFF2-40B4-BE49-F238E27FC236}">
-                <a16:creationId xmlns:a16="http://schemas.microsoft.com/office/drawing/2014/main" id="{FB1B4FF2-F124-9DFE-CADF-E13FC6EEC34D}"/>
+                <a16:creationId xmlns:a16="http://schemas.microsoft.com/office/drawing/2014/main" id="{B10E358A-B961-BFF2-5B05-AC7C46833641}"/>
               </a:ext>
             </a:extLst>
           </p:cNvPr>
@@ -1852,7 +1853,7 @@
           <p:cNvPr id="4" name="Date Placeholder 3">
             <a:extLst>
               <a:ext uri="{FF2B5EF4-FFF2-40B4-BE49-F238E27FC236}">
-                <a16:creationId xmlns:a16="http://schemas.microsoft.com/office/drawing/2014/main" id="{4960A832-5D5C-B6C1-DA2C-436E1F6E3550}"/>
+                <a16:creationId xmlns:a16="http://schemas.microsoft.com/office/drawing/2014/main" id="{4A0CF60E-5D17-71F1-2A5D-86EBCA5634D5}"/>
               </a:ext>
             </a:extLst>
           </p:cNvPr>
@@ -1868,9 +1869,9 @@
           <a:bodyPr/>
           <a:lstStyle/>
           <a:p>
-            <a:fld id="{30B9F9EB-CD4E-4874-BAC5-1330E7B57B4B}" type="datetimeFigureOut">
+            <a:fld id="{2060D58E-3E2B-44B0-91AF-436A738F3104}" type="datetimeFigureOut">
               <a:rPr lang="en-US" smtClean="0"/>
-              <a:t>10/25/2026</a:t>
+              <a:t>10/26/2026</a:t>
             </a:fld>
             <a:endParaRPr lang="en-US"/>
           </a:p>
@@ -1881,7 +1882,7 @@
           <p:cNvPr id="5" name="Footer Placeholder 4">
             <a:extLst>
               <a:ext uri="{FF2B5EF4-FFF2-40B4-BE49-F238E27FC236}">
-                <a16:creationId xmlns:a16="http://schemas.microsoft.com/office/drawing/2014/main" id="{4BB6174D-3059-1B56-B5BD-A0BEB4B6B246}"/>
+                <a16:creationId xmlns:a16="http://schemas.microsoft.com/office/drawing/2014/main" id="{545FC057-420D-7E18-65A1-893655E0142E}"/>
               </a:ext>
             </a:extLst>
           </p:cNvPr>
@@ -1906,7 +1907,7 @@
           <p:cNvPr id="6" name="Slide Number Placeholder 5">
             <a:extLst>
               <a:ext uri="{FF2B5EF4-FFF2-40B4-BE49-F238E27FC236}">
-                <a16:creationId xmlns:a16="http://schemas.microsoft.com/office/drawing/2014/main" id="{12FB871A-D936-9565-6B92-59E551B769B7}"/>
+                <a16:creationId xmlns:a16="http://schemas.microsoft.com/office/drawing/2014/main" id="{21DB55F6-CE02-6E3F-83CF-60A876AAA1F1}"/>
               </a:ext>
             </a:extLst>
           </p:cNvPr>
@@ -1922,7 +1923,7 @@
           <a:bodyPr/>
           <a:lstStyle/>
           <a:p>
-            <a:fld id="{5408F11F-CBAB-4656-9671-9344DA70DEC6}" type="slidenum">
+            <a:fld id="{8C34E1F9-BFB2-47D3-BC8B-67B8C7F4FD80}" type="slidenum">
               <a:rPr lang="en-US" smtClean="0"/>
               <a:t>‹#›</a:t>
             </a:fld>
@@ -1933,7 +1934,7 @@
     </p:spTree>
     <p:extLst>
       <p:ext uri="{BB962C8B-B14F-4D97-AF65-F5344CB8AC3E}">
-        <p14:creationId xmlns:p14="http://schemas.microsoft.com/office/powerpoint/2010/main" val="3470874478"/>
+        <p14:creationId xmlns:p14="http://schemas.microsoft.com/office/powerpoint/2010/main" val="575527594"/>
       </p:ext>
     </p:extLst>
   </p:cSld>
@@ -1965,7 +1966,7 @@
           <p:cNvPr id="2" name="Title 1">
             <a:extLst>
               <a:ext uri="{FF2B5EF4-FFF2-40B4-BE49-F238E27FC236}">
-                <a16:creationId xmlns:a16="http://schemas.microsoft.com/office/drawing/2014/main" id="{6C4FC6A8-60AF-F6B8-0C5D-04E394E31B08}"/>
+                <a16:creationId xmlns:a16="http://schemas.microsoft.com/office/drawing/2014/main" id="{A209306D-545F-8A8A-6C51-5374F396A74A}"/>
               </a:ext>
             </a:extLst>
           </p:cNvPr>
@@ -2002,7 +2003,7 @@
           <p:cNvPr id="3" name="Text Placeholder 2">
             <a:extLst>
               <a:ext uri="{FF2B5EF4-FFF2-40B4-BE49-F238E27FC236}">
-                <a16:creationId xmlns:a16="http://schemas.microsoft.com/office/drawing/2014/main" id="{D4B5BFF5-CD8B-3478-4180-EC44E530D209}"/>
+                <a16:creationId xmlns:a16="http://schemas.microsoft.com/office/drawing/2014/main" id="{451F2D96-31B2-1269-FA16-1AD36C5178A1}"/>
               </a:ext>
             </a:extLst>
           </p:cNvPr>
@@ -2127,7 +2128,7 @@
           <p:cNvPr id="4" name="Date Placeholder 3">
             <a:extLst>
               <a:ext uri="{FF2B5EF4-FFF2-40B4-BE49-F238E27FC236}">
-                <a16:creationId xmlns:a16="http://schemas.microsoft.com/office/drawing/2014/main" id="{11CB5DD2-DF31-A29B-5546-0A9205755E96}"/>
+                <a16:creationId xmlns:a16="http://schemas.microsoft.com/office/drawing/2014/main" id="{5722FF8C-B5C2-6903-EAB0-0A8098CB4D46}"/>
               </a:ext>
             </a:extLst>
           </p:cNvPr>
@@ -2143,9 +2144,9 @@
           <a:bodyPr/>
           <a:lstStyle/>
           <a:p>
-            <a:fld id="{30B9F9EB-CD4E-4874-BAC5-1330E7B57B4B}" type="datetimeFigureOut">
+            <a:fld id="{2060D58E-3E2B-44B0-91AF-436A738F3104}" type="datetimeFigureOut">
               <a:rPr lang="en-US" smtClean="0"/>
-              <a:t>10/25/2026</a:t>
+              <a:t>10/26/2026</a:t>
             </a:fld>
             <a:endParaRPr lang="en-US"/>
           </a:p>
@@ -2156,7 +2157,7 @@
           <p:cNvPr id="5" name="Footer Placeholder 4">
             <a:extLst>
               <a:ext uri="{FF2B5EF4-FFF2-40B4-BE49-F238E27FC236}">
-                <a16:creationId xmlns:a16="http://schemas.microsoft.com/office/drawing/2014/main" id="{E9F3FAE3-BDF8-EC73-1810-3AAE21C9DD51}"/>
+                <a16:creationId xmlns:a16="http://schemas.microsoft.com/office/drawing/2014/main" id="{7870F5A2-E289-294A-882F-6F8C046DD4B0}"/>
               </a:ext>
             </a:extLst>
           </p:cNvPr>
@@ -2181,7 +2182,7 @@
           <p:cNvPr id="6" name="Slide Number Placeholder 5">
             <a:extLst>
               <a:ext uri="{FF2B5EF4-FFF2-40B4-BE49-F238E27FC236}">
-                <a16:creationId xmlns:a16="http://schemas.microsoft.com/office/drawing/2014/main" id="{E6B296DC-D90B-99BD-F7C9-574C0FF5E9EB}"/>
+                <a16:creationId xmlns:a16="http://schemas.microsoft.com/office/drawing/2014/main" id="{AF2FC9ED-674D-1D61-09BC-793D17FD7F36}"/>
               </a:ext>
             </a:extLst>
           </p:cNvPr>
@@ -2197,7 +2198,7 @@
           <a:bodyPr/>
           <a:lstStyle/>
           <a:p>
-            <a:fld id="{5408F11F-CBAB-4656-9671-9344DA70DEC6}" type="slidenum">
+            <a:fld id="{8C34E1F9-BFB2-47D3-BC8B-67B8C7F4FD80}" type="slidenum">
               <a:rPr lang="en-US" smtClean="0"/>
               <a:t>‹#›</a:t>
             </a:fld>
@@ -2208,7 +2209,7 @@
     </p:spTree>
     <p:extLst>
       <p:ext uri="{BB962C8B-B14F-4D97-AF65-F5344CB8AC3E}">
-        <p14:creationId xmlns:p14="http://schemas.microsoft.com/office/powerpoint/2010/main" val="3712231524"/>
+        <p14:creationId xmlns:p14="http://schemas.microsoft.com/office/powerpoint/2010/main" val="2849194241"/>
       </p:ext>
     </p:extLst>
   </p:cSld>
@@ -2240,7 +2241,7 @@
           <p:cNvPr id="2" name="Title 1">
             <a:extLst>
               <a:ext uri="{FF2B5EF4-FFF2-40B4-BE49-F238E27FC236}">
-                <a16:creationId xmlns:a16="http://schemas.microsoft.com/office/drawing/2014/main" id="{53A3BD84-8A09-BD26-FE38-905520EC39AB}"/>
+                <a16:creationId xmlns:a16="http://schemas.microsoft.com/office/drawing/2014/main" id="{2778BC62-C157-41AE-AD03-C3C2DB843642}"/>
               </a:ext>
             </a:extLst>
           </p:cNvPr>
@@ -2268,7 +2269,7 @@
           <p:cNvPr id="3" name="Content Placeholder 2">
             <a:extLst>
               <a:ext uri="{FF2B5EF4-FFF2-40B4-BE49-F238E27FC236}">
-                <a16:creationId xmlns:a16="http://schemas.microsoft.com/office/drawing/2014/main" id="{460E2E78-4EFF-766A-163D-9714B86A0F68}"/>
+                <a16:creationId xmlns:a16="http://schemas.microsoft.com/office/drawing/2014/main" id="{06B8F9E6-F5B4-70A2-49E4-6C3AF3D2A136}"/>
               </a:ext>
             </a:extLst>
           </p:cNvPr>
@@ -2330,7 +2331,7 @@
           <p:cNvPr id="4" name="Content Placeholder 3">
             <a:extLst>
               <a:ext uri="{FF2B5EF4-FFF2-40B4-BE49-F238E27FC236}">
-                <a16:creationId xmlns:a16="http://schemas.microsoft.com/office/drawing/2014/main" id="{DC82E69C-1CAF-4569-B443-FC7506894368}"/>
+                <a16:creationId xmlns:a16="http://schemas.microsoft.com/office/drawing/2014/main" id="{ABD56045-9E4F-6F79-1E2E-F78424458BE3}"/>
               </a:ext>
             </a:extLst>
           </p:cNvPr>
@@ -2392,7 +2393,7 @@
           <p:cNvPr id="5" name="Date Placeholder 4">
             <a:extLst>
               <a:ext uri="{FF2B5EF4-FFF2-40B4-BE49-F238E27FC236}">
-                <a16:creationId xmlns:a16="http://schemas.microsoft.com/office/drawing/2014/main" id="{784446CF-3A20-1EE3-BF19-345047D16C87}"/>
+                <a16:creationId xmlns:a16="http://schemas.microsoft.com/office/drawing/2014/main" id="{92AC1519-12C0-F34A-DB61-BEAC34412ECC}"/>
               </a:ext>
             </a:extLst>
           </p:cNvPr>
@@ -2408,9 +2409,9 @@
           <a:bodyPr/>
           <a:lstStyle/>
           <a:p>
-            <a:fld id="{30B9F9EB-CD4E-4874-BAC5-1330E7B57B4B}" type="datetimeFigureOut">
+            <a:fld id="{2060D58E-3E2B-44B0-91AF-436A738F3104}" type="datetimeFigureOut">
               <a:rPr lang="en-US" smtClean="0"/>
-              <a:t>10/25/2026</a:t>
+              <a:t>10/26/2026</a:t>
             </a:fld>
             <a:endParaRPr lang="en-US"/>
           </a:p>
@@ -2421,7 +2422,7 @@
           <p:cNvPr id="6" name="Footer Placeholder 5">
             <a:extLst>
               <a:ext uri="{FF2B5EF4-FFF2-40B4-BE49-F238E27FC236}">
-                <a16:creationId xmlns:a16="http://schemas.microsoft.com/office/drawing/2014/main" id="{B163C89C-5967-68B6-608B-8BE550099DA3}"/>
+                <a16:creationId xmlns:a16="http://schemas.microsoft.com/office/drawing/2014/main" id="{3753C643-27B9-4215-C8F3-C090B4C584E2}"/>
               </a:ext>
             </a:extLst>
           </p:cNvPr>
@@ -2446,7 +2447,7 @@
           <p:cNvPr id="7" name="Slide Number Placeholder 6">
             <a:extLst>
               <a:ext uri="{FF2B5EF4-FFF2-40B4-BE49-F238E27FC236}">
-                <a16:creationId xmlns:a16="http://schemas.microsoft.com/office/drawing/2014/main" id="{80A549DC-420B-2D6C-A381-63B7D32A9CC9}"/>
+                <a16:creationId xmlns:a16="http://schemas.microsoft.com/office/drawing/2014/main" id="{C6830948-783A-7E7B-2A8F-9D70CF9EBBE1}"/>
               </a:ext>
             </a:extLst>
           </p:cNvPr>
@@ -2462,7 +2463,7 @@
           <a:bodyPr/>
           <a:lstStyle/>
           <a:p>
-            <a:fld id="{5408F11F-CBAB-4656-9671-9344DA70DEC6}" type="slidenum">
+            <a:fld id="{8C34E1F9-BFB2-47D3-BC8B-67B8C7F4FD80}" type="slidenum">
               <a:rPr lang="en-US" smtClean="0"/>
               <a:t>‹#›</a:t>
             </a:fld>
@@ -2473,7 +2474,7 @@
     </p:spTree>
     <p:extLst>
       <p:ext uri="{BB962C8B-B14F-4D97-AF65-F5344CB8AC3E}">
-        <p14:creationId xmlns:p14="http://schemas.microsoft.com/office/powerpoint/2010/main" val="3948330336"/>
+        <p14:creationId xmlns:p14="http://schemas.microsoft.com/office/powerpoint/2010/main" val="656740737"/>
       </p:ext>
     </p:extLst>
   </p:cSld>
@@ -2505,7 +2506,7 @@
           <p:cNvPr id="2" name="Title 1">
             <a:extLst>
               <a:ext uri="{FF2B5EF4-FFF2-40B4-BE49-F238E27FC236}">
-                <a16:creationId xmlns:a16="http://schemas.microsoft.com/office/drawing/2014/main" id="{3CEBA1C4-9666-8D3D-705C-9E316C1D4FF1}"/>
+                <a16:creationId xmlns:a16="http://schemas.microsoft.com/office/drawing/2014/main" id="{6A33EED7-AF76-44A0-4827-9A876AEF932F}"/>
               </a:ext>
             </a:extLst>
           </p:cNvPr>
@@ -2538,7 +2539,7 @@
           <p:cNvPr id="3" name="Text Placeholder 2">
             <a:extLst>
               <a:ext uri="{FF2B5EF4-FFF2-40B4-BE49-F238E27FC236}">
-                <a16:creationId xmlns:a16="http://schemas.microsoft.com/office/drawing/2014/main" id="{11ED423F-896F-6880-000C-DCB1E56F7E36}"/>
+                <a16:creationId xmlns:a16="http://schemas.microsoft.com/office/drawing/2014/main" id="{E7B2CC51-881C-4626-6947-CC847D531A8C}"/>
               </a:ext>
             </a:extLst>
           </p:cNvPr>
@@ -2609,7 +2610,7 @@
           <p:cNvPr id="4" name="Content Placeholder 3">
             <a:extLst>
               <a:ext uri="{FF2B5EF4-FFF2-40B4-BE49-F238E27FC236}">
-                <a16:creationId xmlns:a16="http://schemas.microsoft.com/office/drawing/2014/main" id="{412CD0F2-2537-B1E6-2C27-48C1D0C26DC6}"/>
+                <a16:creationId xmlns:a16="http://schemas.microsoft.com/office/drawing/2014/main" id="{85D4D4D8-C17C-39C2-EB98-6148B4025A29}"/>
               </a:ext>
             </a:extLst>
           </p:cNvPr>
@@ -2671,7 +2672,7 @@
           <p:cNvPr id="5" name="Text Placeholder 4">
             <a:extLst>
               <a:ext uri="{FF2B5EF4-FFF2-40B4-BE49-F238E27FC236}">
-                <a16:creationId xmlns:a16="http://schemas.microsoft.com/office/drawing/2014/main" id="{EEF3D1C1-6D6C-77DD-C663-0B358C489E63}"/>
+                <a16:creationId xmlns:a16="http://schemas.microsoft.com/office/drawing/2014/main" id="{1C87424B-E362-83A2-5503-E70D40D06641}"/>
               </a:ext>
             </a:extLst>
           </p:cNvPr>
@@ -2742,7 +2743,7 @@
           <p:cNvPr id="6" name="Content Placeholder 5">
             <a:extLst>
               <a:ext uri="{FF2B5EF4-FFF2-40B4-BE49-F238E27FC236}">
-                <a16:creationId xmlns:a16="http://schemas.microsoft.com/office/drawing/2014/main" id="{71928BCD-AAF0-3F9F-FC2D-6FD6E1A68C41}"/>
+                <a16:creationId xmlns:a16="http://schemas.microsoft.com/office/drawing/2014/main" id="{06F312C8-8DE9-6B94-0F0A-8C755C03B58C}"/>
               </a:ext>
             </a:extLst>
           </p:cNvPr>
@@ -2804,7 +2805,7 @@
           <p:cNvPr id="7" name="Date Placeholder 6">
             <a:extLst>
               <a:ext uri="{FF2B5EF4-FFF2-40B4-BE49-F238E27FC236}">
-                <a16:creationId xmlns:a16="http://schemas.microsoft.com/office/drawing/2014/main" id="{EB99F80D-8387-CE83-1910-809FAD4B2293}"/>
+                <a16:creationId xmlns:a16="http://schemas.microsoft.com/office/drawing/2014/main" id="{FEDF529D-9A9D-176B-B528-62B6704926B8}"/>
               </a:ext>
             </a:extLst>
           </p:cNvPr>
@@ -2820,9 +2821,9 @@
           <a:bodyPr/>
           <a:lstStyle/>
           <a:p>
-            <a:fld id="{30B9F9EB-CD4E-4874-BAC5-1330E7B57B4B}" type="datetimeFigureOut">
+            <a:fld id="{2060D58E-3E2B-44B0-91AF-436A738F3104}" type="datetimeFigureOut">
               <a:rPr lang="en-US" smtClean="0"/>
-              <a:t>10/25/2026</a:t>
+              <a:t>10/26/2026</a:t>
             </a:fld>
             <a:endParaRPr lang="en-US"/>
           </a:p>
@@ -2833,7 +2834,7 @@
           <p:cNvPr id="8" name="Footer Placeholder 7">
             <a:extLst>
               <a:ext uri="{FF2B5EF4-FFF2-40B4-BE49-F238E27FC236}">
-                <a16:creationId xmlns:a16="http://schemas.microsoft.com/office/drawing/2014/main" id="{9058C322-A3A3-C099-7E42-C6AD53F96876}"/>
+                <a16:creationId xmlns:a16="http://schemas.microsoft.com/office/drawing/2014/main" id="{BA1A56C0-007A-103B-E848-819CF6F29F44}"/>
               </a:ext>
             </a:extLst>
           </p:cNvPr>
@@ -2858,7 +2859,7 @@
           <p:cNvPr id="9" name="Slide Number Placeholder 8">
             <a:extLst>
               <a:ext uri="{FF2B5EF4-FFF2-40B4-BE49-F238E27FC236}">
-                <a16:creationId xmlns:a16="http://schemas.microsoft.com/office/drawing/2014/main" id="{B94E8506-FCCB-D820-8C3D-ABB8755567EB}"/>
+                <a16:creationId xmlns:a16="http://schemas.microsoft.com/office/drawing/2014/main" id="{08048FA9-9FCA-FF1D-5A82-86E18CF62087}"/>
               </a:ext>
             </a:extLst>
           </p:cNvPr>
@@ -2874,7 +2875,7 @@
           <a:bodyPr/>
           <a:lstStyle/>
           <a:p>
-            <a:fld id="{5408F11F-CBAB-4656-9671-9344DA70DEC6}" type="slidenum">
+            <a:fld id="{8C34E1F9-BFB2-47D3-BC8B-67B8C7F4FD80}" type="slidenum">
               <a:rPr lang="en-US" smtClean="0"/>
               <a:t>‹#›</a:t>
             </a:fld>
@@ -2885,7 +2886,7 @@
     </p:spTree>
     <p:extLst>
       <p:ext uri="{BB962C8B-B14F-4D97-AF65-F5344CB8AC3E}">
-        <p14:creationId xmlns:p14="http://schemas.microsoft.com/office/powerpoint/2010/main" val="770124592"/>
+        <p14:creationId xmlns:p14="http://schemas.microsoft.com/office/powerpoint/2010/main" val="1505680432"/>
       </p:ext>
     </p:extLst>
   </p:cSld>
@@ -2917,7 +2918,7 @@
           <p:cNvPr id="2" name="Title 1">
             <a:extLst>
               <a:ext uri="{FF2B5EF4-FFF2-40B4-BE49-F238E27FC236}">
-                <a16:creationId xmlns:a16="http://schemas.microsoft.com/office/drawing/2014/main" id="{612ECF5E-CB2F-A8A7-BB8E-94D8B80E8CB8}"/>
+                <a16:creationId xmlns:a16="http://schemas.microsoft.com/office/drawing/2014/main" id="{D26777E2-A597-EFB8-5E50-7BF4F00D3C0D}"/>
               </a:ext>
             </a:extLst>
           </p:cNvPr>
@@ -2945,7 +2946,7 @@
           <p:cNvPr id="3" name="Date Placeholder 2">
             <a:extLst>
               <a:ext uri="{FF2B5EF4-FFF2-40B4-BE49-F238E27FC236}">
-                <a16:creationId xmlns:a16="http://schemas.microsoft.com/office/drawing/2014/main" id="{DC093146-A599-3721-4E4B-600D6B1FE447}"/>
+                <a16:creationId xmlns:a16="http://schemas.microsoft.com/office/drawing/2014/main" id="{39015138-10FB-8E57-549C-845AB4A3C1CF}"/>
               </a:ext>
             </a:extLst>
           </p:cNvPr>
@@ -2961,9 +2962,9 @@
           <a:bodyPr/>
           <a:lstStyle/>
           <a:p>
-            <a:fld id="{30B9F9EB-CD4E-4874-BAC5-1330E7B57B4B}" type="datetimeFigureOut">
+            <a:fld id="{2060D58E-3E2B-44B0-91AF-436A738F3104}" type="datetimeFigureOut">
               <a:rPr lang="en-US" smtClean="0"/>
-              <a:t>10/25/2026</a:t>
+              <a:t>10/26/2026</a:t>
             </a:fld>
             <a:endParaRPr lang="en-US"/>
           </a:p>
@@ -2974,7 +2975,7 @@
           <p:cNvPr id="4" name="Footer Placeholder 3">
             <a:extLst>
               <a:ext uri="{FF2B5EF4-FFF2-40B4-BE49-F238E27FC236}">
-                <a16:creationId xmlns:a16="http://schemas.microsoft.com/office/drawing/2014/main" id="{1A474996-E3A9-BC16-8FEA-CF5F574550AB}"/>
+                <a16:creationId xmlns:a16="http://schemas.microsoft.com/office/drawing/2014/main" id="{00731ABC-49E2-C556-739B-12C30EE137C0}"/>
               </a:ext>
             </a:extLst>
           </p:cNvPr>
@@ -2999,7 +3000,7 @@
           <p:cNvPr id="5" name="Slide Number Placeholder 4">
             <a:extLst>
               <a:ext uri="{FF2B5EF4-FFF2-40B4-BE49-F238E27FC236}">
-                <a16:creationId xmlns:a16="http://schemas.microsoft.com/office/drawing/2014/main" id="{CB31D627-32DF-DF4E-4799-4727383DA754}"/>
+                <a16:creationId xmlns:a16="http://schemas.microsoft.com/office/drawing/2014/main" id="{9BE2EF01-C46A-D8A0-CD89-5ABA70DBBC56}"/>
               </a:ext>
             </a:extLst>
           </p:cNvPr>
@@ -3015,7 +3016,7 @@
           <a:bodyPr/>
           <a:lstStyle/>
           <a:p>
-            <a:fld id="{5408F11F-CBAB-4656-9671-9344DA70DEC6}" type="slidenum">
+            <a:fld id="{8C34E1F9-BFB2-47D3-BC8B-67B8C7F4FD80}" type="slidenum">
               <a:rPr lang="en-US" smtClean="0"/>
               <a:t>‹#›</a:t>
             </a:fld>
@@ -3026,7 +3027,7 @@
     </p:spTree>
     <p:extLst>
       <p:ext uri="{BB962C8B-B14F-4D97-AF65-F5344CB8AC3E}">
-        <p14:creationId xmlns:p14="http://schemas.microsoft.com/office/powerpoint/2010/main" val="208563352"/>
+        <p14:creationId xmlns:p14="http://schemas.microsoft.com/office/powerpoint/2010/main" val="1322809753"/>
       </p:ext>
     </p:extLst>
   </p:cSld>
@@ -3058,7 +3059,7 @@
           <p:cNvPr id="2" name="Date Placeholder 1">
             <a:extLst>
               <a:ext uri="{FF2B5EF4-FFF2-40B4-BE49-F238E27FC236}">
-                <a16:creationId xmlns:a16="http://schemas.microsoft.com/office/drawing/2014/main" id="{466380EC-B288-1115-0A7C-64D95E1E795A}"/>
+                <a16:creationId xmlns:a16="http://schemas.microsoft.com/office/drawing/2014/main" id="{B12FDC35-BAEB-7884-6C36-6464C63C1F09}"/>
               </a:ext>
             </a:extLst>
           </p:cNvPr>
@@ -3074,9 +3075,9 @@
           <a:bodyPr/>
           <a:lstStyle/>
           <a:p>
-            <a:fld id="{30B9F9EB-CD4E-4874-BAC5-1330E7B57B4B}" type="datetimeFigureOut">
+            <a:fld id="{2060D58E-3E2B-44B0-91AF-436A738F3104}" type="datetimeFigureOut">
               <a:rPr lang="en-US" smtClean="0"/>
-              <a:t>10/25/2026</a:t>
+              <a:t>10/26/2026</a:t>
             </a:fld>
             <a:endParaRPr lang="en-US"/>
           </a:p>
@@ -3087,7 +3088,7 @@
           <p:cNvPr id="3" name="Footer Placeholder 2">
             <a:extLst>
               <a:ext uri="{FF2B5EF4-FFF2-40B4-BE49-F238E27FC236}">
-                <a16:creationId xmlns:a16="http://schemas.microsoft.com/office/drawing/2014/main" id="{64838470-60F7-140B-9DFC-25A8AE33F72F}"/>
+                <a16:creationId xmlns:a16="http://schemas.microsoft.com/office/drawing/2014/main" id="{A9770A8E-4DE0-BEB6-4A03-8F3C7C44DF3E}"/>
               </a:ext>
             </a:extLst>
           </p:cNvPr>
@@ -3112,7 +3113,7 @@
           <p:cNvPr id="4" name="Slide Number Placeholder 3">
             <a:extLst>
               <a:ext uri="{FF2B5EF4-FFF2-40B4-BE49-F238E27FC236}">
-                <a16:creationId xmlns:a16="http://schemas.microsoft.com/office/drawing/2014/main" id="{32061558-734B-B459-1A4A-A8491CD8FBC8}"/>
+                <a16:creationId xmlns:a16="http://schemas.microsoft.com/office/drawing/2014/main" id="{A14C4D67-E0B2-C33F-07C7-51192C44706F}"/>
               </a:ext>
             </a:extLst>
           </p:cNvPr>
@@ -3128,7 +3129,7 @@
           <a:bodyPr/>
           <a:lstStyle/>
           <a:p>
-            <a:fld id="{5408F11F-CBAB-4656-9671-9344DA70DEC6}" type="slidenum">
+            <a:fld id="{8C34E1F9-BFB2-47D3-BC8B-67B8C7F4FD80}" type="slidenum">
               <a:rPr lang="en-US" smtClean="0"/>
               <a:t>‹#›</a:t>
             </a:fld>
@@ -3139,7 +3140,7 @@
     </p:spTree>
     <p:extLst>
       <p:ext uri="{BB962C8B-B14F-4D97-AF65-F5344CB8AC3E}">
-        <p14:creationId xmlns:p14="http://schemas.microsoft.com/office/powerpoint/2010/main" val="1497836278"/>
+        <p14:creationId xmlns:p14="http://schemas.microsoft.com/office/powerpoint/2010/main" val="4011228854"/>
       </p:ext>
     </p:extLst>
   </p:cSld>
@@ -3171,7 +3172,7 @@
           <p:cNvPr id="2" name="Title 1">
             <a:extLst>
               <a:ext uri="{FF2B5EF4-FFF2-40B4-BE49-F238E27FC236}">
-                <a16:creationId xmlns:a16="http://schemas.microsoft.com/office/drawing/2014/main" id="{C38D76FC-986B-BE90-858C-4D5E9D2CDB54}"/>
+                <a16:creationId xmlns:a16="http://schemas.microsoft.com/office/drawing/2014/main" id="{15189157-CC5B-E1B2-2DFF-05F09E6F57E1}"/>
               </a:ext>
             </a:extLst>
           </p:cNvPr>
@@ -3208,7 +3209,7 @@
           <p:cNvPr id="3" name="Content Placeholder 2">
             <a:extLst>
               <a:ext uri="{FF2B5EF4-FFF2-40B4-BE49-F238E27FC236}">
-                <a16:creationId xmlns:a16="http://schemas.microsoft.com/office/drawing/2014/main" id="{98205B58-9A92-BDD6-D6A9-DAE2727BFB8E}"/>
+                <a16:creationId xmlns:a16="http://schemas.microsoft.com/office/drawing/2014/main" id="{C0B13131-52B5-11F9-C4A5-7A8899354D97}"/>
               </a:ext>
             </a:extLst>
           </p:cNvPr>
@@ -3298,7 +3299,7 @@
           <p:cNvPr id="4" name="Text Placeholder 3">
             <a:extLst>
               <a:ext uri="{FF2B5EF4-FFF2-40B4-BE49-F238E27FC236}">
-                <a16:creationId xmlns:a16="http://schemas.microsoft.com/office/drawing/2014/main" id="{A6862A5C-AC88-D60A-9544-4A67750114AA}"/>
+                <a16:creationId xmlns:a16="http://schemas.microsoft.com/office/drawing/2014/main" id="{ECB4ECDE-3E62-C40F-1862-C3E975DD5698}"/>
               </a:ext>
             </a:extLst>
           </p:cNvPr>
@@ -3369,7 +3370,7 @@
           <p:cNvPr id="5" name="Date Placeholder 4">
             <a:extLst>
               <a:ext uri="{FF2B5EF4-FFF2-40B4-BE49-F238E27FC236}">
-                <a16:creationId xmlns:a16="http://schemas.microsoft.com/office/drawing/2014/main" id="{B216735E-6CFA-9230-FF7D-AD4FB791D372}"/>
+                <a16:creationId xmlns:a16="http://schemas.microsoft.com/office/drawing/2014/main" id="{C3CD46DA-58C1-7C58-6F96-F57857A1DEF5}"/>
               </a:ext>
             </a:extLst>
           </p:cNvPr>
@@ -3385,9 +3386,9 @@
           <a:bodyPr/>
           <a:lstStyle/>
           <a:p>
-            <a:fld id="{30B9F9EB-CD4E-4874-BAC5-1330E7B57B4B}" type="datetimeFigureOut">
+            <a:fld id="{2060D58E-3E2B-44B0-91AF-436A738F3104}" type="datetimeFigureOut">
               <a:rPr lang="en-US" smtClean="0"/>
-              <a:t>10/25/2026</a:t>
+              <a:t>10/26/2026</a:t>
             </a:fld>
             <a:endParaRPr lang="en-US"/>
           </a:p>
@@ -3398,7 +3399,7 @@
           <p:cNvPr id="6" name="Footer Placeholder 5">
             <a:extLst>
               <a:ext uri="{FF2B5EF4-FFF2-40B4-BE49-F238E27FC236}">
-                <a16:creationId xmlns:a16="http://schemas.microsoft.com/office/drawing/2014/main" id="{7F0F6C9F-2DD0-E842-94CA-6F21667FA24F}"/>
+                <a16:creationId xmlns:a16="http://schemas.microsoft.com/office/drawing/2014/main" id="{932E9795-7904-B13A-B42B-982A5CB37ADF}"/>
               </a:ext>
             </a:extLst>
           </p:cNvPr>
@@ -3423,7 +3424,7 @@
           <p:cNvPr id="7" name="Slide Number Placeholder 6">
             <a:extLst>
               <a:ext uri="{FF2B5EF4-FFF2-40B4-BE49-F238E27FC236}">
-                <a16:creationId xmlns:a16="http://schemas.microsoft.com/office/drawing/2014/main" id="{3FF34249-FEC9-4651-9A78-32DB06A7F7D6}"/>
+                <a16:creationId xmlns:a16="http://schemas.microsoft.com/office/drawing/2014/main" id="{9C8A386E-BDE8-5EB0-F19F-359E2DA9C991}"/>
               </a:ext>
             </a:extLst>
           </p:cNvPr>
@@ -3439,7 +3440,7 @@
           <a:bodyPr/>
           <a:lstStyle/>
           <a:p>
-            <a:fld id="{5408F11F-CBAB-4656-9671-9344DA70DEC6}" type="slidenum">
+            <a:fld id="{8C34E1F9-BFB2-47D3-BC8B-67B8C7F4FD80}" type="slidenum">
               <a:rPr lang="en-US" smtClean="0"/>
               <a:t>‹#›</a:t>
             </a:fld>
@@ -3450,7 +3451,7 @@
     </p:spTree>
     <p:extLst>
       <p:ext uri="{BB962C8B-B14F-4D97-AF65-F5344CB8AC3E}">
-        <p14:creationId xmlns:p14="http://schemas.microsoft.com/office/powerpoint/2010/main" val="1816748732"/>
+        <p14:creationId xmlns:p14="http://schemas.microsoft.com/office/powerpoint/2010/main" val="3859511263"/>
       </p:ext>
     </p:extLst>
   </p:cSld>
@@ -3482,7 +3483,7 @@
           <p:cNvPr id="2" name="Title 1">
             <a:extLst>
               <a:ext uri="{FF2B5EF4-FFF2-40B4-BE49-F238E27FC236}">
-                <a16:creationId xmlns:a16="http://schemas.microsoft.com/office/drawing/2014/main" id="{9E2406C0-C113-21FA-608C-4AAC599720AD}"/>
+                <a16:creationId xmlns:a16="http://schemas.microsoft.com/office/drawing/2014/main" id="{85CBAC42-6105-BCE5-243A-FA91F058E074}"/>
               </a:ext>
             </a:extLst>
           </p:cNvPr>
@@ -3519,7 +3520,7 @@
           <p:cNvPr id="3" name="Picture Placeholder 2">
             <a:extLst>
               <a:ext uri="{FF2B5EF4-FFF2-40B4-BE49-F238E27FC236}">
-                <a16:creationId xmlns:a16="http://schemas.microsoft.com/office/drawing/2014/main" id="{2BE7F538-B437-C625-79CB-7AF6BF8FB498}"/>
+                <a16:creationId xmlns:a16="http://schemas.microsoft.com/office/drawing/2014/main" id="{825B287A-173B-20DF-2CD7-7957E8448E05}"/>
               </a:ext>
             </a:extLst>
           </p:cNvPr>
@@ -3586,7 +3587,7 @@
           <p:cNvPr id="4" name="Text Placeholder 3">
             <a:extLst>
               <a:ext uri="{FF2B5EF4-FFF2-40B4-BE49-F238E27FC236}">
-                <a16:creationId xmlns:a16="http://schemas.microsoft.com/office/drawing/2014/main" id="{136E38E2-CA15-C213-D44B-CCAE75DD212D}"/>
+                <a16:creationId xmlns:a16="http://schemas.microsoft.com/office/drawing/2014/main" id="{2AD026BF-C97B-D8FC-012C-EE8277199436}"/>
               </a:ext>
             </a:extLst>
           </p:cNvPr>
@@ -3657,7 +3658,7 @@
           <p:cNvPr id="5" name="Date Placeholder 4">
             <a:extLst>
               <a:ext uri="{FF2B5EF4-FFF2-40B4-BE49-F238E27FC236}">
-                <a16:creationId xmlns:a16="http://schemas.microsoft.com/office/drawing/2014/main" id="{BBE303A9-6847-3A25-6E6E-56057776FA21}"/>
+                <a16:creationId xmlns:a16="http://schemas.microsoft.com/office/drawing/2014/main" id="{40D5E518-C724-37DA-2F88-F1AC9EBED64F}"/>
               </a:ext>
             </a:extLst>
           </p:cNvPr>
@@ -3673,9 +3674,9 @@
           <a:bodyPr/>
           <a:lstStyle/>
           <a:p>
-            <a:fld id="{30B9F9EB-CD4E-4874-BAC5-1330E7B57B4B}" type="datetimeFigureOut">
+            <a:fld id="{2060D58E-3E2B-44B0-91AF-436A738F3104}" type="datetimeFigureOut">
               <a:rPr lang="en-US" smtClean="0"/>
-              <a:t>10/25/2026</a:t>
+              <a:t>10/26/2026</a:t>
             </a:fld>
             <a:endParaRPr lang="en-US"/>
           </a:p>
@@ -3686,7 +3687,7 @@
           <p:cNvPr id="6" name="Footer Placeholder 5">
             <a:extLst>
               <a:ext uri="{FF2B5EF4-FFF2-40B4-BE49-F238E27FC236}">
-                <a16:creationId xmlns:a16="http://schemas.microsoft.com/office/drawing/2014/main" id="{6F6BB3A7-C71D-4001-9F1E-DCED765A3A0A}"/>
+                <a16:creationId xmlns:a16="http://schemas.microsoft.com/office/drawing/2014/main" id="{9719003D-2674-4B00-8840-43413B44C11F}"/>
               </a:ext>
             </a:extLst>
           </p:cNvPr>
@@ -3711,7 +3712,7 @@
           <p:cNvPr id="7" name="Slide Number Placeholder 6">
             <a:extLst>
               <a:ext uri="{FF2B5EF4-FFF2-40B4-BE49-F238E27FC236}">
-                <a16:creationId xmlns:a16="http://schemas.microsoft.com/office/drawing/2014/main" id="{775BF967-3833-0EEE-BE52-2A4C29C59551}"/>
+                <a16:creationId xmlns:a16="http://schemas.microsoft.com/office/drawing/2014/main" id="{D4428446-64E1-4FC6-8620-D91CEAFD2A32}"/>
               </a:ext>
             </a:extLst>
           </p:cNvPr>
@@ -3727,7 +3728,7 @@
           <a:bodyPr/>
           <a:lstStyle/>
           <a:p>
-            <a:fld id="{5408F11F-CBAB-4656-9671-9344DA70DEC6}" type="slidenum">
+            <a:fld id="{8C34E1F9-BFB2-47D3-BC8B-67B8C7F4FD80}" type="slidenum">
               <a:rPr lang="en-US" smtClean="0"/>
               <a:t>‹#›</a:t>
             </a:fld>
@@ -3738,7 +3739,7 @@
     </p:spTree>
     <p:extLst>
       <p:ext uri="{BB962C8B-B14F-4D97-AF65-F5344CB8AC3E}">
-        <p14:creationId xmlns:p14="http://schemas.microsoft.com/office/powerpoint/2010/main" val="2163673378"/>
+        <p14:creationId xmlns:p14="http://schemas.microsoft.com/office/powerpoint/2010/main" val="259044894"/>
       </p:ext>
     </p:extLst>
   </p:cSld>
@@ -3775,7 +3776,7 @@
           <p:cNvPr id="2" name="Title Placeholder 1">
             <a:extLst>
               <a:ext uri="{FF2B5EF4-FFF2-40B4-BE49-F238E27FC236}">
-                <a16:creationId xmlns:a16="http://schemas.microsoft.com/office/drawing/2014/main" id="{8C46B43C-2594-C353-E788-D8C5385C3CCA}"/>
+                <a16:creationId xmlns:a16="http://schemas.microsoft.com/office/drawing/2014/main" id="{3371DEFD-7B0A-BC36-3E40-E3BF5E87F381}"/>
               </a:ext>
             </a:extLst>
           </p:cNvPr>
@@ -3813,7 +3814,7 @@
           <p:cNvPr id="3" name="Text Placeholder 2">
             <a:extLst>
               <a:ext uri="{FF2B5EF4-FFF2-40B4-BE49-F238E27FC236}">
-                <a16:creationId xmlns:a16="http://schemas.microsoft.com/office/drawing/2014/main" id="{395578DD-9CE3-8697-7C89-05191DDB942B}"/>
+                <a16:creationId xmlns:a16="http://schemas.microsoft.com/office/drawing/2014/main" id="{CA998330-BF8B-6428-E901-48C51A3DF36C}"/>
               </a:ext>
             </a:extLst>
           </p:cNvPr>
@@ -3880,7 +3881,7 @@
           <p:cNvPr id="4" name="Date Placeholder 3">
             <a:extLst>
               <a:ext uri="{FF2B5EF4-FFF2-40B4-BE49-F238E27FC236}">
-                <a16:creationId xmlns:a16="http://schemas.microsoft.com/office/drawing/2014/main" id="{EA57CA2C-5A5D-8CAE-D208-DF463768B5A8}"/>
+                <a16:creationId xmlns:a16="http://schemas.microsoft.com/office/drawing/2014/main" id="{54940988-462B-F676-4EFB-A8E610BE2042}"/>
               </a:ext>
             </a:extLst>
           </p:cNvPr>
@@ -3914,9 +3915,9 @@
             </a:lvl1pPr>
           </a:lstStyle>
           <a:p>
-            <a:fld id="{30B9F9EB-CD4E-4874-BAC5-1330E7B57B4B}" type="datetimeFigureOut">
+            <a:fld id="{2060D58E-3E2B-44B0-91AF-436A738F3104}" type="datetimeFigureOut">
               <a:rPr lang="en-US" smtClean="0"/>
-              <a:t>10/25/2026</a:t>
+              <a:t>10/26/2026</a:t>
             </a:fld>
             <a:endParaRPr lang="en-US"/>
           </a:p>
@@ -3927,7 +3928,7 @@
           <p:cNvPr id="5" name="Footer Placeholder 4">
             <a:extLst>
               <a:ext uri="{FF2B5EF4-FFF2-40B4-BE49-F238E27FC236}">
-                <a16:creationId xmlns:a16="http://schemas.microsoft.com/office/drawing/2014/main" id="{A2797074-0009-EECC-6874-4227705F7BB7}"/>
+                <a16:creationId xmlns:a16="http://schemas.microsoft.com/office/drawing/2014/main" id="{234D3A32-6709-AC2C-63C6-1542138DDBDE}"/>
               </a:ext>
             </a:extLst>
           </p:cNvPr>
@@ -3970,7 +3971,7 @@
           <p:cNvPr id="6" name="Slide Number Placeholder 5">
             <a:extLst>
               <a:ext uri="{FF2B5EF4-FFF2-40B4-BE49-F238E27FC236}">
-                <a16:creationId xmlns:a16="http://schemas.microsoft.com/office/drawing/2014/main" id="{B743F7A5-5ED4-816D-1F3A-E1A45431924B}"/>
+                <a16:creationId xmlns:a16="http://schemas.microsoft.com/office/drawing/2014/main" id="{7607A494-D644-EA11-65AB-A6960379549B}"/>
               </a:ext>
             </a:extLst>
           </p:cNvPr>
@@ -4004,7 +4005,7 @@
             </a:lvl1pPr>
           </a:lstStyle>
           <a:p>
-            <a:fld id="{5408F11F-CBAB-4656-9671-9344DA70DEC6}" type="slidenum">
+            <a:fld id="{8C34E1F9-BFB2-47D3-BC8B-67B8C7F4FD80}" type="slidenum">
               <a:rPr lang="en-US" smtClean="0"/>
               <a:t>‹#›</a:t>
             </a:fld>
@@ -4015,7 +4016,7 @@
     </p:spTree>
     <p:extLst>
       <p:ext uri="{BB962C8B-B14F-4D97-AF65-F5344CB8AC3E}">
-        <p14:creationId xmlns:p14="http://schemas.microsoft.com/office/powerpoint/2010/main" val="613582778"/>
+        <p14:creationId xmlns:p14="http://schemas.microsoft.com/office/powerpoint/2010/main" val="251300643"/>
       </p:ext>
     </p:extLst>
   </p:cSld>
@@ -4346,7 +4347,7 @@
           <p:cNvPr id="2" name="Rectangle: Rounded Corners 1">
             <a:extLst>
               <a:ext uri="{FF2B5EF4-FFF2-40B4-BE49-F238E27FC236}">
-                <a16:creationId xmlns:a16="http://schemas.microsoft.com/office/drawing/2014/main" id="{39EEBA06-AC7B-82A0-2EA6-D8469BF73CBC}"/>
+                <a16:creationId xmlns:a16="http://schemas.microsoft.com/office/drawing/2014/main" id="{C626C591-B2EA-5E5A-49B1-6B7BD4F3A4C8}"/>
               </a:ext>
             </a:extLst>
           </p:cNvPr>
@@ -4400,7 +4401,7 @@
           <p:cNvPr id="3" name="TextBox 2">
             <a:extLst>
               <a:ext uri="{FF2B5EF4-FFF2-40B4-BE49-F238E27FC236}">
-                <a16:creationId xmlns:a16="http://schemas.microsoft.com/office/drawing/2014/main" id="{CCB0075C-87A7-7EEE-C7EA-91A30F096B9B}"/>
+                <a16:creationId xmlns:a16="http://schemas.microsoft.com/office/drawing/2014/main" id="{D768B68B-4483-6845-F257-E838D198D988}"/>
               </a:ext>
             </a:extLst>
           </p:cNvPr>
@@ -4441,7 +4442,7 @@
           <p:cNvPr id="4" name="TextBox 3">
             <a:extLst>
               <a:ext uri="{FF2B5EF4-FFF2-40B4-BE49-F238E27FC236}">
-                <a16:creationId xmlns:a16="http://schemas.microsoft.com/office/drawing/2014/main" id="{261A2C61-8AB3-9CB4-6C9D-FE4D5AF5EE4D}"/>
+                <a16:creationId xmlns:a16="http://schemas.microsoft.com/office/drawing/2014/main" id="{E1080A0C-B265-6FD4-118A-AB4F8C14BABA}"/>
               </a:ext>
             </a:extLst>
           </p:cNvPr>
@@ -4481,7 +4482,7 @@
           <p:cNvPr id="5" name="TextBox 4">
             <a:extLst>
               <a:ext uri="{FF2B5EF4-FFF2-40B4-BE49-F238E27FC236}">
-                <a16:creationId xmlns:a16="http://schemas.microsoft.com/office/drawing/2014/main" id="{089F9195-6AF0-5771-CF37-45770A60E3AB}"/>
+                <a16:creationId xmlns:a16="http://schemas.microsoft.com/office/drawing/2014/main" id="{4BF4830C-A9F7-1F50-4D0B-F8CF05837770}"/>
               </a:ext>
             </a:extLst>
           </p:cNvPr>
@@ -4521,7 +4522,7 @@
           <p:cNvPr id="6" name="TextBox 5">
             <a:extLst>
               <a:ext uri="{FF2B5EF4-FFF2-40B4-BE49-F238E27FC236}">
-                <a16:creationId xmlns:a16="http://schemas.microsoft.com/office/drawing/2014/main" id="{D5E1A092-EC8C-77B8-2186-27D6E12B3FBB}"/>
+                <a16:creationId xmlns:a16="http://schemas.microsoft.com/office/drawing/2014/main" id="{8F606592-97BD-0379-9E31-1B34BA2C6065}"/>
               </a:ext>
             </a:extLst>
           </p:cNvPr>
@@ -4561,7 +4562,7 @@
           <p:cNvPr id="7" name="Rectangle: Rounded Corners 6">
             <a:extLst>
               <a:ext uri="{FF2B5EF4-FFF2-40B4-BE49-F238E27FC236}">
-                <a16:creationId xmlns:a16="http://schemas.microsoft.com/office/drawing/2014/main" id="{E8F5B4F1-8969-EDC9-2D67-B4DA11488FF4}"/>
+                <a16:creationId xmlns:a16="http://schemas.microsoft.com/office/drawing/2014/main" id="{DE70FE5E-BE16-AD9D-FAB5-B11857ED9F25}"/>
               </a:ext>
             </a:extLst>
           </p:cNvPr>
@@ -4615,7 +4616,7 @@
           <p:cNvPr id="8" name="TextBox 7">
             <a:extLst>
               <a:ext uri="{FF2B5EF4-FFF2-40B4-BE49-F238E27FC236}">
-                <a16:creationId xmlns:a16="http://schemas.microsoft.com/office/drawing/2014/main" id="{53CB7A16-140D-D7E2-666B-8FF4F991F60D}"/>
+                <a16:creationId xmlns:a16="http://schemas.microsoft.com/office/drawing/2014/main" id="{AA25FE87-4428-1EA3-C7BD-956C4A298EDA}"/>
               </a:ext>
             </a:extLst>
           </p:cNvPr>
@@ -4656,7 +4657,7 @@
           <p:cNvPr id="9" name="Rectangle: Rounded Corners 8">
             <a:extLst>
               <a:ext uri="{FF2B5EF4-FFF2-40B4-BE49-F238E27FC236}">
-                <a16:creationId xmlns:a16="http://schemas.microsoft.com/office/drawing/2014/main" id="{E1009525-3CEE-8300-8E96-7EBFEB082611}"/>
+                <a16:creationId xmlns:a16="http://schemas.microsoft.com/office/drawing/2014/main" id="{82EBEE78-9C77-67F5-B27B-060078724586}"/>
               </a:ext>
             </a:extLst>
           </p:cNvPr>
@@ -4710,7 +4711,7 @@
           <p:cNvPr id="10" name="TextBox 9">
             <a:extLst>
               <a:ext uri="{FF2B5EF4-FFF2-40B4-BE49-F238E27FC236}">
-                <a16:creationId xmlns:a16="http://schemas.microsoft.com/office/drawing/2014/main" id="{BFE972C0-3C0D-C207-B24F-241F44C40AD0}"/>
+                <a16:creationId xmlns:a16="http://schemas.microsoft.com/office/drawing/2014/main" id="{DED3DEBB-BBFF-DBC4-DC52-9EA5EC809730}"/>
               </a:ext>
             </a:extLst>
           </p:cNvPr>
@@ -4751,7 +4752,7 @@
           <p:cNvPr id="11" name="Rectangle: Rounded Corners 10">
             <a:extLst>
               <a:ext uri="{FF2B5EF4-FFF2-40B4-BE49-F238E27FC236}">
-                <a16:creationId xmlns:a16="http://schemas.microsoft.com/office/drawing/2014/main" id="{AC236A9D-EBA9-F304-A0EC-03E0F47F3AA8}"/>
+                <a16:creationId xmlns:a16="http://schemas.microsoft.com/office/drawing/2014/main" id="{3C8CAC2B-1C07-C3CC-535D-5764EBC4443F}"/>
               </a:ext>
             </a:extLst>
           </p:cNvPr>
@@ -4805,7 +4806,7 @@
           <p:cNvPr id="12" name="TextBox 11">
             <a:extLst>
               <a:ext uri="{FF2B5EF4-FFF2-40B4-BE49-F238E27FC236}">
-                <a16:creationId xmlns:a16="http://schemas.microsoft.com/office/drawing/2014/main" id="{7163D163-5260-BB57-4B9E-3ABC31BC0C46}"/>
+                <a16:creationId xmlns:a16="http://schemas.microsoft.com/office/drawing/2014/main" id="{BA8A74D1-A4A1-388E-F54C-5B012BA0AA06}"/>
               </a:ext>
             </a:extLst>
           </p:cNvPr>
@@ -4846,7 +4847,7 @@
           <p:cNvPr id="13" name="TextBox 12">
             <a:extLst>
               <a:ext uri="{FF2B5EF4-FFF2-40B4-BE49-F238E27FC236}">
-                <a16:creationId xmlns:a16="http://schemas.microsoft.com/office/drawing/2014/main" id="{3AEEC2CF-F115-CFCB-B7D2-1B5CAFF9D883}"/>
+                <a16:creationId xmlns:a16="http://schemas.microsoft.com/office/drawing/2014/main" id="{52836FBD-F278-BCEC-8628-615261D350BF}"/>
               </a:ext>
             </a:extLst>
           </p:cNvPr>
@@ -4886,7 +4887,7 @@
           <p:cNvPr id="14" name="TextBox 13">
             <a:extLst>
               <a:ext uri="{FF2B5EF4-FFF2-40B4-BE49-F238E27FC236}">
-                <a16:creationId xmlns:a16="http://schemas.microsoft.com/office/drawing/2014/main" id="{CBA0A9D6-1810-3E4B-06E7-3D08567E18D5}"/>
+                <a16:creationId xmlns:a16="http://schemas.microsoft.com/office/drawing/2014/main" id="{7EBF5677-F222-C973-563B-72E9B8159829}"/>
               </a:ext>
             </a:extLst>
           </p:cNvPr>
@@ -4925,7 +4926,7 @@
     </p:spTree>
     <p:extLst>
       <p:ext uri="{BB962C8B-B14F-4D97-AF65-F5344CB8AC3E}">
-        <p14:creationId xmlns:p14="http://schemas.microsoft.com/office/powerpoint/2010/main" val="1261295141"/>
+        <p14:creationId xmlns:p14="http://schemas.microsoft.com/office/powerpoint/2010/main" val="2904742909"/>
       </p:ext>
     </p:extLst>
   </p:cSld>
@@ -4965,7 +4966,7 @@
           <p:cNvPr id="2" name="TextBox 1">
             <a:extLst>
               <a:ext uri="{FF2B5EF4-FFF2-40B4-BE49-F238E27FC236}">
-                <a16:creationId xmlns:a16="http://schemas.microsoft.com/office/drawing/2014/main" id="{9197DF49-24B7-5C39-DA4D-FAC1FB875337}"/>
+                <a16:creationId xmlns:a16="http://schemas.microsoft.com/office/drawing/2014/main" id="{79FA6110-5C39-0032-4958-C23319E2F9CA}"/>
               </a:ext>
             </a:extLst>
           </p:cNvPr>
@@ -5005,7 +5006,7 @@
           <p:cNvPr id="3" name="TextBox 2">
             <a:extLst>
               <a:ext uri="{FF2B5EF4-FFF2-40B4-BE49-F238E27FC236}">
-                <a16:creationId xmlns:a16="http://schemas.microsoft.com/office/drawing/2014/main" id="{EAF10953-8F1B-7563-FE13-B38A444F7BED}"/>
+                <a16:creationId xmlns:a16="http://schemas.microsoft.com/office/drawing/2014/main" id="{2F9282B3-3093-0BEA-4741-3ADF6B1BFB65}"/>
               </a:ext>
             </a:extLst>
           </p:cNvPr>
@@ -5045,7 +5046,7 @@
           <p:cNvPr id="4" name="Straight Connector 3">
             <a:extLst>
               <a:ext uri="{FF2B5EF4-FFF2-40B4-BE49-F238E27FC236}">
-                <a16:creationId xmlns:a16="http://schemas.microsoft.com/office/drawing/2014/main" id="{C6B0FEEF-C7B1-3446-78CC-06B7CF9F565F}"/>
+                <a16:creationId xmlns:a16="http://schemas.microsoft.com/office/drawing/2014/main" id="{C8939C0B-E3BD-5E7F-FB85-6C0D062551FA}"/>
               </a:ext>
             </a:extLst>
           </p:cNvPr>
@@ -5086,7 +5087,7 @@
           <p:cNvPr id="5" name="TextBox 4">
             <a:extLst>
               <a:ext uri="{FF2B5EF4-FFF2-40B4-BE49-F238E27FC236}">
-                <a16:creationId xmlns:a16="http://schemas.microsoft.com/office/drawing/2014/main" id="{841C8D25-1FA6-1818-1EE0-7E2F5C650CC8}"/>
+                <a16:creationId xmlns:a16="http://schemas.microsoft.com/office/drawing/2014/main" id="{BA28393A-53BB-3912-8EB8-6444A2D1CC95}"/>
               </a:ext>
             </a:extLst>
           </p:cNvPr>
@@ -5126,7 +5127,7 @@
           <p:cNvPr id="6" name="TextBox 5">
             <a:extLst>
               <a:ext uri="{FF2B5EF4-FFF2-40B4-BE49-F238E27FC236}">
-                <a16:creationId xmlns:a16="http://schemas.microsoft.com/office/drawing/2014/main" id="{CA37D863-D7C0-2CEF-6DC7-BF79F7426525}"/>
+                <a16:creationId xmlns:a16="http://schemas.microsoft.com/office/drawing/2014/main" id="{E8703B73-5A40-A4D8-0866-AA9FF88820D7}"/>
               </a:ext>
             </a:extLst>
           </p:cNvPr>
@@ -5167,7 +5168,7 @@
           <p:cNvPr id="7" name="Rectangle: Rounded Corners 6">
             <a:extLst>
               <a:ext uri="{FF2B5EF4-FFF2-40B4-BE49-F238E27FC236}">
-                <a16:creationId xmlns:a16="http://schemas.microsoft.com/office/drawing/2014/main" id="{851FC484-EBB8-30A0-42E2-3BD9842EFCFA}"/>
+                <a16:creationId xmlns:a16="http://schemas.microsoft.com/office/drawing/2014/main" id="{0CB9E965-69F5-378A-EDDA-48D410A80749}"/>
               </a:ext>
             </a:extLst>
           </p:cNvPr>
@@ -5221,7 +5222,7 @@
           <p:cNvPr id="8" name="Oval 7">
             <a:extLst>
               <a:ext uri="{FF2B5EF4-FFF2-40B4-BE49-F238E27FC236}">
-                <a16:creationId xmlns:a16="http://schemas.microsoft.com/office/drawing/2014/main" id="{AAEC2D86-2F2E-1EB5-E782-9AF25540C39B}"/>
+                <a16:creationId xmlns:a16="http://schemas.microsoft.com/office/drawing/2014/main" id="{EA04F7C3-ADB5-C945-8F8B-0F70C5D63225}"/>
               </a:ext>
             </a:extLst>
           </p:cNvPr>
@@ -5289,7 +5290,7 @@
           <p:cNvPr id="9" name="TextBox 8">
             <a:extLst>
               <a:ext uri="{FF2B5EF4-FFF2-40B4-BE49-F238E27FC236}">
-                <a16:creationId xmlns:a16="http://schemas.microsoft.com/office/drawing/2014/main" id="{2318CE69-2020-33A7-618F-12C6E1CF0906}"/>
+                <a16:creationId xmlns:a16="http://schemas.microsoft.com/office/drawing/2014/main" id="{84C81A9F-91FC-110A-9CBA-6816EFD09601}"/>
               </a:ext>
             </a:extLst>
           </p:cNvPr>
@@ -5330,7 +5331,7 @@
           <p:cNvPr id="10" name="TextBox 9">
             <a:extLst>
               <a:ext uri="{FF2B5EF4-FFF2-40B4-BE49-F238E27FC236}">
-                <a16:creationId xmlns:a16="http://schemas.microsoft.com/office/drawing/2014/main" id="{06DE4D48-07A6-DEB5-DCA1-40089424B03D}"/>
+                <a16:creationId xmlns:a16="http://schemas.microsoft.com/office/drawing/2014/main" id="{F8466152-986F-640C-751F-73087C8A18C6}"/>
               </a:ext>
             </a:extLst>
           </p:cNvPr>
@@ -5371,7 +5372,7 @@
           <p:cNvPr id="11" name="TextBox 10">
             <a:extLst>
               <a:ext uri="{FF2B5EF4-FFF2-40B4-BE49-F238E27FC236}">
-                <a16:creationId xmlns:a16="http://schemas.microsoft.com/office/drawing/2014/main" id="{B4F1688D-63ED-3946-8749-D6E53FF5FE86}"/>
+                <a16:creationId xmlns:a16="http://schemas.microsoft.com/office/drawing/2014/main" id="{06EAE32D-A79C-8B7C-9A02-E6427EB7112C}"/>
               </a:ext>
             </a:extLst>
           </p:cNvPr>
@@ -5414,7 +5415,7 @@
           <p:cNvPr id="12" name="Rectangle: Rounded Corners 11">
             <a:extLst>
               <a:ext uri="{FF2B5EF4-FFF2-40B4-BE49-F238E27FC236}">
-                <a16:creationId xmlns:a16="http://schemas.microsoft.com/office/drawing/2014/main" id="{743E782E-8FF1-F515-0860-885CF1F4D164}"/>
+                <a16:creationId xmlns:a16="http://schemas.microsoft.com/office/drawing/2014/main" id="{79D76777-C965-E77D-AC5D-7CA4F4622A25}"/>
               </a:ext>
             </a:extLst>
           </p:cNvPr>
@@ -5468,7 +5469,7 @@
           <p:cNvPr id="13" name="Oval 12">
             <a:extLst>
               <a:ext uri="{FF2B5EF4-FFF2-40B4-BE49-F238E27FC236}">
-                <a16:creationId xmlns:a16="http://schemas.microsoft.com/office/drawing/2014/main" id="{68DBC622-8F41-3DC0-7AA6-90409F122C7B}"/>
+                <a16:creationId xmlns:a16="http://schemas.microsoft.com/office/drawing/2014/main" id="{DE7126FB-1C42-4976-6290-0019AEB7A368}"/>
               </a:ext>
             </a:extLst>
           </p:cNvPr>
@@ -5536,7 +5537,7 @@
           <p:cNvPr id="14" name="TextBox 13">
             <a:extLst>
               <a:ext uri="{FF2B5EF4-FFF2-40B4-BE49-F238E27FC236}">
-                <a16:creationId xmlns:a16="http://schemas.microsoft.com/office/drawing/2014/main" id="{A05BB636-1471-C44C-24AD-50A7EBB450C6}"/>
+                <a16:creationId xmlns:a16="http://schemas.microsoft.com/office/drawing/2014/main" id="{B2FA6FD5-D9F9-C703-E9BD-F7AC1A1F7649}"/>
               </a:ext>
             </a:extLst>
           </p:cNvPr>
@@ -5577,7 +5578,7 @@
           <p:cNvPr id="15" name="TextBox 14">
             <a:extLst>
               <a:ext uri="{FF2B5EF4-FFF2-40B4-BE49-F238E27FC236}">
-                <a16:creationId xmlns:a16="http://schemas.microsoft.com/office/drawing/2014/main" id="{AE92FBB7-892B-DCD6-CD10-580AC9EF2486}"/>
+                <a16:creationId xmlns:a16="http://schemas.microsoft.com/office/drawing/2014/main" id="{9481BC28-9D2D-FC43-4D80-EAB96A842B28}"/>
               </a:ext>
             </a:extLst>
           </p:cNvPr>
@@ -5618,7 +5619,7 @@
           <p:cNvPr id="16" name="TextBox 15">
             <a:extLst>
               <a:ext uri="{FF2B5EF4-FFF2-40B4-BE49-F238E27FC236}">
-                <a16:creationId xmlns:a16="http://schemas.microsoft.com/office/drawing/2014/main" id="{3B95EEE1-821B-8DA1-3B18-97048AE41566}"/>
+                <a16:creationId xmlns:a16="http://schemas.microsoft.com/office/drawing/2014/main" id="{5A3E750A-49BC-282E-54FE-25B028FD1605}"/>
               </a:ext>
             </a:extLst>
           </p:cNvPr>
@@ -5661,7 +5662,7 @@
           <p:cNvPr id="17" name="Rectangle: Rounded Corners 16">
             <a:extLst>
               <a:ext uri="{FF2B5EF4-FFF2-40B4-BE49-F238E27FC236}">
-                <a16:creationId xmlns:a16="http://schemas.microsoft.com/office/drawing/2014/main" id="{B7FC40C7-5375-F19E-CD74-2A5EBB6791C3}"/>
+                <a16:creationId xmlns:a16="http://schemas.microsoft.com/office/drawing/2014/main" id="{4D15C50B-D33D-2883-E916-2F36E9773E28}"/>
               </a:ext>
             </a:extLst>
           </p:cNvPr>
@@ -5715,7 +5716,7 @@
           <p:cNvPr id="18" name="Oval 17">
             <a:extLst>
               <a:ext uri="{FF2B5EF4-FFF2-40B4-BE49-F238E27FC236}">
-                <a16:creationId xmlns:a16="http://schemas.microsoft.com/office/drawing/2014/main" id="{746CE96A-DAE2-DA40-99B8-42082E9628C8}"/>
+                <a16:creationId xmlns:a16="http://schemas.microsoft.com/office/drawing/2014/main" id="{EE5130D4-2B87-A87C-D74A-20E6A7976514}"/>
               </a:ext>
             </a:extLst>
           </p:cNvPr>
@@ -5783,7 +5784,7 @@
           <p:cNvPr id="19" name="TextBox 18">
             <a:extLst>
               <a:ext uri="{FF2B5EF4-FFF2-40B4-BE49-F238E27FC236}">
-                <a16:creationId xmlns:a16="http://schemas.microsoft.com/office/drawing/2014/main" id="{65D4199A-866A-6635-E1F0-8A106F5A1F71}"/>
+                <a16:creationId xmlns:a16="http://schemas.microsoft.com/office/drawing/2014/main" id="{B943B227-CDA2-E46B-7434-EBB7921DACB7}"/>
               </a:ext>
             </a:extLst>
           </p:cNvPr>
@@ -5824,7 +5825,7 @@
           <p:cNvPr id="20" name="TextBox 19">
             <a:extLst>
               <a:ext uri="{FF2B5EF4-FFF2-40B4-BE49-F238E27FC236}">
-                <a16:creationId xmlns:a16="http://schemas.microsoft.com/office/drawing/2014/main" id="{4C46A7A4-14EC-742F-6E59-EFF4E735433E}"/>
+                <a16:creationId xmlns:a16="http://schemas.microsoft.com/office/drawing/2014/main" id="{CC651C83-F472-2B77-D40F-76F0809D5C98}"/>
               </a:ext>
             </a:extLst>
           </p:cNvPr>
@@ -5865,7 +5866,7 @@
           <p:cNvPr id="21" name="TextBox 20">
             <a:extLst>
               <a:ext uri="{FF2B5EF4-FFF2-40B4-BE49-F238E27FC236}">
-                <a16:creationId xmlns:a16="http://schemas.microsoft.com/office/drawing/2014/main" id="{64681360-07AA-951D-384E-D8F0E58B8949}"/>
+                <a16:creationId xmlns:a16="http://schemas.microsoft.com/office/drawing/2014/main" id="{ADD8E3BD-E7E5-BFA2-B46A-10FF9AD99E3E}"/>
               </a:ext>
             </a:extLst>
           </p:cNvPr>
@@ -5908,7 +5909,7 @@
           <p:cNvPr id="22" name="Rectangle: Rounded Corners 21">
             <a:extLst>
               <a:ext uri="{FF2B5EF4-FFF2-40B4-BE49-F238E27FC236}">
-                <a16:creationId xmlns:a16="http://schemas.microsoft.com/office/drawing/2014/main" id="{C1076BF7-289F-D7BD-8094-948C33ED2D4A}"/>
+                <a16:creationId xmlns:a16="http://schemas.microsoft.com/office/drawing/2014/main" id="{CD4A60D4-54E6-699D-E276-674C59503CCC}"/>
               </a:ext>
             </a:extLst>
           </p:cNvPr>
@@ -5962,7 +5963,7 @@
           <p:cNvPr id="23" name="Oval 22">
             <a:extLst>
               <a:ext uri="{FF2B5EF4-FFF2-40B4-BE49-F238E27FC236}">
-                <a16:creationId xmlns:a16="http://schemas.microsoft.com/office/drawing/2014/main" id="{A9587931-2746-08F7-CF73-1FD920F57FF2}"/>
+                <a16:creationId xmlns:a16="http://schemas.microsoft.com/office/drawing/2014/main" id="{2EF5F72F-9479-FEB8-1287-31658D5E9979}"/>
               </a:ext>
             </a:extLst>
           </p:cNvPr>
@@ -6030,7 +6031,7 @@
           <p:cNvPr id="24" name="TextBox 23">
             <a:extLst>
               <a:ext uri="{FF2B5EF4-FFF2-40B4-BE49-F238E27FC236}">
-                <a16:creationId xmlns:a16="http://schemas.microsoft.com/office/drawing/2014/main" id="{7DB83170-21AB-6ECF-1C1C-281CAA63C94C}"/>
+                <a16:creationId xmlns:a16="http://schemas.microsoft.com/office/drawing/2014/main" id="{626EAE70-CC1D-9E98-A260-7532CCF87CD4}"/>
               </a:ext>
             </a:extLst>
           </p:cNvPr>
@@ -6071,7 +6072,7 @@
           <p:cNvPr id="25" name="TextBox 24">
             <a:extLst>
               <a:ext uri="{FF2B5EF4-FFF2-40B4-BE49-F238E27FC236}">
-                <a16:creationId xmlns:a16="http://schemas.microsoft.com/office/drawing/2014/main" id="{9B3BC3DB-B7B8-3563-0664-D864A82E4DAA}"/>
+                <a16:creationId xmlns:a16="http://schemas.microsoft.com/office/drawing/2014/main" id="{4BD61548-A409-46BE-A0AA-D422A3B4EEE9}"/>
               </a:ext>
             </a:extLst>
           </p:cNvPr>
@@ -6112,7 +6113,7 @@
           <p:cNvPr id="26" name="TextBox 25">
             <a:extLst>
               <a:ext uri="{FF2B5EF4-FFF2-40B4-BE49-F238E27FC236}">
-                <a16:creationId xmlns:a16="http://schemas.microsoft.com/office/drawing/2014/main" id="{515D4646-E1C6-4BC4-75B5-2349D692CF1E}"/>
+                <a16:creationId xmlns:a16="http://schemas.microsoft.com/office/drawing/2014/main" id="{C40094DA-D9A3-79A5-527E-6E1CC1C30F78}"/>
               </a:ext>
             </a:extLst>
           </p:cNvPr>
@@ -6155,7 +6156,7 @@
           <p:cNvPr id="27" name="Rectangle: Rounded Corners 26">
             <a:extLst>
               <a:ext uri="{FF2B5EF4-FFF2-40B4-BE49-F238E27FC236}">
-                <a16:creationId xmlns:a16="http://schemas.microsoft.com/office/drawing/2014/main" id="{05B17CF4-EAB2-A2E4-3D72-8D3BD30B141D}"/>
+                <a16:creationId xmlns:a16="http://schemas.microsoft.com/office/drawing/2014/main" id="{00AA798B-210A-C28C-3624-1D5B95F59552}"/>
               </a:ext>
             </a:extLst>
           </p:cNvPr>
@@ -6209,7 +6210,7 @@
           <p:cNvPr id="28" name="Oval 27">
             <a:extLst>
               <a:ext uri="{FF2B5EF4-FFF2-40B4-BE49-F238E27FC236}">
-                <a16:creationId xmlns:a16="http://schemas.microsoft.com/office/drawing/2014/main" id="{3BC120E3-8D2E-43D6-DC99-48E07067654B}"/>
+                <a16:creationId xmlns:a16="http://schemas.microsoft.com/office/drawing/2014/main" id="{AF5BF5D0-0DFD-2BFF-F172-B031516BDCC8}"/>
               </a:ext>
             </a:extLst>
           </p:cNvPr>
@@ -6277,7 +6278,7 @@
           <p:cNvPr id="29" name="TextBox 28">
             <a:extLst>
               <a:ext uri="{FF2B5EF4-FFF2-40B4-BE49-F238E27FC236}">
-                <a16:creationId xmlns:a16="http://schemas.microsoft.com/office/drawing/2014/main" id="{4D8F6EB3-528E-6728-2F38-74A8C96792DD}"/>
+                <a16:creationId xmlns:a16="http://schemas.microsoft.com/office/drawing/2014/main" id="{DEE4496D-8CFC-3A28-37AE-F1FC84BCC8AE}"/>
               </a:ext>
             </a:extLst>
           </p:cNvPr>
@@ -6318,7 +6319,7 @@
           <p:cNvPr id="30" name="TextBox 29">
             <a:extLst>
               <a:ext uri="{FF2B5EF4-FFF2-40B4-BE49-F238E27FC236}">
-                <a16:creationId xmlns:a16="http://schemas.microsoft.com/office/drawing/2014/main" id="{EF85DDF4-6173-6A63-9524-BD10185218A9}"/>
+                <a16:creationId xmlns:a16="http://schemas.microsoft.com/office/drawing/2014/main" id="{D762F21E-6CB5-B57D-C479-C098942F0E26}"/>
               </a:ext>
             </a:extLst>
           </p:cNvPr>
@@ -6359,7 +6360,7 @@
           <p:cNvPr id="31" name="TextBox 30">
             <a:extLst>
               <a:ext uri="{FF2B5EF4-FFF2-40B4-BE49-F238E27FC236}">
-                <a16:creationId xmlns:a16="http://schemas.microsoft.com/office/drawing/2014/main" id="{A89349DB-0FC5-67B7-B6A4-8D4EBA58DE9E}"/>
+                <a16:creationId xmlns:a16="http://schemas.microsoft.com/office/drawing/2014/main" id="{28C0FE00-4EB0-F679-2DD4-F86B620ED3A6}"/>
               </a:ext>
             </a:extLst>
           </p:cNvPr>
@@ -6402,7 +6403,7 @@
           <p:cNvPr id="32" name="Straight Connector 31">
             <a:extLst>
               <a:ext uri="{FF2B5EF4-FFF2-40B4-BE49-F238E27FC236}">
-                <a16:creationId xmlns:a16="http://schemas.microsoft.com/office/drawing/2014/main" id="{26341AE0-6941-40C8-0F05-D3428226BC5E}"/>
+                <a16:creationId xmlns:a16="http://schemas.microsoft.com/office/drawing/2014/main" id="{33BC0BA1-ED31-C76B-7342-20971EAE0C0C}"/>
               </a:ext>
             </a:extLst>
           </p:cNvPr>
@@ -6444,7 +6445,7 @@
           <p:cNvPr id="33" name="Straight Connector 32">
             <a:extLst>
               <a:ext uri="{FF2B5EF4-FFF2-40B4-BE49-F238E27FC236}">
-                <a16:creationId xmlns:a16="http://schemas.microsoft.com/office/drawing/2014/main" id="{CE8C245A-AA93-C554-3F20-54ADCF565625}"/>
+                <a16:creationId xmlns:a16="http://schemas.microsoft.com/office/drawing/2014/main" id="{2C12C13F-DAD1-12EE-C458-5C18B18BB6A1}"/>
               </a:ext>
             </a:extLst>
           </p:cNvPr>
@@ -6486,7 +6487,7 @@
           <p:cNvPr id="34" name="Straight Connector 33">
             <a:extLst>
               <a:ext uri="{FF2B5EF4-FFF2-40B4-BE49-F238E27FC236}">
-                <a16:creationId xmlns:a16="http://schemas.microsoft.com/office/drawing/2014/main" id="{39D0C026-C8C4-EF83-754E-D6E049897ECE}"/>
+                <a16:creationId xmlns:a16="http://schemas.microsoft.com/office/drawing/2014/main" id="{B748FBD1-1165-3A3C-B1D6-DDF999204480}"/>
               </a:ext>
             </a:extLst>
           </p:cNvPr>
@@ -6528,7 +6529,7 @@
           <p:cNvPr id="35" name="Straight Connector 34">
             <a:extLst>
               <a:ext uri="{FF2B5EF4-FFF2-40B4-BE49-F238E27FC236}">
-                <a16:creationId xmlns:a16="http://schemas.microsoft.com/office/drawing/2014/main" id="{61059191-A2ED-815A-76DA-3F9044A3E27C}"/>
+                <a16:creationId xmlns:a16="http://schemas.microsoft.com/office/drawing/2014/main" id="{2DA871F1-C43A-B7AF-1F52-4F321CC53D31}"/>
               </a:ext>
             </a:extLst>
           </p:cNvPr>
@@ -6570,7 +6571,7 @@
           <p:cNvPr id="36" name="Rectangle: Rounded Corners 35">
             <a:extLst>
               <a:ext uri="{FF2B5EF4-FFF2-40B4-BE49-F238E27FC236}">
-                <a16:creationId xmlns:a16="http://schemas.microsoft.com/office/drawing/2014/main" id="{D3D8DD38-5CC6-AA1D-606B-6717F29B4FEA}"/>
+                <a16:creationId xmlns:a16="http://schemas.microsoft.com/office/drawing/2014/main" id="{6D51ECB0-7B48-42E9-7BA5-411D5C2D3E80}"/>
               </a:ext>
             </a:extLst>
           </p:cNvPr>
@@ -6624,7 +6625,7 @@
           <p:cNvPr id="37" name="TextBox 36">
             <a:extLst>
               <a:ext uri="{FF2B5EF4-FFF2-40B4-BE49-F238E27FC236}">
-                <a16:creationId xmlns:a16="http://schemas.microsoft.com/office/drawing/2014/main" id="{5A3441CC-2E89-57B5-FC48-FFC9B0574628}"/>
+                <a16:creationId xmlns:a16="http://schemas.microsoft.com/office/drawing/2014/main" id="{DF019075-767A-9AE0-65FF-568FF1D9855C}"/>
               </a:ext>
             </a:extLst>
           </p:cNvPr>
@@ -6663,7 +6664,7 @@
     </p:spTree>
     <p:extLst>
       <p:ext uri="{BB962C8B-B14F-4D97-AF65-F5344CB8AC3E}">
-        <p14:creationId xmlns:p14="http://schemas.microsoft.com/office/powerpoint/2010/main" val="2097966209"/>
+        <p14:creationId xmlns:p14="http://schemas.microsoft.com/office/powerpoint/2010/main" val="3432259183"/>
       </p:ext>
     </p:extLst>
   </p:cSld>
@@ -6703,7 +6704,7 @@
           <p:cNvPr id="2" name="TextBox 1">
             <a:extLst>
               <a:ext uri="{FF2B5EF4-FFF2-40B4-BE49-F238E27FC236}">
-                <a16:creationId xmlns:a16="http://schemas.microsoft.com/office/drawing/2014/main" id="{738BE2AD-A912-9F36-BD65-B18734549EE6}"/>
+                <a16:creationId xmlns:a16="http://schemas.microsoft.com/office/drawing/2014/main" id="{658020B1-C3A9-EAFB-11C2-F6FE9C787865}"/>
               </a:ext>
             </a:extLst>
           </p:cNvPr>
@@ -6743,7 +6744,7 @@
           <p:cNvPr id="3" name="TextBox 2">
             <a:extLst>
               <a:ext uri="{FF2B5EF4-FFF2-40B4-BE49-F238E27FC236}">
-                <a16:creationId xmlns:a16="http://schemas.microsoft.com/office/drawing/2014/main" id="{79F495EB-8FA6-B6C8-26CF-C0B20ACACE05}"/>
+                <a16:creationId xmlns:a16="http://schemas.microsoft.com/office/drawing/2014/main" id="{9C396386-F35C-AC7B-00A4-60BBC2E58B1D}"/>
               </a:ext>
             </a:extLst>
           </p:cNvPr>
@@ -6783,7 +6784,7 @@
           <p:cNvPr id="4" name="Straight Connector 3">
             <a:extLst>
               <a:ext uri="{FF2B5EF4-FFF2-40B4-BE49-F238E27FC236}">
-                <a16:creationId xmlns:a16="http://schemas.microsoft.com/office/drawing/2014/main" id="{F0B14DC1-D7F9-980E-63B0-85A19349F1E3}"/>
+                <a16:creationId xmlns:a16="http://schemas.microsoft.com/office/drawing/2014/main" id="{46EEF994-3E80-9251-4BEC-BE824CB58D57}"/>
               </a:ext>
             </a:extLst>
           </p:cNvPr>
@@ -6824,7 +6825,7 @@
           <p:cNvPr id="5" name="TextBox 4">
             <a:extLst>
               <a:ext uri="{FF2B5EF4-FFF2-40B4-BE49-F238E27FC236}">
-                <a16:creationId xmlns:a16="http://schemas.microsoft.com/office/drawing/2014/main" id="{57D90985-F375-3058-88E6-F4606CD604AA}"/>
+                <a16:creationId xmlns:a16="http://schemas.microsoft.com/office/drawing/2014/main" id="{9E8BCCFC-EC48-595A-923C-591D91126CA9}"/>
               </a:ext>
             </a:extLst>
           </p:cNvPr>
@@ -6864,7 +6865,7 @@
           <p:cNvPr id="6" name="TextBox 5">
             <a:extLst>
               <a:ext uri="{FF2B5EF4-FFF2-40B4-BE49-F238E27FC236}">
-                <a16:creationId xmlns:a16="http://schemas.microsoft.com/office/drawing/2014/main" id="{DD490D7B-8F49-D89F-A150-A5478C1A240F}"/>
+                <a16:creationId xmlns:a16="http://schemas.microsoft.com/office/drawing/2014/main" id="{8C77F497-F9BF-737E-8418-4617DD193D2A}"/>
               </a:ext>
             </a:extLst>
           </p:cNvPr>
@@ -6905,7 +6906,7 @@
           <p:cNvPr id="7" name="Rectangle: Rounded Corners 6">
             <a:extLst>
               <a:ext uri="{FF2B5EF4-FFF2-40B4-BE49-F238E27FC236}">
-                <a16:creationId xmlns:a16="http://schemas.microsoft.com/office/drawing/2014/main" id="{F550A6C9-0C71-155C-2500-0DB32D9BFD19}"/>
+                <a16:creationId xmlns:a16="http://schemas.microsoft.com/office/drawing/2014/main" id="{873546CA-C548-F4C7-720D-04E39E13E8FC}"/>
               </a:ext>
             </a:extLst>
           </p:cNvPr>
@@ -6959,7 +6960,7 @@
           <p:cNvPr id="8" name="TextBox 7">
             <a:extLst>
               <a:ext uri="{FF2B5EF4-FFF2-40B4-BE49-F238E27FC236}">
-                <a16:creationId xmlns:a16="http://schemas.microsoft.com/office/drawing/2014/main" id="{89990B1A-8A49-D5AC-6035-4E5A5E18075E}"/>
+                <a16:creationId xmlns:a16="http://schemas.microsoft.com/office/drawing/2014/main" id="{8D4ACF33-5260-FAF7-83CF-0B35F79AF97C}"/>
               </a:ext>
             </a:extLst>
           </p:cNvPr>
@@ -7000,7 +7001,7 @@
           <p:cNvPr id="9" name="TextBox 8">
             <a:extLst>
               <a:ext uri="{FF2B5EF4-FFF2-40B4-BE49-F238E27FC236}">
-                <a16:creationId xmlns:a16="http://schemas.microsoft.com/office/drawing/2014/main" id="{51D6F605-7090-A9E5-EA53-9431D4DF089A}"/>
+                <a16:creationId xmlns:a16="http://schemas.microsoft.com/office/drawing/2014/main" id="{E75661FF-0BBB-D6FB-2A87-4FDAF6FDF36C}"/>
               </a:ext>
             </a:extLst>
           </p:cNvPr>
@@ -7041,7 +7042,7 @@
           <p:cNvPr id="10" name="Rectangle: Rounded Corners 9">
             <a:extLst>
               <a:ext uri="{FF2B5EF4-FFF2-40B4-BE49-F238E27FC236}">
-                <a16:creationId xmlns:a16="http://schemas.microsoft.com/office/drawing/2014/main" id="{FA0FE889-E893-AF14-495F-9F6E498FE598}"/>
+                <a16:creationId xmlns:a16="http://schemas.microsoft.com/office/drawing/2014/main" id="{021969DC-3D34-35CB-8F9A-EA8931BC4D64}"/>
               </a:ext>
             </a:extLst>
           </p:cNvPr>
@@ -7095,7 +7096,7 @@
           <p:cNvPr id="11" name="TextBox 10">
             <a:extLst>
               <a:ext uri="{FF2B5EF4-FFF2-40B4-BE49-F238E27FC236}">
-                <a16:creationId xmlns:a16="http://schemas.microsoft.com/office/drawing/2014/main" id="{AC607F92-54FA-4CC8-1BEA-ACD145D24752}"/>
+                <a16:creationId xmlns:a16="http://schemas.microsoft.com/office/drawing/2014/main" id="{89F48E19-932E-1843-0ABF-6AB6E015C960}"/>
               </a:ext>
             </a:extLst>
           </p:cNvPr>
@@ -7136,7 +7137,7 @@
           <p:cNvPr id="12" name="TextBox 11">
             <a:extLst>
               <a:ext uri="{FF2B5EF4-FFF2-40B4-BE49-F238E27FC236}">
-                <a16:creationId xmlns:a16="http://schemas.microsoft.com/office/drawing/2014/main" id="{9C84A18E-D369-06CF-88C1-124C33C5F1F0}"/>
+                <a16:creationId xmlns:a16="http://schemas.microsoft.com/office/drawing/2014/main" id="{7C77A8AC-B1B1-1B9E-364B-978DC72230D2}"/>
               </a:ext>
             </a:extLst>
           </p:cNvPr>
@@ -7177,7 +7178,7 @@
           <p:cNvPr id="13" name="Rectangle: Rounded Corners 12">
             <a:extLst>
               <a:ext uri="{FF2B5EF4-FFF2-40B4-BE49-F238E27FC236}">
-                <a16:creationId xmlns:a16="http://schemas.microsoft.com/office/drawing/2014/main" id="{E5BB0A6D-C84B-44F6-E198-400B0FC652AE}"/>
+                <a16:creationId xmlns:a16="http://schemas.microsoft.com/office/drawing/2014/main" id="{049CDCFD-E408-0242-41C4-B773F0A77445}"/>
               </a:ext>
             </a:extLst>
           </p:cNvPr>
@@ -7231,7 +7232,7 @@
           <p:cNvPr id="14" name="TextBox 13">
             <a:extLst>
               <a:ext uri="{FF2B5EF4-FFF2-40B4-BE49-F238E27FC236}">
-                <a16:creationId xmlns:a16="http://schemas.microsoft.com/office/drawing/2014/main" id="{D74A35EB-3614-8AAC-43BA-6E35CAA1F052}"/>
+                <a16:creationId xmlns:a16="http://schemas.microsoft.com/office/drawing/2014/main" id="{4BE51C20-428F-5EDC-5CFC-EAD74F472EEA}"/>
               </a:ext>
             </a:extLst>
           </p:cNvPr>
@@ -7272,7 +7273,7 @@
           <p:cNvPr id="15" name="TextBox 14">
             <a:extLst>
               <a:ext uri="{FF2B5EF4-FFF2-40B4-BE49-F238E27FC236}">
-                <a16:creationId xmlns:a16="http://schemas.microsoft.com/office/drawing/2014/main" id="{EA6F1E6F-8B91-DDB5-E375-BD6987E4C63A}"/>
+                <a16:creationId xmlns:a16="http://schemas.microsoft.com/office/drawing/2014/main" id="{C1081684-C4EC-C35A-46A2-CE9A92A36E1F}"/>
               </a:ext>
             </a:extLst>
           </p:cNvPr>
@@ -7313,7 +7314,7 @@
           <p:cNvPr id="16" name="Rectangle: Rounded Corners 15">
             <a:extLst>
               <a:ext uri="{FF2B5EF4-FFF2-40B4-BE49-F238E27FC236}">
-                <a16:creationId xmlns:a16="http://schemas.microsoft.com/office/drawing/2014/main" id="{CE7679AC-19C2-F744-A1A8-09C57B181914}"/>
+                <a16:creationId xmlns:a16="http://schemas.microsoft.com/office/drawing/2014/main" id="{C9E190EC-51A1-A4FF-36EC-1ED40BC59C80}"/>
               </a:ext>
             </a:extLst>
           </p:cNvPr>
@@ -7367,7 +7368,7 @@
           <p:cNvPr id="17" name="TextBox 16">
             <a:extLst>
               <a:ext uri="{FF2B5EF4-FFF2-40B4-BE49-F238E27FC236}">
-                <a16:creationId xmlns:a16="http://schemas.microsoft.com/office/drawing/2014/main" id="{461EA595-9994-5012-20E4-A5B32402B501}"/>
+                <a16:creationId xmlns:a16="http://schemas.microsoft.com/office/drawing/2014/main" id="{36AF4F21-A6A4-B2F4-2E95-9BC27306B25F}"/>
               </a:ext>
             </a:extLst>
           </p:cNvPr>
@@ -7408,7 +7409,7 @@
           <p:cNvPr id="18" name="TextBox 17">
             <a:extLst>
               <a:ext uri="{FF2B5EF4-FFF2-40B4-BE49-F238E27FC236}">
-                <a16:creationId xmlns:a16="http://schemas.microsoft.com/office/drawing/2014/main" id="{6336D5DE-BD60-8F9A-1FE6-72709614369F}"/>
+                <a16:creationId xmlns:a16="http://schemas.microsoft.com/office/drawing/2014/main" id="{A6F85F77-9CFA-7AFE-34C0-52073FE9E1F0}"/>
               </a:ext>
             </a:extLst>
           </p:cNvPr>
@@ -7449,7 +7450,7 @@
           <p:cNvPr id="19" name="Rectangle: Rounded Corners 18">
             <a:extLst>
               <a:ext uri="{FF2B5EF4-FFF2-40B4-BE49-F238E27FC236}">
-                <a16:creationId xmlns:a16="http://schemas.microsoft.com/office/drawing/2014/main" id="{317D4B47-3735-3A06-A055-EDD68931FAB9}"/>
+                <a16:creationId xmlns:a16="http://schemas.microsoft.com/office/drawing/2014/main" id="{D9AD2135-DD6D-A4A2-0523-96F65402DADE}"/>
               </a:ext>
             </a:extLst>
           </p:cNvPr>
@@ -7503,7 +7504,7 @@
           <p:cNvPr id="20" name="TextBox 19">
             <a:extLst>
               <a:ext uri="{FF2B5EF4-FFF2-40B4-BE49-F238E27FC236}">
-                <a16:creationId xmlns:a16="http://schemas.microsoft.com/office/drawing/2014/main" id="{6B739817-4424-F200-7F7B-0FDA44EDAAF8}"/>
+                <a16:creationId xmlns:a16="http://schemas.microsoft.com/office/drawing/2014/main" id="{CD8253D3-7557-D0C0-6BDD-F3CF4D79F670}"/>
               </a:ext>
             </a:extLst>
           </p:cNvPr>
@@ -7544,7 +7545,7 @@
           <p:cNvPr id="21" name="TextBox 20">
             <a:extLst>
               <a:ext uri="{FF2B5EF4-FFF2-40B4-BE49-F238E27FC236}">
-                <a16:creationId xmlns:a16="http://schemas.microsoft.com/office/drawing/2014/main" id="{531274EA-E751-8028-3CD7-D4B723AE921F}"/>
+                <a16:creationId xmlns:a16="http://schemas.microsoft.com/office/drawing/2014/main" id="{12E1559D-1EBC-35DC-5105-64A0B25F57EE}"/>
               </a:ext>
             </a:extLst>
           </p:cNvPr>
@@ -7585,7 +7586,7 @@
           <p:cNvPr id="22" name="Straight Connector 21">
             <a:extLst>
               <a:ext uri="{FF2B5EF4-FFF2-40B4-BE49-F238E27FC236}">
-                <a16:creationId xmlns:a16="http://schemas.microsoft.com/office/drawing/2014/main" id="{4463AFCD-76B0-8CEE-FC1B-72FAAC01E0CA}"/>
+                <a16:creationId xmlns:a16="http://schemas.microsoft.com/office/drawing/2014/main" id="{A3EAE4FD-7A9C-27F6-406D-BFB9063B9279}"/>
               </a:ext>
             </a:extLst>
           </p:cNvPr>
@@ -7627,7 +7628,7 @@
           <p:cNvPr id="23" name="Straight Connector 22">
             <a:extLst>
               <a:ext uri="{FF2B5EF4-FFF2-40B4-BE49-F238E27FC236}">
-                <a16:creationId xmlns:a16="http://schemas.microsoft.com/office/drawing/2014/main" id="{415CAECF-2086-3E5D-877F-9D21FFE28E28}"/>
+                <a16:creationId xmlns:a16="http://schemas.microsoft.com/office/drawing/2014/main" id="{BB1523E1-3441-3B10-2C8C-540C678C068D}"/>
               </a:ext>
             </a:extLst>
           </p:cNvPr>
@@ -7669,7 +7670,7 @@
           <p:cNvPr id="24" name="Straight Connector 23">
             <a:extLst>
               <a:ext uri="{FF2B5EF4-FFF2-40B4-BE49-F238E27FC236}">
-                <a16:creationId xmlns:a16="http://schemas.microsoft.com/office/drawing/2014/main" id="{AB836019-753F-4774-4805-5F6B2AFE2227}"/>
+                <a16:creationId xmlns:a16="http://schemas.microsoft.com/office/drawing/2014/main" id="{9EA5EC05-489B-A5D1-376F-310B79CE3D09}"/>
               </a:ext>
             </a:extLst>
           </p:cNvPr>
@@ -7711,7 +7712,7 @@
           <p:cNvPr id="25" name="Straight Connector 24">
             <a:extLst>
               <a:ext uri="{FF2B5EF4-FFF2-40B4-BE49-F238E27FC236}">
-                <a16:creationId xmlns:a16="http://schemas.microsoft.com/office/drawing/2014/main" id="{3C7629F3-6C19-A1F1-F9C8-835D74C27210}"/>
+                <a16:creationId xmlns:a16="http://schemas.microsoft.com/office/drawing/2014/main" id="{E1D8C3E3-2791-49D5-23E1-371E4E8ABB34}"/>
               </a:ext>
             </a:extLst>
           </p:cNvPr>
@@ -7753,7 +7754,7 @@
           <p:cNvPr id="26" name="Straight Connector 25">
             <a:extLst>
               <a:ext uri="{FF2B5EF4-FFF2-40B4-BE49-F238E27FC236}">
-                <a16:creationId xmlns:a16="http://schemas.microsoft.com/office/drawing/2014/main" id="{ADBCEEE4-1269-910F-D883-32A1F59051C1}"/>
+                <a16:creationId xmlns:a16="http://schemas.microsoft.com/office/drawing/2014/main" id="{821159B1-26AA-917A-B4A5-8E6AB48EC36F}"/>
               </a:ext>
             </a:extLst>
           </p:cNvPr>
@@ -7795,7 +7796,7 @@
           <p:cNvPr id="27" name="Rectangle: Rounded Corners 26">
             <a:extLst>
               <a:ext uri="{FF2B5EF4-FFF2-40B4-BE49-F238E27FC236}">
-                <a16:creationId xmlns:a16="http://schemas.microsoft.com/office/drawing/2014/main" id="{B14F02E6-DC22-4345-0ADE-6BA33EFE01C5}"/>
+                <a16:creationId xmlns:a16="http://schemas.microsoft.com/office/drawing/2014/main" id="{6FD14F02-8E88-A02C-44B0-E6078039EA7C}"/>
               </a:ext>
             </a:extLst>
           </p:cNvPr>
@@ -7849,7 +7850,7 @@
           <p:cNvPr id="28" name="TextBox 27">
             <a:extLst>
               <a:ext uri="{FF2B5EF4-FFF2-40B4-BE49-F238E27FC236}">
-                <a16:creationId xmlns:a16="http://schemas.microsoft.com/office/drawing/2014/main" id="{BE092277-B133-4320-ECCB-C302A5D52868}"/>
+                <a16:creationId xmlns:a16="http://schemas.microsoft.com/office/drawing/2014/main" id="{B0B76DFE-951E-A0C3-B3C1-DAD3C7BE440F}"/>
               </a:ext>
             </a:extLst>
           </p:cNvPr>
@@ -7890,7 +7891,7 @@
           <p:cNvPr id="29" name="TextBox 28">
             <a:extLst>
               <a:ext uri="{FF2B5EF4-FFF2-40B4-BE49-F238E27FC236}">
-                <a16:creationId xmlns:a16="http://schemas.microsoft.com/office/drawing/2014/main" id="{7B5E8709-A0BC-1B1F-3CEB-F4A18FA045E5}"/>
+                <a16:creationId xmlns:a16="http://schemas.microsoft.com/office/drawing/2014/main" id="{E34E9B32-B7FF-94E8-8575-457A670FB0C3}"/>
               </a:ext>
             </a:extLst>
           </p:cNvPr>
@@ -7931,7 +7932,7 @@
           <p:cNvPr id="30" name="Rectangle: Rounded Corners 29">
             <a:extLst>
               <a:ext uri="{FF2B5EF4-FFF2-40B4-BE49-F238E27FC236}">
-                <a16:creationId xmlns:a16="http://schemas.microsoft.com/office/drawing/2014/main" id="{7ED35BAD-3F4F-ED5E-808D-41F410136C8E}"/>
+                <a16:creationId xmlns:a16="http://schemas.microsoft.com/office/drawing/2014/main" id="{C6E7FE65-553A-EA99-7E6A-6D05FA7B4249}"/>
               </a:ext>
             </a:extLst>
           </p:cNvPr>
@@ -7985,7 +7986,7 @@
           <p:cNvPr id="31" name="TextBox 30">
             <a:extLst>
               <a:ext uri="{FF2B5EF4-FFF2-40B4-BE49-F238E27FC236}">
-                <a16:creationId xmlns:a16="http://schemas.microsoft.com/office/drawing/2014/main" id="{5A67144E-E588-0AC0-01FB-9B244737BF33}"/>
+                <a16:creationId xmlns:a16="http://schemas.microsoft.com/office/drawing/2014/main" id="{9277CC3E-DE4A-2220-E271-077C8DD27CB4}"/>
               </a:ext>
             </a:extLst>
           </p:cNvPr>
@@ -8025,7 +8026,7 @@
           <p:cNvPr id="32" name="Rectangle: Rounded Corners 31">
             <a:extLst>
               <a:ext uri="{FF2B5EF4-FFF2-40B4-BE49-F238E27FC236}">
-                <a16:creationId xmlns:a16="http://schemas.microsoft.com/office/drawing/2014/main" id="{36B60952-76A8-4D7A-E3D5-654FF39A2BB9}"/>
+                <a16:creationId xmlns:a16="http://schemas.microsoft.com/office/drawing/2014/main" id="{6E9BC5B0-F560-A603-B987-7EB0BC43162E}"/>
               </a:ext>
             </a:extLst>
           </p:cNvPr>
@@ -8079,7 +8080,7 @@
           <p:cNvPr id="33" name="TextBox 32">
             <a:extLst>
               <a:ext uri="{FF2B5EF4-FFF2-40B4-BE49-F238E27FC236}">
-                <a16:creationId xmlns:a16="http://schemas.microsoft.com/office/drawing/2014/main" id="{D5425AB9-0771-859F-46D3-71E50C9DB12E}"/>
+                <a16:creationId xmlns:a16="http://schemas.microsoft.com/office/drawing/2014/main" id="{0EFD64B2-E136-A470-C403-AC250DD3832C}"/>
               </a:ext>
             </a:extLst>
           </p:cNvPr>
@@ -8120,7 +8121,7 @@
           <p:cNvPr id="34" name="Rectangle: Rounded Corners 33">
             <a:extLst>
               <a:ext uri="{FF2B5EF4-FFF2-40B4-BE49-F238E27FC236}">
-                <a16:creationId xmlns:a16="http://schemas.microsoft.com/office/drawing/2014/main" id="{3407D76D-6AA7-20F7-0745-3C847926B393}"/>
+                <a16:creationId xmlns:a16="http://schemas.microsoft.com/office/drawing/2014/main" id="{88A5CBA8-72D6-BB2A-D4EC-B0B85C037FE6}"/>
               </a:ext>
             </a:extLst>
           </p:cNvPr>
@@ -8174,7 +8175,7 @@
           <p:cNvPr id="35" name="TextBox 34">
             <a:extLst>
               <a:ext uri="{FF2B5EF4-FFF2-40B4-BE49-F238E27FC236}">
-                <a16:creationId xmlns:a16="http://schemas.microsoft.com/office/drawing/2014/main" id="{232D1C0F-1E70-5A23-49A5-E9BFF4C058DB}"/>
+                <a16:creationId xmlns:a16="http://schemas.microsoft.com/office/drawing/2014/main" id="{806EE9BF-EB29-01D7-3028-E466181E0618}"/>
               </a:ext>
             </a:extLst>
           </p:cNvPr>
@@ -8215,7 +8216,7 @@
           <p:cNvPr id="36" name="Rectangle: Rounded Corners 35">
             <a:extLst>
               <a:ext uri="{FF2B5EF4-FFF2-40B4-BE49-F238E27FC236}">
-                <a16:creationId xmlns:a16="http://schemas.microsoft.com/office/drawing/2014/main" id="{2F11FD4D-D768-D900-E0AC-050F198D821B}"/>
+                <a16:creationId xmlns:a16="http://schemas.microsoft.com/office/drawing/2014/main" id="{2D159B34-37DF-6FFC-4615-0D99AD636740}"/>
               </a:ext>
             </a:extLst>
           </p:cNvPr>
@@ -8269,7 +8270,7 @@
           <p:cNvPr id="37" name="TextBox 36">
             <a:extLst>
               <a:ext uri="{FF2B5EF4-FFF2-40B4-BE49-F238E27FC236}">
-                <a16:creationId xmlns:a16="http://schemas.microsoft.com/office/drawing/2014/main" id="{B44BCEA8-AB39-1021-BEC5-858EDB84D8DB}"/>
+                <a16:creationId xmlns:a16="http://schemas.microsoft.com/office/drawing/2014/main" id="{3DFA4A05-33B3-AF7C-12C5-59561D076AE7}"/>
               </a:ext>
             </a:extLst>
           </p:cNvPr>
@@ -8310,7 +8311,7 @@
           <p:cNvPr id="38" name="Rectangle: Rounded Corners 37">
             <a:extLst>
               <a:ext uri="{FF2B5EF4-FFF2-40B4-BE49-F238E27FC236}">
-                <a16:creationId xmlns:a16="http://schemas.microsoft.com/office/drawing/2014/main" id="{4EF33E11-7E4F-51DE-6E6F-C523FECB46E6}"/>
+                <a16:creationId xmlns:a16="http://schemas.microsoft.com/office/drawing/2014/main" id="{EDAB9E29-8B30-0784-8AD4-F555EC632F20}"/>
               </a:ext>
             </a:extLst>
           </p:cNvPr>
@@ -8364,7 +8365,7 @@
           <p:cNvPr id="39" name="TextBox 38">
             <a:extLst>
               <a:ext uri="{FF2B5EF4-FFF2-40B4-BE49-F238E27FC236}">
-                <a16:creationId xmlns:a16="http://schemas.microsoft.com/office/drawing/2014/main" id="{12BEFAC6-D338-76ED-9F20-BB056C1C6FF2}"/>
+                <a16:creationId xmlns:a16="http://schemas.microsoft.com/office/drawing/2014/main" id="{A97BF8A0-CCD9-928F-B4FF-5FA90D67D0AC}"/>
               </a:ext>
             </a:extLst>
           </p:cNvPr>
@@ -8405,7 +8406,7 @@
           <p:cNvPr id="40" name="Rectangle: Rounded Corners 39">
             <a:extLst>
               <a:ext uri="{FF2B5EF4-FFF2-40B4-BE49-F238E27FC236}">
-                <a16:creationId xmlns:a16="http://schemas.microsoft.com/office/drawing/2014/main" id="{AA132C06-B2E1-4E11-0711-CAD951575F89}"/>
+                <a16:creationId xmlns:a16="http://schemas.microsoft.com/office/drawing/2014/main" id="{E29956CB-25DC-4072-21D5-883CA618CBBF}"/>
               </a:ext>
             </a:extLst>
           </p:cNvPr>
@@ -8459,7 +8460,7 @@
           <p:cNvPr id="41" name="TextBox 40">
             <a:extLst>
               <a:ext uri="{FF2B5EF4-FFF2-40B4-BE49-F238E27FC236}">
-                <a16:creationId xmlns:a16="http://schemas.microsoft.com/office/drawing/2014/main" id="{E08451F6-FE00-C4E1-DFDD-17FF02CFB6C3}"/>
+                <a16:creationId xmlns:a16="http://schemas.microsoft.com/office/drawing/2014/main" id="{73BF18EE-E136-F9C1-6123-5EA6485CC9E4}"/>
               </a:ext>
             </a:extLst>
           </p:cNvPr>
@@ -8500,7 +8501,7 @@
           <p:cNvPr id="42" name="Rectangle: Rounded Corners 41">
             <a:extLst>
               <a:ext uri="{FF2B5EF4-FFF2-40B4-BE49-F238E27FC236}">
-                <a16:creationId xmlns:a16="http://schemas.microsoft.com/office/drawing/2014/main" id="{5B65955A-3619-A72D-212E-6A236FC0B924}"/>
+                <a16:creationId xmlns:a16="http://schemas.microsoft.com/office/drawing/2014/main" id="{C27393C5-11B3-40DD-CE4E-556C3A76D907}"/>
               </a:ext>
             </a:extLst>
           </p:cNvPr>
@@ -8554,7 +8555,7 @@
           <p:cNvPr id="43" name="TextBox 42">
             <a:extLst>
               <a:ext uri="{FF2B5EF4-FFF2-40B4-BE49-F238E27FC236}">
-                <a16:creationId xmlns:a16="http://schemas.microsoft.com/office/drawing/2014/main" id="{D7FDCF26-2F3F-E9C9-FEAC-7F434C8D7C67}"/>
+                <a16:creationId xmlns:a16="http://schemas.microsoft.com/office/drawing/2014/main" id="{BA693769-A2A0-1988-1A45-4E07E3460BD8}"/>
               </a:ext>
             </a:extLst>
           </p:cNvPr>
@@ -8594,7 +8595,7 @@
           <p:cNvPr id="44" name="TextBox 43">
             <a:extLst>
               <a:ext uri="{FF2B5EF4-FFF2-40B4-BE49-F238E27FC236}">
-                <a16:creationId xmlns:a16="http://schemas.microsoft.com/office/drawing/2014/main" id="{D5784A17-797B-C88A-4863-57BDDF8193BE}"/>
+                <a16:creationId xmlns:a16="http://schemas.microsoft.com/office/drawing/2014/main" id="{59A879E6-06AE-6D6F-EECD-A89092398B14}"/>
               </a:ext>
             </a:extLst>
           </p:cNvPr>
@@ -8633,7 +8634,7 @@
     </p:spTree>
     <p:extLst>
       <p:ext uri="{BB962C8B-B14F-4D97-AF65-F5344CB8AC3E}">
-        <p14:creationId xmlns:p14="http://schemas.microsoft.com/office/powerpoint/2010/main" val="3087137125"/>
+        <p14:creationId xmlns:p14="http://schemas.microsoft.com/office/powerpoint/2010/main" val="3702120149"/>
       </p:ext>
     </p:extLst>
   </p:cSld>
@@ -8673,7 +8674,7 @@
           <p:cNvPr id="2" name="TextBox 1">
             <a:extLst>
               <a:ext uri="{FF2B5EF4-FFF2-40B4-BE49-F238E27FC236}">
-                <a16:creationId xmlns:a16="http://schemas.microsoft.com/office/drawing/2014/main" id="{6AFFD602-4B0F-6FE0-D5C3-497673FDD99C}"/>
+                <a16:creationId xmlns:a16="http://schemas.microsoft.com/office/drawing/2014/main" id="{DEA60681-5290-3590-7428-168CCA2E2CDF}"/>
               </a:ext>
             </a:extLst>
           </p:cNvPr>
@@ -8713,7 +8714,7 @@
           <p:cNvPr id="3" name="TextBox 2">
             <a:extLst>
               <a:ext uri="{FF2B5EF4-FFF2-40B4-BE49-F238E27FC236}">
-                <a16:creationId xmlns:a16="http://schemas.microsoft.com/office/drawing/2014/main" id="{0E1B45C7-8B79-0DF2-7E0F-AA5D9BBF4BAA}"/>
+                <a16:creationId xmlns:a16="http://schemas.microsoft.com/office/drawing/2014/main" id="{6703E7F9-7841-E2C1-1B1B-345C218AA1AF}"/>
               </a:ext>
             </a:extLst>
           </p:cNvPr>
@@ -8753,7 +8754,7 @@
           <p:cNvPr id="4" name="Straight Connector 3">
             <a:extLst>
               <a:ext uri="{FF2B5EF4-FFF2-40B4-BE49-F238E27FC236}">
-                <a16:creationId xmlns:a16="http://schemas.microsoft.com/office/drawing/2014/main" id="{3A68A5BB-5EE4-D8AF-4250-03CAFB873B6E}"/>
+                <a16:creationId xmlns:a16="http://schemas.microsoft.com/office/drawing/2014/main" id="{5328455C-C327-7F3B-8BC7-95F4BD60E5E4}"/>
               </a:ext>
             </a:extLst>
           </p:cNvPr>
@@ -8794,7 +8795,7 @@
           <p:cNvPr id="5" name="TextBox 4">
             <a:extLst>
               <a:ext uri="{FF2B5EF4-FFF2-40B4-BE49-F238E27FC236}">
-                <a16:creationId xmlns:a16="http://schemas.microsoft.com/office/drawing/2014/main" id="{9D5E0044-66C4-8EAD-2E7D-375A348915D2}"/>
+                <a16:creationId xmlns:a16="http://schemas.microsoft.com/office/drawing/2014/main" id="{D38588A8-288F-F321-026A-3C07375CF06F}"/>
               </a:ext>
             </a:extLst>
           </p:cNvPr>
@@ -8834,7 +8835,7 @@
           <p:cNvPr id="6" name="TextBox 5">
             <a:extLst>
               <a:ext uri="{FF2B5EF4-FFF2-40B4-BE49-F238E27FC236}">
-                <a16:creationId xmlns:a16="http://schemas.microsoft.com/office/drawing/2014/main" id="{728E38B0-FFC3-D832-B2A0-7061410B9AC5}"/>
+                <a16:creationId xmlns:a16="http://schemas.microsoft.com/office/drawing/2014/main" id="{36FC2F3E-1131-8FFE-6FD5-C46821349930}"/>
               </a:ext>
             </a:extLst>
           </p:cNvPr>
@@ -8875,7 +8876,7 @@
           <p:cNvPr id="7" name="Rectangle: Rounded Corners 6">
             <a:extLst>
               <a:ext uri="{FF2B5EF4-FFF2-40B4-BE49-F238E27FC236}">
-                <a16:creationId xmlns:a16="http://schemas.microsoft.com/office/drawing/2014/main" id="{DA2F67F6-FC52-A891-75C5-3B9A7E16B7C1}"/>
+                <a16:creationId xmlns:a16="http://schemas.microsoft.com/office/drawing/2014/main" id="{A6D70682-2757-A68D-E04E-F0B022AB7966}"/>
               </a:ext>
             </a:extLst>
           </p:cNvPr>
@@ -8929,7 +8930,7 @@
           <p:cNvPr id="8" name="TextBox 7">
             <a:extLst>
               <a:ext uri="{FF2B5EF4-FFF2-40B4-BE49-F238E27FC236}">
-                <a16:creationId xmlns:a16="http://schemas.microsoft.com/office/drawing/2014/main" id="{CCCA6E87-BB20-4C62-B3F8-B5056FCF8EF6}"/>
+                <a16:creationId xmlns:a16="http://schemas.microsoft.com/office/drawing/2014/main" id="{F9E33FEE-BA05-D30A-5206-0A950701FA76}"/>
               </a:ext>
             </a:extLst>
           </p:cNvPr>
@@ -8969,7 +8970,7 @@
           <p:cNvPr id="9" name="TextBox 8">
             <a:extLst>
               <a:ext uri="{FF2B5EF4-FFF2-40B4-BE49-F238E27FC236}">
-                <a16:creationId xmlns:a16="http://schemas.microsoft.com/office/drawing/2014/main" id="{F6DCCFAA-CFCE-D071-33AD-0576ECFB5DAB}"/>
+                <a16:creationId xmlns:a16="http://schemas.microsoft.com/office/drawing/2014/main" id="{3E901D1D-8A50-0191-CF08-686772B1069E}"/>
               </a:ext>
             </a:extLst>
           </p:cNvPr>
@@ -9009,7 +9010,7 @@
           <p:cNvPr id="10" name="TextBox 9">
             <a:extLst>
               <a:ext uri="{FF2B5EF4-FFF2-40B4-BE49-F238E27FC236}">
-                <a16:creationId xmlns:a16="http://schemas.microsoft.com/office/drawing/2014/main" id="{6DD4076B-7896-60CB-D688-A8488A757D3A}"/>
+                <a16:creationId xmlns:a16="http://schemas.microsoft.com/office/drawing/2014/main" id="{33EC809C-39B5-3F62-8636-B6A307362A33}"/>
               </a:ext>
             </a:extLst>
           </p:cNvPr>
@@ -9049,7 +9050,7 @@
           <p:cNvPr id="11" name="Straight Connector 10">
             <a:extLst>
               <a:ext uri="{FF2B5EF4-FFF2-40B4-BE49-F238E27FC236}">
-                <a16:creationId xmlns:a16="http://schemas.microsoft.com/office/drawing/2014/main" id="{6992A8D4-A811-7541-59D4-D2C076EF826C}"/>
+                <a16:creationId xmlns:a16="http://schemas.microsoft.com/office/drawing/2014/main" id="{2C60744F-347B-612B-86FA-DE6092033C81}"/>
               </a:ext>
             </a:extLst>
           </p:cNvPr>
@@ -9090,7 +9091,7 @@
           <p:cNvPr id="12" name="TextBox 11">
             <a:extLst>
               <a:ext uri="{FF2B5EF4-FFF2-40B4-BE49-F238E27FC236}">
-                <a16:creationId xmlns:a16="http://schemas.microsoft.com/office/drawing/2014/main" id="{E61F99FA-FDF5-E042-1F6C-5DCDF36C1490}"/>
+                <a16:creationId xmlns:a16="http://schemas.microsoft.com/office/drawing/2014/main" id="{DA4CFEE2-D3E9-6840-EE9A-139B2B4F4758}"/>
               </a:ext>
             </a:extLst>
           </p:cNvPr>
@@ -9132,7 +9133,7 @@
           <p:cNvPr id="13" name="Rectangle: Rounded Corners 12">
             <a:extLst>
               <a:ext uri="{FF2B5EF4-FFF2-40B4-BE49-F238E27FC236}">
-                <a16:creationId xmlns:a16="http://schemas.microsoft.com/office/drawing/2014/main" id="{65C10D84-595E-E0AB-55BF-3A41A2A8A10F}"/>
+                <a16:creationId xmlns:a16="http://schemas.microsoft.com/office/drawing/2014/main" id="{BB5335F5-F7A0-84C7-5BAF-C1FE00F6C8B8}"/>
               </a:ext>
             </a:extLst>
           </p:cNvPr>
@@ -9186,7 +9187,7 @@
           <p:cNvPr id="14" name="TextBox 13">
             <a:extLst>
               <a:ext uri="{FF2B5EF4-FFF2-40B4-BE49-F238E27FC236}">
-                <a16:creationId xmlns:a16="http://schemas.microsoft.com/office/drawing/2014/main" id="{5947A464-4EFE-368A-7496-1491BF6DB785}"/>
+                <a16:creationId xmlns:a16="http://schemas.microsoft.com/office/drawing/2014/main" id="{5E2C91AA-91E8-437E-FC4D-AC5113DE5449}"/>
               </a:ext>
             </a:extLst>
           </p:cNvPr>
@@ -9226,7 +9227,7 @@
           <p:cNvPr id="15" name="TextBox 14">
             <a:extLst>
               <a:ext uri="{FF2B5EF4-FFF2-40B4-BE49-F238E27FC236}">
-                <a16:creationId xmlns:a16="http://schemas.microsoft.com/office/drawing/2014/main" id="{34731127-A5A6-8138-BC2F-C132EB78CE33}"/>
+                <a16:creationId xmlns:a16="http://schemas.microsoft.com/office/drawing/2014/main" id="{65B9377D-B738-5B78-3CEB-19F28D2E10C4}"/>
               </a:ext>
             </a:extLst>
           </p:cNvPr>
@@ -9266,7 +9267,7 @@
           <p:cNvPr id="16" name="TextBox 15">
             <a:extLst>
               <a:ext uri="{FF2B5EF4-FFF2-40B4-BE49-F238E27FC236}">
-                <a16:creationId xmlns:a16="http://schemas.microsoft.com/office/drawing/2014/main" id="{027D2800-A2F9-9B2E-0A1D-A9E1DDE2395F}"/>
+                <a16:creationId xmlns:a16="http://schemas.microsoft.com/office/drawing/2014/main" id="{171D2824-01CC-F109-D5BE-1548E16532B0}"/>
               </a:ext>
             </a:extLst>
           </p:cNvPr>
@@ -9312,7 +9313,7 @@
           <p:cNvPr id="17" name="Straight Connector 16">
             <a:extLst>
               <a:ext uri="{FF2B5EF4-FFF2-40B4-BE49-F238E27FC236}">
-                <a16:creationId xmlns:a16="http://schemas.microsoft.com/office/drawing/2014/main" id="{4FAF497D-6107-744B-F05B-F100282F6093}"/>
+                <a16:creationId xmlns:a16="http://schemas.microsoft.com/office/drawing/2014/main" id="{BD0DA1FE-3B10-3726-955F-86BD2394F2B8}"/>
               </a:ext>
             </a:extLst>
           </p:cNvPr>
@@ -9353,7 +9354,7 @@
           <p:cNvPr id="18" name="TextBox 17">
             <a:extLst>
               <a:ext uri="{FF2B5EF4-FFF2-40B4-BE49-F238E27FC236}">
-                <a16:creationId xmlns:a16="http://schemas.microsoft.com/office/drawing/2014/main" id="{519EB3A0-5A1D-1F6D-0FC3-FCA4C188D1DF}"/>
+                <a16:creationId xmlns:a16="http://schemas.microsoft.com/office/drawing/2014/main" id="{106A2CE0-1563-84D9-3B43-4C64A1025408}"/>
               </a:ext>
             </a:extLst>
           </p:cNvPr>
@@ -9394,7 +9395,7 @@
           <p:cNvPr id="19" name="Rectangle: Rounded Corners 18">
             <a:extLst>
               <a:ext uri="{FF2B5EF4-FFF2-40B4-BE49-F238E27FC236}">
-                <a16:creationId xmlns:a16="http://schemas.microsoft.com/office/drawing/2014/main" id="{1379145F-14EA-7DAE-694B-170778724750}"/>
+                <a16:creationId xmlns:a16="http://schemas.microsoft.com/office/drawing/2014/main" id="{C59F5C75-5289-72A0-A809-D5296906D066}"/>
               </a:ext>
             </a:extLst>
           </p:cNvPr>
@@ -9448,7 +9449,7 @@
           <p:cNvPr id="20" name="TextBox 19">
             <a:extLst>
               <a:ext uri="{FF2B5EF4-FFF2-40B4-BE49-F238E27FC236}">
-                <a16:creationId xmlns:a16="http://schemas.microsoft.com/office/drawing/2014/main" id="{124A8DEF-0EAD-55B8-F0F9-BD242F07E931}"/>
+                <a16:creationId xmlns:a16="http://schemas.microsoft.com/office/drawing/2014/main" id="{FC4E5E61-4950-4CEA-CB7E-B5274105D011}"/>
               </a:ext>
             </a:extLst>
           </p:cNvPr>
@@ -9488,7 +9489,7 @@
           <p:cNvPr id="21" name="TextBox 20">
             <a:extLst>
               <a:ext uri="{FF2B5EF4-FFF2-40B4-BE49-F238E27FC236}">
-                <a16:creationId xmlns:a16="http://schemas.microsoft.com/office/drawing/2014/main" id="{4664F49C-115E-D4F3-FBD8-8F0F8FDF06F0}"/>
+                <a16:creationId xmlns:a16="http://schemas.microsoft.com/office/drawing/2014/main" id="{AD859DAB-4C2D-080A-E90B-3D58C6219770}"/>
               </a:ext>
             </a:extLst>
           </p:cNvPr>
@@ -9528,7 +9529,7 @@
           <p:cNvPr id="22" name="TextBox 21">
             <a:extLst>
               <a:ext uri="{FF2B5EF4-FFF2-40B4-BE49-F238E27FC236}">
-                <a16:creationId xmlns:a16="http://schemas.microsoft.com/office/drawing/2014/main" id="{344896A1-87B4-3D07-734B-4C9126199347}"/>
+                <a16:creationId xmlns:a16="http://schemas.microsoft.com/office/drawing/2014/main" id="{EEFF58C4-4F2F-1740-A338-375C64165831}"/>
               </a:ext>
             </a:extLst>
           </p:cNvPr>
@@ -9574,7 +9575,7 @@
           <p:cNvPr id="23" name="Straight Connector 22">
             <a:extLst>
               <a:ext uri="{FF2B5EF4-FFF2-40B4-BE49-F238E27FC236}">
-                <a16:creationId xmlns:a16="http://schemas.microsoft.com/office/drawing/2014/main" id="{3884A100-F684-467F-8395-9C21AE6E84F7}"/>
+                <a16:creationId xmlns:a16="http://schemas.microsoft.com/office/drawing/2014/main" id="{7F2CC9ED-0C99-6562-77C3-C452BDE6AA31}"/>
               </a:ext>
             </a:extLst>
           </p:cNvPr>
@@ -9615,7 +9616,7 @@
           <p:cNvPr id="24" name="TextBox 23">
             <a:extLst>
               <a:ext uri="{FF2B5EF4-FFF2-40B4-BE49-F238E27FC236}">
-                <a16:creationId xmlns:a16="http://schemas.microsoft.com/office/drawing/2014/main" id="{1ADAC8C0-FDD1-A340-DAF1-907972A2B37F}"/>
+                <a16:creationId xmlns:a16="http://schemas.microsoft.com/office/drawing/2014/main" id="{5851FB80-6CAA-E539-01EE-44D628543F4A}"/>
               </a:ext>
             </a:extLst>
           </p:cNvPr>
@@ -9656,7 +9657,7 @@
           <p:cNvPr id="25" name="Rectangle: Rounded Corners 24">
             <a:extLst>
               <a:ext uri="{FF2B5EF4-FFF2-40B4-BE49-F238E27FC236}">
-                <a16:creationId xmlns:a16="http://schemas.microsoft.com/office/drawing/2014/main" id="{A984C369-2619-AA27-3C8F-2341A51D4CE2}"/>
+                <a16:creationId xmlns:a16="http://schemas.microsoft.com/office/drawing/2014/main" id="{68592C0D-8D83-8000-589F-BDC369E1964C}"/>
               </a:ext>
             </a:extLst>
           </p:cNvPr>
@@ -9710,7 +9711,7 @@
           <p:cNvPr id="26" name="TextBox 25">
             <a:extLst>
               <a:ext uri="{FF2B5EF4-FFF2-40B4-BE49-F238E27FC236}">
-                <a16:creationId xmlns:a16="http://schemas.microsoft.com/office/drawing/2014/main" id="{20770DED-D84B-A94C-F1D9-A7AC7DBC3D64}"/>
+                <a16:creationId xmlns:a16="http://schemas.microsoft.com/office/drawing/2014/main" id="{93569005-5A68-3741-91ED-03A401D4DFAD}"/>
               </a:ext>
             </a:extLst>
           </p:cNvPr>
@@ -9750,7 +9751,7 @@
           <p:cNvPr id="27" name="TextBox 26">
             <a:extLst>
               <a:ext uri="{FF2B5EF4-FFF2-40B4-BE49-F238E27FC236}">
-                <a16:creationId xmlns:a16="http://schemas.microsoft.com/office/drawing/2014/main" id="{9198019F-3814-8099-F76E-E63837DB36AC}"/>
+                <a16:creationId xmlns:a16="http://schemas.microsoft.com/office/drawing/2014/main" id="{5A7464BC-E83C-9998-DCCA-F4B33950C1C8}"/>
               </a:ext>
             </a:extLst>
           </p:cNvPr>
@@ -9789,7 +9790,7 @@
     </p:spTree>
     <p:extLst>
       <p:ext uri="{BB962C8B-B14F-4D97-AF65-F5344CB8AC3E}">
-        <p14:creationId xmlns:p14="http://schemas.microsoft.com/office/powerpoint/2010/main" val="2035592991"/>
+        <p14:creationId xmlns:p14="http://schemas.microsoft.com/office/powerpoint/2010/main" val="1019692461"/>
       </p:ext>
     </p:extLst>
   </p:cSld>
@@ -9829,7 +9830,7 @@
           <p:cNvPr id="2" name="TextBox 1">
             <a:extLst>
               <a:ext uri="{FF2B5EF4-FFF2-40B4-BE49-F238E27FC236}">
-                <a16:creationId xmlns:a16="http://schemas.microsoft.com/office/drawing/2014/main" id="{169F2A18-C34F-1CF7-DD30-A4C1093BBAFB}"/>
+                <a16:creationId xmlns:a16="http://schemas.microsoft.com/office/drawing/2014/main" id="{9E3E6C17-0839-DC00-8E89-55B62A70BDFC}"/>
               </a:ext>
             </a:extLst>
           </p:cNvPr>
@@ -9869,7 +9870,7 @@
           <p:cNvPr id="3" name="TextBox 2">
             <a:extLst>
               <a:ext uri="{FF2B5EF4-FFF2-40B4-BE49-F238E27FC236}">
-                <a16:creationId xmlns:a16="http://schemas.microsoft.com/office/drawing/2014/main" id="{04EDF68D-49B8-09A8-B71B-CD4F7E937AD2}"/>
+                <a16:creationId xmlns:a16="http://schemas.microsoft.com/office/drawing/2014/main" id="{E8A43C7A-0BFF-C9E3-1435-BFCEAFC3433E}"/>
               </a:ext>
             </a:extLst>
           </p:cNvPr>
@@ -9909,7 +9910,7 @@
           <p:cNvPr id="4" name="Straight Connector 3">
             <a:extLst>
               <a:ext uri="{FF2B5EF4-FFF2-40B4-BE49-F238E27FC236}">
-                <a16:creationId xmlns:a16="http://schemas.microsoft.com/office/drawing/2014/main" id="{72A4B966-E3A1-4B1D-8D50-9C2474789A51}"/>
+                <a16:creationId xmlns:a16="http://schemas.microsoft.com/office/drawing/2014/main" id="{4179BB8B-639B-C200-64A8-5F89C3AE0036}"/>
               </a:ext>
             </a:extLst>
           </p:cNvPr>
@@ -9950,7 +9951,7 @@
           <p:cNvPr id="5" name="TextBox 4">
             <a:extLst>
               <a:ext uri="{FF2B5EF4-FFF2-40B4-BE49-F238E27FC236}">
-                <a16:creationId xmlns:a16="http://schemas.microsoft.com/office/drawing/2014/main" id="{2632C3E8-3037-9B3D-7960-098DB2CB5480}"/>
+                <a16:creationId xmlns:a16="http://schemas.microsoft.com/office/drawing/2014/main" id="{EE023C59-A9C6-7C8C-E5E4-06B406E27CB0}"/>
               </a:ext>
             </a:extLst>
           </p:cNvPr>
@@ -9990,7 +9991,7 @@
           <p:cNvPr id="6" name="TextBox 5">
             <a:extLst>
               <a:ext uri="{FF2B5EF4-FFF2-40B4-BE49-F238E27FC236}">
-                <a16:creationId xmlns:a16="http://schemas.microsoft.com/office/drawing/2014/main" id="{650F2C54-049E-1822-232A-5D0C0EEF8B11}"/>
+                <a16:creationId xmlns:a16="http://schemas.microsoft.com/office/drawing/2014/main" id="{9BB6B9E0-08E1-4600-A4EF-CA10A2A63D2D}"/>
               </a:ext>
             </a:extLst>
           </p:cNvPr>
@@ -10031,7 +10032,7 @@
           <p:cNvPr id="7" name="Rectangle: Rounded Corners 6">
             <a:extLst>
               <a:ext uri="{FF2B5EF4-FFF2-40B4-BE49-F238E27FC236}">
-                <a16:creationId xmlns:a16="http://schemas.microsoft.com/office/drawing/2014/main" id="{A2B644DE-D492-96B9-B042-DD8D06054D8D}"/>
+                <a16:creationId xmlns:a16="http://schemas.microsoft.com/office/drawing/2014/main" id="{65198E2F-641E-AB0A-2C7E-EBD533AE7A52}"/>
               </a:ext>
             </a:extLst>
           </p:cNvPr>
@@ -10085,7 +10086,7 @@
           <p:cNvPr id="8" name="Rectangle: Rounded Corners 7">
             <a:extLst>
               <a:ext uri="{FF2B5EF4-FFF2-40B4-BE49-F238E27FC236}">
-                <a16:creationId xmlns:a16="http://schemas.microsoft.com/office/drawing/2014/main" id="{9005DD76-8160-D836-A58B-9FF985398C9C}"/>
+                <a16:creationId xmlns:a16="http://schemas.microsoft.com/office/drawing/2014/main" id="{1C132A82-376F-665A-ACA8-E1FE78FBE5BA}"/>
               </a:ext>
             </a:extLst>
           </p:cNvPr>
@@ -10139,7 +10140,7 @@
           <p:cNvPr id="9" name="TextBox 8">
             <a:extLst>
               <a:ext uri="{FF2B5EF4-FFF2-40B4-BE49-F238E27FC236}">
-                <a16:creationId xmlns:a16="http://schemas.microsoft.com/office/drawing/2014/main" id="{BF9D2886-AF6A-4CE2-DA3A-A589A2EF5CEC}"/>
+                <a16:creationId xmlns:a16="http://schemas.microsoft.com/office/drawing/2014/main" id="{D06E5C77-3EE0-C6B7-A5E3-3F6E9847DB73}"/>
               </a:ext>
             </a:extLst>
           </p:cNvPr>
@@ -10180,7 +10181,7 @@
           <p:cNvPr id="10" name="TextBox 9">
             <a:extLst>
               <a:ext uri="{FF2B5EF4-FFF2-40B4-BE49-F238E27FC236}">
-                <a16:creationId xmlns:a16="http://schemas.microsoft.com/office/drawing/2014/main" id="{31EB1B32-D596-41C2-4DC7-0F35603BF1CD}"/>
+                <a16:creationId xmlns:a16="http://schemas.microsoft.com/office/drawing/2014/main" id="{9B36BF60-BD65-83FC-116E-A23FEB59F254}"/>
               </a:ext>
             </a:extLst>
           </p:cNvPr>
@@ -10220,7 +10221,7 @@
           <p:cNvPr id="11" name="TextBox 10">
             <a:extLst>
               <a:ext uri="{FF2B5EF4-FFF2-40B4-BE49-F238E27FC236}">
-                <a16:creationId xmlns:a16="http://schemas.microsoft.com/office/drawing/2014/main" id="{76A2759B-5758-91B9-0237-CF2071F65525}"/>
+                <a16:creationId xmlns:a16="http://schemas.microsoft.com/office/drawing/2014/main" id="{AD8865AD-1BBF-2A3C-F536-984E963AC745}"/>
               </a:ext>
             </a:extLst>
           </p:cNvPr>
@@ -10260,7 +10261,7 @@
           <p:cNvPr id="12" name="TextBox 11">
             <a:extLst>
               <a:ext uri="{FF2B5EF4-FFF2-40B4-BE49-F238E27FC236}">
-                <a16:creationId xmlns:a16="http://schemas.microsoft.com/office/drawing/2014/main" id="{DFA93CBE-35EF-E6D5-B46F-1CA772660772}"/>
+                <a16:creationId xmlns:a16="http://schemas.microsoft.com/office/drawing/2014/main" id="{9F268EEC-1A98-DF7B-40FD-07A43E3C1D1A}"/>
               </a:ext>
             </a:extLst>
           </p:cNvPr>
@@ -10300,7 +10301,7 @@
           <p:cNvPr id="13" name="TextBox 12">
             <a:extLst>
               <a:ext uri="{FF2B5EF4-FFF2-40B4-BE49-F238E27FC236}">
-                <a16:creationId xmlns:a16="http://schemas.microsoft.com/office/drawing/2014/main" id="{407E1F6E-B392-04A8-5AC4-8210F3144380}"/>
+                <a16:creationId xmlns:a16="http://schemas.microsoft.com/office/drawing/2014/main" id="{51CBF15E-8007-BD48-BB1C-7C6A5C1BC971}"/>
               </a:ext>
             </a:extLst>
           </p:cNvPr>
@@ -10340,7 +10341,7 @@
           <p:cNvPr id="14" name="Straight Connector 13">
             <a:extLst>
               <a:ext uri="{FF2B5EF4-FFF2-40B4-BE49-F238E27FC236}">
-                <a16:creationId xmlns:a16="http://schemas.microsoft.com/office/drawing/2014/main" id="{67C37603-7E46-C2E8-0D32-191543F67101}"/>
+                <a16:creationId xmlns:a16="http://schemas.microsoft.com/office/drawing/2014/main" id="{AA5B351B-13F1-8DFF-B30C-133C1EA9DE4E}"/>
               </a:ext>
             </a:extLst>
           </p:cNvPr>
@@ -10381,7 +10382,7 @@
           <p:cNvPr id="15" name="TextBox 14">
             <a:extLst>
               <a:ext uri="{FF2B5EF4-FFF2-40B4-BE49-F238E27FC236}">
-                <a16:creationId xmlns:a16="http://schemas.microsoft.com/office/drawing/2014/main" id="{A56F1153-33AF-F88B-93EF-026D8DF8D613}"/>
+                <a16:creationId xmlns:a16="http://schemas.microsoft.com/office/drawing/2014/main" id="{7C9B74C5-F94F-8902-41B0-FFA66C67946A}"/>
               </a:ext>
             </a:extLst>
           </p:cNvPr>
@@ -10421,7 +10422,7 @@
           <p:cNvPr id="16" name="Rectangle: Rounded Corners 15">
             <a:extLst>
               <a:ext uri="{FF2B5EF4-FFF2-40B4-BE49-F238E27FC236}">
-                <a16:creationId xmlns:a16="http://schemas.microsoft.com/office/drawing/2014/main" id="{BB53D4D6-5C91-35F5-0888-EF2960AFC726}"/>
+                <a16:creationId xmlns:a16="http://schemas.microsoft.com/office/drawing/2014/main" id="{0B16E9B9-8EC7-4127-5D6F-26B315485D78}"/>
               </a:ext>
             </a:extLst>
           </p:cNvPr>
@@ -10475,7 +10476,7 @@
           <p:cNvPr id="17" name="Rectangle: Rounded Corners 16">
             <a:extLst>
               <a:ext uri="{FF2B5EF4-FFF2-40B4-BE49-F238E27FC236}">
-                <a16:creationId xmlns:a16="http://schemas.microsoft.com/office/drawing/2014/main" id="{4B58E791-0888-A7CF-683E-97DB324E01D7}"/>
+                <a16:creationId xmlns:a16="http://schemas.microsoft.com/office/drawing/2014/main" id="{E08AA0D5-A297-BAD0-0D0F-64FBBE56EBCD}"/>
               </a:ext>
             </a:extLst>
           </p:cNvPr>
@@ -10529,7 +10530,7 @@
           <p:cNvPr id="18" name="TextBox 17">
             <a:extLst>
               <a:ext uri="{FF2B5EF4-FFF2-40B4-BE49-F238E27FC236}">
-                <a16:creationId xmlns:a16="http://schemas.microsoft.com/office/drawing/2014/main" id="{FA348DE2-73C2-A5F0-616D-AB7093DC22E8}"/>
+                <a16:creationId xmlns:a16="http://schemas.microsoft.com/office/drawing/2014/main" id="{32D5F3A5-62FD-4E2F-3718-2B568FD9B705}"/>
               </a:ext>
             </a:extLst>
           </p:cNvPr>
@@ -10570,7 +10571,7 @@
           <p:cNvPr id="19" name="TextBox 18">
             <a:extLst>
               <a:ext uri="{FF2B5EF4-FFF2-40B4-BE49-F238E27FC236}">
-                <a16:creationId xmlns:a16="http://schemas.microsoft.com/office/drawing/2014/main" id="{23AF60DD-964B-89F5-2DCE-7EC334170D0B}"/>
+                <a16:creationId xmlns:a16="http://schemas.microsoft.com/office/drawing/2014/main" id="{EA0A243D-B214-CFC7-C2F0-A5E37C9BB51D}"/>
               </a:ext>
             </a:extLst>
           </p:cNvPr>
@@ -10610,7 +10611,7 @@
           <p:cNvPr id="20" name="TextBox 19">
             <a:extLst>
               <a:ext uri="{FF2B5EF4-FFF2-40B4-BE49-F238E27FC236}">
-                <a16:creationId xmlns:a16="http://schemas.microsoft.com/office/drawing/2014/main" id="{FB1A2628-E83E-A6D7-9D5D-C8081B69F4AB}"/>
+                <a16:creationId xmlns:a16="http://schemas.microsoft.com/office/drawing/2014/main" id="{E3820048-1775-36C4-D334-F5D6D8F7B50B}"/>
               </a:ext>
             </a:extLst>
           </p:cNvPr>
@@ -10650,7 +10651,7 @@
           <p:cNvPr id="21" name="TextBox 20">
             <a:extLst>
               <a:ext uri="{FF2B5EF4-FFF2-40B4-BE49-F238E27FC236}">
-                <a16:creationId xmlns:a16="http://schemas.microsoft.com/office/drawing/2014/main" id="{5354AE13-BE18-6234-D4CD-8233D011A84E}"/>
+                <a16:creationId xmlns:a16="http://schemas.microsoft.com/office/drawing/2014/main" id="{3072D7BB-EC68-523C-FCFA-004B17F21C74}"/>
               </a:ext>
             </a:extLst>
           </p:cNvPr>
@@ -10690,7 +10691,7 @@
           <p:cNvPr id="22" name="TextBox 21">
             <a:extLst>
               <a:ext uri="{FF2B5EF4-FFF2-40B4-BE49-F238E27FC236}">
-                <a16:creationId xmlns:a16="http://schemas.microsoft.com/office/drawing/2014/main" id="{1D74DAD1-B29D-A521-A8B4-F5B768218561}"/>
+                <a16:creationId xmlns:a16="http://schemas.microsoft.com/office/drawing/2014/main" id="{7277899E-5EE1-87D2-6044-E57341282C41}"/>
               </a:ext>
             </a:extLst>
           </p:cNvPr>
@@ -10730,7 +10731,7 @@
           <p:cNvPr id="23" name="Straight Connector 22">
             <a:extLst>
               <a:ext uri="{FF2B5EF4-FFF2-40B4-BE49-F238E27FC236}">
-                <a16:creationId xmlns:a16="http://schemas.microsoft.com/office/drawing/2014/main" id="{442773D6-7015-2F44-82E9-A17F0C9393BD}"/>
+                <a16:creationId xmlns:a16="http://schemas.microsoft.com/office/drawing/2014/main" id="{E46F72D3-EE87-609C-9B18-E7427854B978}"/>
               </a:ext>
             </a:extLst>
           </p:cNvPr>
@@ -10771,7 +10772,7 @@
           <p:cNvPr id="24" name="TextBox 23">
             <a:extLst>
               <a:ext uri="{FF2B5EF4-FFF2-40B4-BE49-F238E27FC236}">
-                <a16:creationId xmlns:a16="http://schemas.microsoft.com/office/drawing/2014/main" id="{62D98428-AB3E-6F39-2B10-2BF045C6B00E}"/>
+                <a16:creationId xmlns:a16="http://schemas.microsoft.com/office/drawing/2014/main" id="{C974E273-D9D7-025E-274A-17511FEBC72B}"/>
               </a:ext>
             </a:extLst>
           </p:cNvPr>
@@ -10811,7 +10812,7 @@
           <p:cNvPr id="25" name="Rectangle: Rounded Corners 24">
             <a:extLst>
               <a:ext uri="{FF2B5EF4-FFF2-40B4-BE49-F238E27FC236}">
-                <a16:creationId xmlns:a16="http://schemas.microsoft.com/office/drawing/2014/main" id="{33082765-DCF6-2A74-9394-08E755F033DA}"/>
+                <a16:creationId xmlns:a16="http://schemas.microsoft.com/office/drawing/2014/main" id="{A5DB8A69-06E8-07E0-3DCA-600F00941F2F}"/>
               </a:ext>
             </a:extLst>
           </p:cNvPr>
@@ -10865,7 +10866,7 @@
           <p:cNvPr id="26" name="Rectangle: Rounded Corners 25">
             <a:extLst>
               <a:ext uri="{FF2B5EF4-FFF2-40B4-BE49-F238E27FC236}">
-                <a16:creationId xmlns:a16="http://schemas.microsoft.com/office/drawing/2014/main" id="{68855E4F-5251-A6F3-92DA-A1346C053CDB}"/>
+                <a16:creationId xmlns:a16="http://schemas.microsoft.com/office/drawing/2014/main" id="{7579EA41-7E0D-4D97-C3B6-6AD423FC72A2}"/>
               </a:ext>
             </a:extLst>
           </p:cNvPr>
@@ -10919,7 +10920,7 @@
           <p:cNvPr id="27" name="TextBox 26">
             <a:extLst>
               <a:ext uri="{FF2B5EF4-FFF2-40B4-BE49-F238E27FC236}">
-                <a16:creationId xmlns:a16="http://schemas.microsoft.com/office/drawing/2014/main" id="{5A3CE223-EE94-AF3C-2D48-A7DDDCA2E95D}"/>
+                <a16:creationId xmlns:a16="http://schemas.microsoft.com/office/drawing/2014/main" id="{03565D6B-2F5E-40D4-E84A-23500B85328C}"/>
               </a:ext>
             </a:extLst>
           </p:cNvPr>
@@ -10960,7 +10961,7 @@
           <p:cNvPr id="28" name="TextBox 27">
             <a:extLst>
               <a:ext uri="{FF2B5EF4-FFF2-40B4-BE49-F238E27FC236}">
-                <a16:creationId xmlns:a16="http://schemas.microsoft.com/office/drawing/2014/main" id="{1C7E071A-EB6E-C80C-DE4B-8E62BC1AEE1E}"/>
+                <a16:creationId xmlns:a16="http://schemas.microsoft.com/office/drawing/2014/main" id="{C0CB3C2A-577F-9595-FF76-83FC9D6F1412}"/>
               </a:ext>
             </a:extLst>
           </p:cNvPr>
@@ -11000,7 +11001,7 @@
           <p:cNvPr id="29" name="TextBox 28">
             <a:extLst>
               <a:ext uri="{FF2B5EF4-FFF2-40B4-BE49-F238E27FC236}">
-                <a16:creationId xmlns:a16="http://schemas.microsoft.com/office/drawing/2014/main" id="{1A0E2CE4-C83E-9079-CB06-8C4D8573297A}"/>
+                <a16:creationId xmlns:a16="http://schemas.microsoft.com/office/drawing/2014/main" id="{07F3117A-1F7F-788C-D957-D075DA1446F5}"/>
               </a:ext>
             </a:extLst>
           </p:cNvPr>
@@ -11040,7 +11041,7 @@
           <p:cNvPr id="30" name="TextBox 29">
             <a:extLst>
               <a:ext uri="{FF2B5EF4-FFF2-40B4-BE49-F238E27FC236}">
-                <a16:creationId xmlns:a16="http://schemas.microsoft.com/office/drawing/2014/main" id="{D008B2D8-E16F-5D96-2D4E-F62656D75101}"/>
+                <a16:creationId xmlns:a16="http://schemas.microsoft.com/office/drawing/2014/main" id="{70DB3ABB-B17E-E60A-6972-0F4336373489}"/>
               </a:ext>
             </a:extLst>
           </p:cNvPr>
@@ -11080,7 +11081,7 @@
           <p:cNvPr id="31" name="TextBox 30">
             <a:extLst>
               <a:ext uri="{FF2B5EF4-FFF2-40B4-BE49-F238E27FC236}">
-                <a16:creationId xmlns:a16="http://schemas.microsoft.com/office/drawing/2014/main" id="{7FB6D574-0FB1-D578-2A24-7D7DFE2B2A68}"/>
+                <a16:creationId xmlns:a16="http://schemas.microsoft.com/office/drawing/2014/main" id="{86734D67-8CB7-56F6-1BA6-EB44BFBA11D2}"/>
               </a:ext>
             </a:extLst>
           </p:cNvPr>
@@ -11120,7 +11121,7 @@
           <p:cNvPr id="32" name="Straight Connector 31">
             <a:extLst>
               <a:ext uri="{FF2B5EF4-FFF2-40B4-BE49-F238E27FC236}">
-                <a16:creationId xmlns:a16="http://schemas.microsoft.com/office/drawing/2014/main" id="{7B1F0BEB-1C56-DA86-FBAD-F28D2EF31089}"/>
+                <a16:creationId xmlns:a16="http://schemas.microsoft.com/office/drawing/2014/main" id="{7EBE2EC5-C507-530E-9B25-D32D751E0717}"/>
               </a:ext>
             </a:extLst>
           </p:cNvPr>
@@ -11161,7 +11162,7 @@
           <p:cNvPr id="33" name="TextBox 32">
             <a:extLst>
               <a:ext uri="{FF2B5EF4-FFF2-40B4-BE49-F238E27FC236}">
-                <a16:creationId xmlns:a16="http://schemas.microsoft.com/office/drawing/2014/main" id="{DEF9DB00-D77D-7148-171E-F5C6CB1E2F75}"/>
+                <a16:creationId xmlns:a16="http://schemas.microsoft.com/office/drawing/2014/main" id="{7BDACBC6-7EC8-B02E-28FB-9267FA092A93}"/>
               </a:ext>
             </a:extLst>
           </p:cNvPr>
@@ -11201,7 +11202,7 @@
           <p:cNvPr id="34" name="TextBox 33">
             <a:extLst>
               <a:ext uri="{FF2B5EF4-FFF2-40B4-BE49-F238E27FC236}">
-                <a16:creationId xmlns:a16="http://schemas.microsoft.com/office/drawing/2014/main" id="{43E3272A-835A-3D75-6288-B5ABEDEEB1AE}"/>
+                <a16:creationId xmlns:a16="http://schemas.microsoft.com/office/drawing/2014/main" id="{69B842B5-61F9-C87B-2025-8B11DB4F4A20}"/>
               </a:ext>
             </a:extLst>
           </p:cNvPr>
@@ -11240,7 +11241,7 @@
     </p:spTree>
     <p:extLst>
       <p:ext uri="{BB962C8B-B14F-4D97-AF65-F5344CB8AC3E}">
-        <p14:creationId xmlns:p14="http://schemas.microsoft.com/office/powerpoint/2010/main" val="4041990449"/>
+        <p14:creationId xmlns:p14="http://schemas.microsoft.com/office/powerpoint/2010/main" val="3966796978"/>
       </p:ext>
     </p:extLst>
   </p:cSld>
@@ -11280,7 +11281,7 @@
           <p:cNvPr id="2" name="TextBox 1">
             <a:extLst>
               <a:ext uri="{FF2B5EF4-FFF2-40B4-BE49-F238E27FC236}">
-                <a16:creationId xmlns:a16="http://schemas.microsoft.com/office/drawing/2014/main" id="{4ED077B3-5BB4-7AF4-9351-32FFF6BC13AA}"/>
+                <a16:creationId xmlns:a16="http://schemas.microsoft.com/office/drawing/2014/main" id="{F11CFC21-FD6D-8CED-1361-308827334EED}"/>
               </a:ext>
             </a:extLst>
           </p:cNvPr>
@@ -11320,7 +11321,7 @@
           <p:cNvPr id="3" name="TextBox 2">
             <a:extLst>
               <a:ext uri="{FF2B5EF4-FFF2-40B4-BE49-F238E27FC236}">
-                <a16:creationId xmlns:a16="http://schemas.microsoft.com/office/drawing/2014/main" id="{DAFC65DF-CF07-60D8-B8B2-756A5C5617BC}"/>
+                <a16:creationId xmlns:a16="http://schemas.microsoft.com/office/drawing/2014/main" id="{01601D4B-528E-6AFE-A61D-62EA978F8472}"/>
               </a:ext>
             </a:extLst>
           </p:cNvPr>
@@ -11360,7 +11361,7 @@
           <p:cNvPr id="4" name="Straight Connector 3">
             <a:extLst>
               <a:ext uri="{FF2B5EF4-FFF2-40B4-BE49-F238E27FC236}">
-                <a16:creationId xmlns:a16="http://schemas.microsoft.com/office/drawing/2014/main" id="{FCD19FE5-5DD4-A739-09E9-B840FC966CE7}"/>
+                <a16:creationId xmlns:a16="http://schemas.microsoft.com/office/drawing/2014/main" id="{ABFA973E-B251-61DF-4304-C0C86FDDC6BF}"/>
               </a:ext>
             </a:extLst>
           </p:cNvPr>
@@ -11401,7 +11402,7 @@
           <p:cNvPr id="5" name="TextBox 4">
             <a:extLst>
               <a:ext uri="{FF2B5EF4-FFF2-40B4-BE49-F238E27FC236}">
-                <a16:creationId xmlns:a16="http://schemas.microsoft.com/office/drawing/2014/main" id="{E08D9C73-E947-13C5-A8B9-4994CE487395}"/>
+                <a16:creationId xmlns:a16="http://schemas.microsoft.com/office/drawing/2014/main" id="{5F3A4E5C-74DF-6EEE-A67D-40DB95957CCF}"/>
               </a:ext>
             </a:extLst>
           </p:cNvPr>
@@ -11441,7 +11442,7 @@
           <p:cNvPr id="6" name="TextBox 5">
             <a:extLst>
               <a:ext uri="{FF2B5EF4-FFF2-40B4-BE49-F238E27FC236}">
-                <a16:creationId xmlns:a16="http://schemas.microsoft.com/office/drawing/2014/main" id="{22E257BB-B877-D336-321E-2C12E61CE1C5}"/>
+                <a16:creationId xmlns:a16="http://schemas.microsoft.com/office/drawing/2014/main" id="{D28CE5FC-47DF-4331-0B08-C2A031024321}"/>
               </a:ext>
             </a:extLst>
           </p:cNvPr>
@@ -11482,7 +11483,7 @@
           <p:cNvPr id="7" name="Rectangle: Rounded Corners 6">
             <a:extLst>
               <a:ext uri="{FF2B5EF4-FFF2-40B4-BE49-F238E27FC236}">
-                <a16:creationId xmlns:a16="http://schemas.microsoft.com/office/drawing/2014/main" id="{C3E62BCD-EBE6-4540-090B-8292EE2763CE}"/>
+                <a16:creationId xmlns:a16="http://schemas.microsoft.com/office/drawing/2014/main" id="{965E6737-3A4F-4BFC-78F1-445BD43B36F4}"/>
               </a:ext>
             </a:extLst>
           </p:cNvPr>
@@ -11536,7 +11537,7 @@
           <p:cNvPr id="8" name="TextBox 7">
             <a:extLst>
               <a:ext uri="{FF2B5EF4-FFF2-40B4-BE49-F238E27FC236}">
-                <a16:creationId xmlns:a16="http://schemas.microsoft.com/office/drawing/2014/main" id="{1E0E6A3B-B5A7-E0B4-7299-9E8F460CE94C}"/>
+                <a16:creationId xmlns:a16="http://schemas.microsoft.com/office/drawing/2014/main" id="{7C201F2F-2ECF-2FDA-57DF-F7FB13CD3A8C}"/>
               </a:ext>
             </a:extLst>
           </p:cNvPr>
@@ -11576,7 +11577,7 @@
           <p:cNvPr id="9" name="Oval 8">
             <a:extLst>
               <a:ext uri="{FF2B5EF4-FFF2-40B4-BE49-F238E27FC236}">
-                <a16:creationId xmlns:a16="http://schemas.microsoft.com/office/drawing/2014/main" id="{4FDFF595-A8B6-9217-1AE0-1539762FCB9E}"/>
+                <a16:creationId xmlns:a16="http://schemas.microsoft.com/office/drawing/2014/main" id="{8A7A5797-754F-0078-6F73-CA899E2EC81A}"/>
               </a:ext>
             </a:extLst>
           </p:cNvPr>
@@ -11644,7 +11645,7 @@
           <p:cNvPr id="10" name="TextBox 9">
             <a:extLst>
               <a:ext uri="{FF2B5EF4-FFF2-40B4-BE49-F238E27FC236}">
-                <a16:creationId xmlns:a16="http://schemas.microsoft.com/office/drawing/2014/main" id="{FB1D817F-A4A3-C100-12DC-3DBD727BDA83}"/>
+                <a16:creationId xmlns:a16="http://schemas.microsoft.com/office/drawing/2014/main" id="{E26F9457-7C9D-36B1-136A-01090EA2F6AC}"/>
               </a:ext>
             </a:extLst>
           </p:cNvPr>
@@ -11685,7 +11686,7 @@
           <p:cNvPr id="11" name="TextBox 10">
             <a:extLst>
               <a:ext uri="{FF2B5EF4-FFF2-40B4-BE49-F238E27FC236}">
-                <a16:creationId xmlns:a16="http://schemas.microsoft.com/office/drawing/2014/main" id="{0C847B1E-7593-40EF-6DED-E3C7C7081B13}"/>
+                <a16:creationId xmlns:a16="http://schemas.microsoft.com/office/drawing/2014/main" id="{85DC452F-BC52-FFA0-114B-4ED79036B4DD}"/>
               </a:ext>
             </a:extLst>
           </p:cNvPr>
@@ -11725,7 +11726,7 @@
           <p:cNvPr id="12" name="Oval 11">
             <a:extLst>
               <a:ext uri="{FF2B5EF4-FFF2-40B4-BE49-F238E27FC236}">
-                <a16:creationId xmlns:a16="http://schemas.microsoft.com/office/drawing/2014/main" id="{48E66E08-E3D2-6FEF-6093-93C984896E9E}"/>
+                <a16:creationId xmlns:a16="http://schemas.microsoft.com/office/drawing/2014/main" id="{59B8536B-C361-4FDD-35F2-B34275D3998C}"/>
               </a:ext>
             </a:extLst>
           </p:cNvPr>
@@ -11793,7 +11794,7 @@
           <p:cNvPr id="13" name="TextBox 12">
             <a:extLst>
               <a:ext uri="{FF2B5EF4-FFF2-40B4-BE49-F238E27FC236}">
-                <a16:creationId xmlns:a16="http://schemas.microsoft.com/office/drawing/2014/main" id="{1B37C3CF-EFAF-A679-0F9C-CDF9F22DE0E5}"/>
+                <a16:creationId xmlns:a16="http://schemas.microsoft.com/office/drawing/2014/main" id="{A6F9DF38-10E0-B5DC-1A39-DA726D283E0B}"/>
               </a:ext>
             </a:extLst>
           </p:cNvPr>
@@ -11834,7 +11835,7 @@
           <p:cNvPr id="14" name="TextBox 13">
             <a:extLst>
               <a:ext uri="{FF2B5EF4-FFF2-40B4-BE49-F238E27FC236}">
-                <a16:creationId xmlns:a16="http://schemas.microsoft.com/office/drawing/2014/main" id="{806F854D-3936-EEA4-5D58-AE7E414BBDB4}"/>
+                <a16:creationId xmlns:a16="http://schemas.microsoft.com/office/drawing/2014/main" id="{331349A2-42EF-D157-DF79-60FD893F8527}"/>
               </a:ext>
             </a:extLst>
           </p:cNvPr>
@@ -11874,7 +11875,7 @@
           <p:cNvPr id="15" name="Oval 14">
             <a:extLst>
               <a:ext uri="{FF2B5EF4-FFF2-40B4-BE49-F238E27FC236}">
-                <a16:creationId xmlns:a16="http://schemas.microsoft.com/office/drawing/2014/main" id="{C01A5003-3C64-F6D9-2470-306FF0B3EE12}"/>
+                <a16:creationId xmlns:a16="http://schemas.microsoft.com/office/drawing/2014/main" id="{87DC35A0-3DE3-485D-7FE9-E54CC9A8F931}"/>
               </a:ext>
             </a:extLst>
           </p:cNvPr>
@@ -11942,7 +11943,7 @@
           <p:cNvPr id="16" name="TextBox 15">
             <a:extLst>
               <a:ext uri="{FF2B5EF4-FFF2-40B4-BE49-F238E27FC236}">
-                <a16:creationId xmlns:a16="http://schemas.microsoft.com/office/drawing/2014/main" id="{865DA0D8-537C-8949-6B72-13CA2D355A1A}"/>
+                <a16:creationId xmlns:a16="http://schemas.microsoft.com/office/drawing/2014/main" id="{0125C8E9-7E2C-78BF-2839-73939AED74AC}"/>
               </a:ext>
             </a:extLst>
           </p:cNvPr>
@@ -11983,7 +11984,7 @@
           <p:cNvPr id="17" name="TextBox 16">
             <a:extLst>
               <a:ext uri="{FF2B5EF4-FFF2-40B4-BE49-F238E27FC236}">
-                <a16:creationId xmlns:a16="http://schemas.microsoft.com/office/drawing/2014/main" id="{568F0280-01F0-AF42-72F0-B64FC70E3FF6}"/>
+                <a16:creationId xmlns:a16="http://schemas.microsoft.com/office/drawing/2014/main" id="{B825FCBD-867A-EE19-7E88-08062346E585}"/>
               </a:ext>
             </a:extLst>
           </p:cNvPr>
@@ -12023,7 +12024,7 @@
           <p:cNvPr id="18" name="Oval 17">
             <a:extLst>
               <a:ext uri="{FF2B5EF4-FFF2-40B4-BE49-F238E27FC236}">
-                <a16:creationId xmlns:a16="http://schemas.microsoft.com/office/drawing/2014/main" id="{72EF3BA8-3E1E-5CBC-9975-0A06EC81924B}"/>
+                <a16:creationId xmlns:a16="http://schemas.microsoft.com/office/drawing/2014/main" id="{D85405FC-9D33-5EE2-B671-CF554601BFCA}"/>
               </a:ext>
             </a:extLst>
           </p:cNvPr>
@@ -12091,7 +12092,7 @@
           <p:cNvPr id="19" name="TextBox 18">
             <a:extLst>
               <a:ext uri="{FF2B5EF4-FFF2-40B4-BE49-F238E27FC236}">
-                <a16:creationId xmlns:a16="http://schemas.microsoft.com/office/drawing/2014/main" id="{370D84F2-E23C-9101-1923-DF95A314C606}"/>
+                <a16:creationId xmlns:a16="http://schemas.microsoft.com/office/drawing/2014/main" id="{338BEB60-9752-4507-256D-097EB7298465}"/>
               </a:ext>
             </a:extLst>
           </p:cNvPr>
@@ -12132,7 +12133,7 @@
           <p:cNvPr id="20" name="TextBox 19">
             <a:extLst>
               <a:ext uri="{FF2B5EF4-FFF2-40B4-BE49-F238E27FC236}">
-                <a16:creationId xmlns:a16="http://schemas.microsoft.com/office/drawing/2014/main" id="{C7AFEA45-30E5-4C4F-13BB-37EBCD35F192}"/>
+                <a16:creationId xmlns:a16="http://schemas.microsoft.com/office/drawing/2014/main" id="{04F355C1-F644-3DA7-7F21-069E03E74FB5}"/>
               </a:ext>
             </a:extLst>
           </p:cNvPr>
@@ -12172,7 +12173,7 @@
           <p:cNvPr id="21" name="Rectangle: Rounded Corners 20">
             <a:extLst>
               <a:ext uri="{FF2B5EF4-FFF2-40B4-BE49-F238E27FC236}">
-                <a16:creationId xmlns:a16="http://schemas.microsoft.com/office/drawing/2014/main" id="{DCC1FA36-C048-253E-5EBD-4A497DCD4F2F}"/>
+                <a16:creationId xmlns:a16="http://schemas.microsoft.com/office/drawing/2014/main" id="{7B4082BF-3BD4-F9EF-F913-6C8F19D1EA35}"/>
               </a:ext>
             </a:extLst>
           </p:cNvPr>
@@ -12226,7 +12227,7 @@
           <p:cNvPr id="22" name="TextBox 21">
             <a:extLst>
               <a:ext uri="{FF2B5EF4-FFF2-40B4-BE49-F238E27FC236}">
-                <a16:creationId xmlns:a16="http://schemas.microsoft.com/office/drawing/2014/main" id="{8FDD5FD0-42C1-BCCE-ACEF-6B743F3EF45A}"/>
+                <a16:creationId xmlns:a16="http://schemas.microsoft.com/office/drawing/2014/main" id="{79DAE622-FEA2-8770-27EC-AE0AD1DC2062}"/>
               </a:ext>
             </a:extLst>
           </p:cNvPr>
@@ -12266,7 +12267,7 @@
           <p:cNvPr id="23" name="TextBox 22">
             <a:extLst>
               <a:ext uri="{FF2B5EF4-FFF2-40B4-BE49-F238E27FC236}">
-                <a16:creationId xmlns:a16="http://schemas.microsoft.com/office/drawing/2014/main" id="{03B91B45-79F2-6DEA-AE51-10AFA6CB1171}"/>
+                <a16:creationId xmlns:a16="http://schemas.microsoft.com/office/drawing/2014/main" id="{9F84C149-8E3E-2261-34D7-87567DA9502C}"/>
               </a:ext>
             </a:extLst>
           </p:cNvPr>
@@ -12307,7 +12308,7 @@
           <p:cNvPr id="24" name="TextBox 23">
             <a:extLst>
               <a:ext uri="{FF2B5EF4-FFF2-40B4-BE49-F238E27FC236}">
-                <a16:creationId xmlns:a16="http://schemas.microsoft.com/office/drawing/2014/main" id="{94DE84DC-CE59-2E43-4255-FD8D9334A6BC}"/>
+                <a16:creationId xmlns:a16="http://schemas.microsoft.com/office/drawing/2014/main" id="{B35ED5C4-5C67-E44A-D277-6A13422F77C3}"/>
               </a:ext>
             </a:extLst>
           </p:cNvPr>
@@ -12348,7 +12349,7 @@
           <p:cNvPr id="25" name="TextBox 24">
             <a:extLst>
               <a:ext uri="{FF2B5EF4-FFF2-40B4-BE49-F238E27FC236}">
-                <a16:creationId xmlns:a16="http://schemas.microsoft.com/office/drawing/2014/main" id="{6F4CC7C5-9DC8-1234-9C2A-9D62EA45560D}"/>
+                <a16:creationId xmlns:a16="http://schemas.microsoft.com/office/drawing/2014/main" id="{7878E066-B1E6-3DED-B8B1-5693DAE54DC4}"/>
               </a:ext>
             </a:extLst>
           </p:cNvPr>
@@ -12389,7 +12390,7 @@
           <p:cNvPr id="26" name="TextBox 25">
             <a:extLst>
               <a:ext uri="{FF2B5EF4-FFF2-40B4-BE49-F238E27FC236}">
-                <a16:creationId xmlns:a16="http://schemas.microsoft.com/office/drawing/2014/main" id="{066DB6CC-A4E5-175B-0C68-979C057FDDD7}"/>
+                <a16:creationId xmlns:a16="http://schemas.microsoft.com/office/drawing/2014/main" id="{D1F41BBF-E403-B35E-D978-375FDDA00343}"/>
               </a:ext>
             </a:extLst>
           </p:cNvPr>
@@ -12430,7 +12431,7 @@
           <p:cNvPr id="27" name="TextBox 26">
             <a:extLst>
               <a:ext uri="{FF2B5EF4-FFF2-40B4-BE49-F238E27FC236}">
-                <a16:creationId xmlns:a16="http://schemas.microsoft.com/office/drawing/2014/main" id="{EABA2386-71B7-46AA-9814-E0BD5EDFAE6C}"/>
+                <a16:creationId xmlns:a16="http://schemas.microsoft.com/office/drawing/2014/main" id="{52F000E9-6390-24F3-5D8F-EC4F727AB876}"/>
               </a:ext>
             </a:extLst>
           </p:cNvPr>
@@ -12471,7 +12472,7 @@
           <p:cNvPr id="28" name="TextBox 27">
             <a:extLst>
               <a:ext uri="{FF2B5EF4-FFF2-40B4-BE49-F238E27FC236}">
-                <a16:creationId xmlns:a16="http://schemas.microsoft.com/office/drawing/2014/main" id="{A0BEB97D-70ED-53B6-07D6-93F219E97A7A}"/>
+                <a16:creationId xmlns:a16="http://schemas.microsoft.com/office/drawing/2014/main" id="{CE455286-7D91-174F-E99B-23BBF52B40DA}"/>
               </a:ext>
             </a:extLst>
           </p:cNvPr>
@@ -12512,7 +12513,7 @@
           <p:cNvPr id="29" name="TextBox 28">
             <a:extLst>
               <a:ext uri="{FF2B5EF4-FFF2-40B4-BE49-F238E27FC236}">
-                <a16:creationId xmlns:a16="http://schemas.microsoft.com/office/drawing/2014/main" id="{AE0DD5E8-4C9F-D6FC-8CA7-810B89315AD7}"/>
+                <a16:creationId xmlns:a16="http://schemas.microsoft.com/office/drawing/2014/main" id="{1927E1D3-3874-97ED-1CA0-C0D16F5ED7EE}"/>
               </a:ext>
             </a:extLst>
           </p:cNvPr>
@@ -12553,7 +12554,7 @@
           <p:cNvPr id="30" name="Rectangle: Rounded Corners 29">
             <a:extLst>
               <a:ext uri="{FF2B5EF4-FFF2-40B4-BE49-F238E27FC236}">
-                <a16:creationId xmlns:a16="http://schemas.microsoft.com/office/drawing/2014/main" id="{8C5962B9-5F72-7B02-4DF6-46B14969F186}"/>
+                <a16:creationId xmlns:a16="http://schemas.microsoft.com/office/drawing/2014/main" id="{18D50CC9-7F09-F60C-17BC-DF193AA00041}"/>
               </a:ext>
             </a:extLst>
           </p:cNvPr>
@@ -12607,7 +12608,7 @@
           <p:cNvPr id="31" name="TextBox 30">
             <a:extLst>
               <a:ext uri="{FF2B5EF4-FFF2-40B4-BE49-F238E27FC236}">
-                <a16:creationId xmlns:a16="http://schemas.microsoft.com/office/drawing/2014/main" id="{42248267-208F-4417-0BD7-33A6AB89F7A2}"/>
+                <a16:creationId xmlns:a16="http://schemas.microsoft.com/office/drawing/2014/main" id="{8906048D-D748-69A0-BF60-B517D0FC2132}"/>
               </a:ext>
             </a:extLst>
           </p:cNvPr>
@@ -12647,7 +12648,7 @@
           <p:cNvPr id="32" name="TextBox 31">
             <a:extLst>
               <a:ext uri="{FF2B5EF4-FFF2-40B4-BE49-F238E27FC236}">
-                <a16:creationId xmlns:a16="http://schemas.microsoft.com/office/drawing/2014/main" id="{8E5F4DAE-8B14-184D-D762-96EA7DBEB55D}"/>
+                <a16:creationId xmlns:a16="http://schemas.microsoft.com/office/drawing/2014/main" id="{BED71532-05F5-19D0-9EE7-4E97D384FB4D}"/>
               </a:ext>
             </a:extLst>
           </p:cNvPr>
@@ -12686,7 +12687,7 @@
     </p:spTree>
     <p:extLst>
       <p:ext uri="{BB962C8B-B14F-4D97-AF65-F5344CB8AC3E}">
-        <p14:creationId xmlns:p14="http://schemas.microsoft.com/office/powerpoint/2010/main" val="3748645251"/>
+        <p14:creationId xmlns:p14="http://schemas.microsoft.com/office/powerpoint/2010/main" val="959720157"/>
       </p:ext>
     </p:extLst>
   </p:cSld>
@@ -12726,7 +12727,7 @@
           <p:cNvPr id="2" name="TextBox 1">
             <a:extLst>
               <a:ext uri="{FF2B5EF4-FFF2-40B4-BE49-F238E27FC236}">
-                <a16:creationId xmlns:a16="http://schemas.microsoft.com/office/drawing/2014/main" id="{12E70967-B7CD-2CCF-CAF5-E330C4ACAC5C}"/>
+                <a16:creationId xmlns:a16="http://schemas.microsoft.com/office/drawing/2014/main" id="{7A147615-C860-DB5B-D549-61BFA0B33DBA}"/>
               </a:ext>
             </a:extLst>
           </p:cNvPr>
@@ -12766,7 +12767,7 @@
           <p:cNvPr id="3" name="TextBox 2">
             <a:extLst>
               <a:ext uri="{FF2B5EF4-FFF2-40B4-BE49-F238E27FC236}">
-                <a16:creationId xmlns:a16="http://schemas.microsoft.com/office/drawing/2014/main" id="{53BFCC7D-54CF-0A3A-2140-1AFB6DBE4F38}"/>
+                <a16:creationId xmlns:a16="http://schemas.microsoft.com/office/drawing/2014/main" id="{B26324BC-4DA7-878C-8FBB-6F1E9655ED53}"/>
               </a:ext>
             </a:extLst>
           </p:cNvPr>
@@ -12806,7 +12807,7 @@
           <p:cNvPr id="4" name="Straight Connector 3">
             <a:extLst>
               <a:ext uri="{FF2B5EF4-FFF2-40B4-BE49-F238E27FC236}">
-                <a16:creationId xmlns:a16="http://schemas.microsoft.com/office/drawing/2014/main" id="{D33EE40D-7A73-D3D9-A3FC-E6DFC993A819}"/>
+                <a16:creationId xmlns:a16="http://schemas.microsoft.com/office/drawing/2014/main" id="{68A51235-09D3-0F40-D52C-316B128B9E51}"/>
               </a:ext>
             </a:extLst>
           </p:cNvPr>
@@ -12847,7 +12848,7 @@
           <p:cNvPr id="5" name="TextBox 4">
             <a:extLst>
               <a:ext uri="{FF2B5EF4-FFF2-40B4-BE49-F238E27FC236}">
-                <a16:creationId xmlns:a16="http://schemas.microsoft.com/office/drawing/2014/main" id="{68AC9D0A-20C6-5A3B-694B-F94253931580}"/>
+                <a16:creationId xmlns:a16="http://schemas.microsoft.com/office/drawing/2014/main" id="{2AFE796E-93EB-2CEB-B992-61200EA48895}"/>
               </a:ext>
             </a:extLst>
           </p:cNvPr>
@@ -12887,7 +12888,7 @@
           <p:cNvPr id="6" name="TextBox 5">
             <a:extLst>
               <a:ext uri="{FF2B5EF4-FFF2-40B4-BE49-F238E27FC236}">
-                <a16:creationId xmlns:a16="http://schemas.microsoft.com/office/drawing/2014/main" id="{A33201FA-7A21-7B4C-4D18-5A5A2F8D7632}"/>
+                <a16:creationId xmlns:a16="http://schemas.microsoft.com/office/drawing/2014/main" id="{D3ED49B4-473D-ACB0-84C2-A37025F74920}"/>
               </a:ext>
             </a:extLst>
           </p:cNvPr>
@@ -12928,7 +12929,7 @@
           <p:cNvPr id="7" name="Rectangle: Rounded Corners 6">
             <a:extLst>
               <a:ext uri="{FF2B5EF4-FFF2-40B4-BE49-F238E27FC236}">
-                <a16:creationId xmlns:a16="http://schemas.microsoft.com/office/drawing/2014/main" id="{25D34A68-34A1-9B3E-A1A6-04BEC53704E1}"/>
+                <a16:creationId xmlns:a16="http://schemas.microsoft.com/office/drawing/2014/main" id="{9AD74FDA-6D91-C616-26C2-329130A6C08E}"/>
               </a:ext>
             </a:extLst>
           </p:cNvPr>
@@ -12982,7 +12983,7 @@
           <p:cNvPr id="8" name="TextBox 7">
             <a:extLst>
               <a:ext uri="{FF2B5EF4-FFF2-40B4-BE49-F238E27FC236}">
-                <a16:creationId xmlns:a16="http://schemas.microsoft.com/office/drawing/2014/main" id="{82D56200-9746-A0C7-F8E8-BBF22AB5208E}"/>
+                <a16:creationId xmlns:a16="http://schemas.microsoft.com/office/drawing/2014/main" id="{7B707518-CD55-B49B-34FF-02199219480E}"/>
               </a:ext>
             </a:extLst>
           </p:cNvPr>
@@ -13022,7 +13023,7 @@
           <p:cNvPr id="9" name="Oval 8">
             <a:extLst>
               <a:ext uri="{FF2B5EF4-FFF2-40B4-BE49-F238E27FC236}">
-                <a16:creationId xmlns:a16="http://schemas.microsoft.com/office/drawing/2014/main" id="{569814C7-D1D7-5F7A-31D3-FCEDFDE36A78}"/>
+                <a16:creationId xmlns:a16="http://schemas.microsoft.com/office/drawing/2014/main" id="{E2B88F65-62AD-E5EC-D5F5-65FAAD75450B}"/>
               </a:ext>
             </a:extLst>
           </p:cNvPr>
@@ -13090,7 +13091,7 @@
           <p:cNvPr id="10" name="TextBox 9">
             <a:extLst>
               <a:ext uri="{FF2B5EF4-FFF2-40B4-BE49-F238E27FC236}">
-                <a16:creationId xmlns:a16="http://schemas.microsoft.com/office/drawing/2014/main" id="{57A63019-ECFC-A66F-D663-2DC3BB207380}"/>
+                <a16:creationId xmlns:a16="http://schemas.microsoft.com/office/drawing/2014/main" id="{2B99DCE0-E4FB-0D03-87D1-F67DD871CB15}"/>
               </a:ext>
             </a:extLst>
           </p:cNvPr>
@@ -13131,7 +13132,7 @@
           <p:cNvPr id="11" name="TextBox 10">
             <a:extLst>
               <a:ext uri="{FF2B5EF4-FFF2-40B4-BE49-F238E27FC236}">
-                <a16:creationId xmlns:a16="http://schemas.microsoft.com/office/drawing/2014/main" id="{C2CE8A00-89B8-6F71-ACBE-949308CD8B98}"/>
+                <a16:creationId xmlns:a16="http://schemas.microsoft.com/office/drawing/2014/main" id="{AC84C055-B659-7286-422B-0EC423E9C21E}"/>
               </a:ext>
             </a:extLst>
           </p:cNvPr>
@@ -13171,7 +13172,7 @@
           <p:cNvPr id="12" name="Oval 11">
             <a:extLst>
               <a:ext uri="{FF2B5EF4-FFF2-40B4-BE49-F238E27FC236}">
-                <a16:creationId xmlns:a16="http://schemas.microsoft.com/office/drawing/2014/main" id="{59DB0702-CE7F-6A7B-2A1E-99727E311A3B}"/>
+                <a16:creationId xmlns:a16="http://schemas.microsoft.com/office/drawing/2014/main" id="{B6EEF41C-A757-342A-2DC3-B2A20C535066}"/>
               </a:ext>
             </a:extLst>
           </p:cNvPr>
@@ -13239,7 +13240,7 @@
           <p:cNvPr id="13" name="TextBox 12">
             <a:extLst>
               <a:ext uri="{FF2B5EF4-FFF2-40B4-BE49-F238E27FC236}">
-                <a16:creationId xmlns:a16="http://schemas.microsoft.com/office/drawing/2014/main" id="{974A5893-C95F-4296-B5E6-0ACC126298B8}"/>
+                <a16:creationId xmlns:a16="http://schemas.microsoft.com/office/drawing/2014/main" id="{BB2863AD-C8E5-5801-4282-DD750316EEEE}"/>
               </a:ext>
             </a:extLst>
           </p:cNvPr>
@@ -13280,7 +13281,7 @@
           <p:cNvPr id="14" name="TextBox 13">
             <a:extLst>
               <a:ext uri="{FF2B5EF4-FFF2-40B4-BE49-F238E27FC236}">
-                <a16:creationId xmlns:a16="http://schemas.microsoft.com/office/drawing/2014/main" id="{03DF33F2-3BCF-7669-9104-960EAA5E0EDC}"/>
+                <a16:creationId xmlns:a16="http://schemas.microsoft.com/office/drawing/2014/main" id="{FC4DAD31-5287-86C6-AE29-02A57B204B94}"/>
               </a:ext>
             </a:extLst>
           </p:cNvPr>
@@ -13320,7 +13321,7 @@
           <p:cNvPr id="15" name="Oval 14">
             <a:extLst>
               <a:ext uri="{FF2B5EF4-FFF2-40B4-BE49-F238E27FC236}">
-                <a16:creationId xmlns:a16="http://schemas.microsoft.com/office/drawing/2014/main" id="{0039324F-88C2-4011-6EBC-C27968020A7C}"/>
+                <a16:creationId xmlns:a16="http://schemas.microsoft.com/office/drawing/2014/main" id="{0512010C-D322-81C9-765A-CDA845DDE27C}"/>
               </a:ext>
             </a:extLst>
           </p:cNvPr>
@@ -13388,7 +13389,7 @@
           <p:cNvPr id="16" name="TextBox 15">
             <a:extLst>
               <a:ext uri="{FF2B5EF4-FFF2-40B4-BE49-F238E27FC236}">
-                <a16:creationId xmlns:a16="http://schemas.microsoft.com/office/drawing/2014/main" id="{DF6727F8-228B-213E-C1BC-68F2845FA61A}"/>
+                <a16:creationId xmlns:a16="http://schemas.microsoft.com/office/drawing/2014/main" id="{51011F3D-C373-F9F4-8492-682CF954720B}"/>
               </a:ext>
             </a:extLst>
           </p:cNvPr>
@@ -13429,7 +13430,7 @@
           <p:cNvPr id="17" name="TextBox 16">
             <a:extLst>
               <a:ext uri="{FF2B5EF4-FFF2-40B4-BE49-F238E27FC236}">
-                <a16:creationId xmlns:a16="http://schemas.microsoft.com/office/drawing/2014/main" id="{B8BA8F87-C0F6-F145-7C3B-932E26EE44BF}"/>
+                <a16:creationId xmlns:a16="http://schemas.microsoft.com/office/drawing/2014/main" id="{0C32A023-EAB5-A81E-9044-BD4440BA8D05}"/>
               </a:ext>
             </a:extLst>
           </p:cNvPr>
@@ -13469,7 +13470,7 @@
           <p:cNvPr id="18" name="Rectangle: Rounded Corners 17">
             <a:extLst>
               <a:ext uri="{FF2B5EF4-FFF2-40B4-BE49-F238E27FC236}">
-                <a16:creationId xmlns:a16="http://schemas.microsoft.com/office/drawing/2014/main" id="{2D995A9C-0D1B-7C1F-10E1-02E511016346}"/>
+                <a16:creationId xmlns:a16="http://schemas.microsoft.com/office/drawing/2014/main" id="{5DF5677C-8898-BAEC-A18D-1C54D363BE10}"/>
               </a:ext>
             </a:extLst>
           </p:cNvPr>
@@ -13523,7 +13524,7 @@
           <p:cNvPr id="19" name="TextBox 18">
             <a:extLst>
               <a:ext uri="{FF2B5EF4-FFF2-40B4-BE49-F238E27FC236}">
-                <a16:creationId xmlns:a16="http://schemas.microsoft.com/office/drawing/2014/main" id="{5AF86BD4-E47D-07EB-1276-DB4F9F6213AE}"/>
+                <a16:creationId xmlns:a16="http://schemas.microsoft.com/office/drawing/2014/main" id="{3698694A-E997-1971-23E8-E08022422940}"/>
               </a:ext>
             </a:extLst>
           </p:cNvPr>
@@ -13563,7 +13564,7 @@
           <p:cNvPr id="20" name="TextBox 19">
             <a:extLst>
               <a:ext uri="{FF2B5EF4-FFF2-40B4-BE49-F238E27FC236}">
-                <a16:creationId xmlns:a16="http://schemas.microsoft.com/office/drawing/2014/main" id="{9DAFDB1D-117F-2C4E-F42A-0E3BF72AE617}"/>
+                <a16:creationId xmlns:a16="http://schemas.microsoft.com/office/drawing/2014/main" id="{2B13D515-1E34-3375-96F7-C0771F3EFF81}"/>
               </a:ext>
             </a:extLst>
           </p:cNvPr>
@@ -13603,7 +13604,7 @@
           <p:cNvPr id="21" name="TextBox 20">
             <a:extLst>
               <a:ext uri="{FF2B5EF4-FFF2-40B4-BE49-F238E27FC236}">
-                <a16:creationId xmlns:a16="http://schemas.microsoft.com/office/drawing/2014/main" id="{16F9F54B-47E3-5A14-6092-5890ABBC6DC0}"/>
+                <a16:creationId xmlns:a16="http://schemas.microsoft.com/office/drawing/2014/main" id="{2728D97A-B8BB-276A-FA61-AE05D262919B}"/>
               </a:ext>
             </a:extLst>
           </p:cNvPr>
@@ -13643,7 +13644,7 @@
           <p:cNvPr id="22" name="TextBox 21">
             <a:extLst>
               <a:ext uri="{FF2B5EF4-FFF2-40B4-BE49-F238E27FC236}">
-                <a16:creationId xmlns:a16="http://schemas.microsoft.com/office/drawing/2014/main" id="{AFAB63BC-8848-E945-2292-16F4B8D19509}"/>
+                <a16:creationId xmlns:a16="http://schemas.microsoft.com/office/drawing/2014/main" id="{6A9C01F2-F845-E12B-A308-F412F8B1DDFE}"/>
               </a:ext>
             </a:extLst>
           </p:cNvPr>
@@ -13683,7 +13684,7 @@
           <p:cNvPr id="23" name="Rectangle: Rounded Corners 22">
             <a:extLst>
               <a:ext uri="{FF2B5EF4-FFF2-40B4-BE49-F238E27FC236}">
-                <a16:creationId xmlns:a16="http://schemas.microsoft.com/office/drawing/2014/main" id="{1D3856DF-D0CB-772A-BF95-836C705F48CD}"/>
+                <a16:creationId xmlns:a16="http://schemas.microsoft.com/office/drawing/2014/main" id="{82A413C5-0EA6-F824-21E6-4E0ADA452BAC}"/>
               </a:ext>
             </a:extLst>
           </p:cNvPr>
@@ -13737,7 +13738,7 @@
           <p:cNvPr id="24" name="TextBox 23">
             <a:extLst>
               <a:ext uri="{FF2B5EF4-FFF2-40B4-BE49-F238E27FC236}">
-                <a16:creationId xmlns:a16="http://schemas.microsoft.com/office/drawing/2014/main" id="{975CD87E-651A-07CF-4575-8C1545126B43}"/>
+                <a16:creationId xmlns:a16="http://schemas.microsoft.com/office/drawing/2014/main" id="{A2A70FA4-87DE-B1AD-3CCA-9C1E9C6F7CD0}"/>
               </a:ext>
             </a:extLst>
           </p:cNvPr>
@@ -13777,7 +13778,7 @@
           <p:cNvPr id="25" name="TextBox 24">
             <a:extLst>
               <a:ext uri="{FF2B5EF4-FFF2-40B4-BE49-F238E27FC236}">
-                <a16:creationId xmlns:a16="http://schemas.microsoft.com/office/drawing/2014/main" id="{6BC12C87-FF49-1F03-7FED-F3F21FCD8162}"/>
+                <a16:creationId xmlns:a16="http://schemas.microsoft.com/office/drawing/2014/main" id="{FF5D0C9B-62DC-D5FF-28F8-C21B9841A404}"/>
               </a:ext>
             </a:extLst>
           </p:cNvPr>
@@ -13817,7 +13818,7 @@
           <p:cNvPr id="26" name="TextBox 25">
             <a:extLst>
               <a:ext uri="{FF2B5EF4-FFF2-40B4-BE49-F238E27FC236}">
-                <a16:creationId xmlns:a16="http://schemas.microsoft.com/office/drawing/2014/main" id="{A02933AE-3227-EECA-2272-AD632387A4F9}"/>
+                <a16:creationId xmlns:a16="http://schemas.microsoft.com/office/drawing/2014/main" id="{8A6DA841-52A5-5718-6A34-A009B042F4DB}"/>
               </a:ext>
             </a:extLst>
           </p:cNvPr>
@@ -13857,7 +13858,7 @@
           <p:cNvPr id="27" name="TextBox 26">
             <a:extLst>
               <a:ext uri="{FF2B5EF4-FFF2-40B4-BE49-F238E27FC236}">
-                <a16:creationId xmlns:a16="http://schemas.microsoft.com/office/drawing/2014/main" id="{119BC269-E2E6-5EF3-1BAE-ADA1DB739580}"/>
+                <a16:creationId xmlns:a16="http://schemas.microsoft.com/office/drawing/2014/main" id="{9E87EEB0-DDA1-0C13-FED8-628C1FB1AEEA}"/>
               </a:ext>
             </a:extLst>
           </p:cNvPr>
@@ -13897,7 +13898,7 @@
           <p:cNvPr id="28" name="TextBox 27">
             <a:extLst>
               <a:ext uri="{FF2B5EF4-FFF2-40B4-BE49-F238E27FC236}">
-                <a16:creationId xmlns:a16="http://schemas.microsoft.com/office/drawing/2014/main" id="{4B041517-00A4-D2A4-4EAC-0893B69C3F70}"/>
+                <a16:creationId xmlns:a16="http://schemas.microsoft.com/office/drawing/2014/main" id="{7B56572A-8DE7-FBA3-DDCE-7E999917AFC3}"/>
               </a:ext>
             </a:extLst>
           </p:cNvPr>
@@ -13937,7 +13938,7 @@
           <p:cNvPr id="29" name="TextBox 28">
             <a:extLst>
               <a:ext uri="{FF2B5EF4-FFF2-40B4-BE49-F238E27FC236}">
-                <a16:creationId xmlns:a16="http://schemas.microsoft.com/office/drawing/2014/main" id="{E880C923-F854-9677-5F82-ADEA68516D6B}"/>
+                <a16:creationId xmlns:a16="http://schemas.microsoft.com/office/drawing/2014/main" id="{30C44820-74FA-5877-777B-DB14EA0A5A27}"/>
               </a:ext>
             </a:extLst>
           </p:cNvPr>
@@ -13977,7 +13978,7 @@
           <p:cNvPr id="30" name="TextBox 29">
             <a:extLst>
               <a:ext uri="{FF2B5EF4-FFF2-40B4-BE49-F238E27FC236}">
-                <a16:creationId xmlns:a16="http://schemas.microsoft.com/office/drawing/2014/main" id="{4296AE74-A614-96C7-BC45-4CE6647250C4}"/>
+                <a16:creationId xmlns:a16="http://schemas.microsoft.com/office/drawing/2014/main" id="{C7840C72-2761-9E0B-74BA-D03594D28FB5}"/>
               </a:ext>
             </a:extLst>
           </p:cNvPr>
@@ -14017,7 +14018,7 @@
           <p:cNvPr id="31" name="TextBox 30">
             <a:extLst>
               <a:ext uri="{FF2B5EF4-FFF2-40B4-BE49-F238E27FC236}">
-                <a16:creationId xmlns:a16="http://schemas.microsoft.com/office/drawing/2014/main" id="{298BF34B-381F-A8B6-8784-399FA8A2DEFC}"/>
+                <a16:creationId xmlns:a16="http://schemas.microsoft.com/office/drawing/2014/main" id="{B33466E8-2D5A-44BC-45A1-9EA9FD917BC7}"/>
               </a:ext>
             </a:extLst>
           </p:cNvPr>
@@ -14057,7 +14058,7 @@
           <p:cNvPr id="32" name="Rectangle: Rounded Corners 31">
             <a:extLst>
               <a:ext uri="{FF2B5EF4-FFF2-40B4-BE49-F238E27FC236}">
-                <a16:creationId xmlns:a16="http://schemas.microsoft.com/office/drawing/2014/main" id="{83B94E5A-7BAF-550F-0598-AA09E26D9089}"/>
+                <a16:creationId xmlns:a16="http://schemas.microsoft.com/office/drawing/2014/main" id="{1AB37ADC-F0ED-BADE-9E0E-6DFC70D9945E}"/>
               </a:ext>
             </a:extLst>
           </p:cNvPr>
@@ -14066,8 +14067,8 @@
         </p:nvSpPr>
         <p:spPr>
           <a:xfrm>
-            <a:off x="609600" y="5511800"/>
-            <a:ext cx="10972800" cy="660400"/>
+            <a:off x="609600" y="5461000"/>
+            <a:ext cx="10972800" cy="812800"/>
           </a:xfrm>
           <a:prstGeom prst="roundRect">
             <a:avLst/>
@@ -14111,7 +14112,7 @@
           <p:cNvPr id="33" name="TextBox 32">
             <a:extLst>
               <a:ext uri="{FF2B5EF4-FFF2-40B4-BE49-F238E27FC236}">
-                <a16:creationId xmlns:a16="http://schemas.microsoft.com/office/drawing/2014/main" id="{B7D8890A-DC83-09BC-3503-C49B5FBBFBFF}"/>
+                <a16:creationId xmlns:a16="http://schemas.microsoft.com/office/drawing/2014/main" id="{DEB6B1DE-7E36-31F2-BB26-1D21FE538CA9}"/>
               </a:ext>
             </a:extLst>
           </p:cNvPr>
@@ -14120,8 +14121,8 @@
         </p:nvSpPr>
         <p:spPr>
           <a:xfrm>
-            <a:off x="863600" y="5727700"/>
-            <a:ext cx="965200" cy="276999"/>
+            <a:off x="863600" y="5613400"/>
+            <a:ext cx="1270000" cy="276999"/>
           </a:xfrm>
           <a:prstGeom prst="rect">
             <a:avLst/>
@@ -14135,13 +14136,13 @@
           <a:lstStyle/>
           <a:p>
             <a:r>
-              <a:rPr lang="en-US" sz="1100" b="1">
+              <a:rPr lang="en-US" sz="1000" b="1">
                 <a:solidFill>
                   <a:srgbClr val="755D9B"/>
                 </a:solidFill>
                 <a:latin typeface="Aptos" panose="020B0004020202020204" pitchFamily="34" charset="0"/>
               </a:rPr>
-              <a:t>FEEDBACK</a:t>
+              <a:t>FEEDBACK USED</a:t>
             </a:r>
           </a:p>
         </p:txBody>
@@ -14151,7 +14152,7 @@
           <p:cNvPr id="34" name="TextBox 33">
             <a:extLst>
               <a:ext uri="{FF2B5EF4-FFF2-40B4-BE49-F238E27FC236}">
-                <a16:creationId xmlns:a16="http://schemas.microsoft.com/office/drawing/2014/main" id="{BCC6A394-BB7B-42D5-24B6-174C2336E127}"/>
+                <a16:creationId xmlns:a16="http://schemas.microsoft.com/office/drawing/2014/main" id="{866AFEAD-8079-DEE0-82C8-614D331FA92D}"/>
               </a:ext>
             </a:extLst>
           </p:cNvPr>
@@ -14160,8 +14161,8 @@
         </p:nvSpPr>
         <p:spPr>
           <a:xfrm>
-            <a:off x="1930400" y="5689600"/>
-            <a:ext cx="9398000" cy="276999"/>
+            <a:off x="2260600" y="5588000"/>
+            <a:ext cx="9067800" cy="276999"/>
           </a:xfrm>
           <a:prstGeom prst="rect">
             <a:avLst/>
@@ -14174,9 +14175,89 @@
           </a:bodyPr>
           <a:lstStyle/>
           <a:p>
+            <a:r>
+              <a:rPr lang="en-US" sz="1100">
+                <a:solidFill>
+                  <a:srgbClr val="546987"/>
+                </a:solidFill>
+                <a:latin typeface="Aptos" panose="020B0004020202020204" pitchFamily="34" charset="0"/>
+              </a:rPr>
+              <a:t>Audit trail retained; second fixture recorded as future work; clean rehearsal not called independent.</a:t>
+            </a:r>
+          </a:p>
+        </p:txBody>
+      </p:sp>
+      <p:sp>
+        <p:nvSpPr>
+          <p:cNvPr id="35" name="TextBox 34">
+            <a:extLst>
+              <a:ext uri="{FF2B5EF4-FFF2-40B4-BE49-F238E27FC236}">
+                <a16:creationId xmlns:a16="http://schemas.microsoft.com/office/drawing/2014/main" id="{16693F01-0F74-4E19-505D-778F971DEB4A}"/>
+              </a:ext>
+            </a:extLst>
+          </p:cNvPr>
+          <p:cNvSpPr txBox="1"/>
+          <p:nvPr/>
+        </p:nvSpPr>
+        <p:spPr>
+          <a:xfrm>
+            <a:off x="863600" y="5943600"/>
+            <a:ext cx="431800" cy="276999"/>
+          </a:xfrm>
+          <a:prstGeom prst="rect">
+            <a:avLst/>
+          </a:prstGeom>
+          <a:noFill/>
+        </p:spPr>
+        <p:txBody>
+          <a:bodyPr vert="horz" wrap="square" lIns="0" tIns="0" rIns="0" bIns="0" rtlCol="0" anchor="t">
+            <a:noAutofit/>
+          </a:bodyPr>
+          <a:lstStyle/>
+          <a:p>
+            <a:r>
+              <a:rPr lang="en-US" sz="1000" b="1">
+                <a:solidFill>
+                  <a:srgbClr val="496FA8"/>
+                </a:solidFill>
+                <a:latin typeface="Aptos" panose="020B0004020202020204" pitchFamily="34" charset="0"/>
+              </a:rPr>
+              <a:t>ASK</a:t>
+            </a:r>
+          </a:p>
+        </p:txBody>
+      </p:sp>
+      <p:sp>
+        <p:nvSpPr>
+          <p:cNvPr id="36" name="TextBox 35">
+            <a:extLst>
+              <a:ext uri="{FF2B5EF4-FFF2-40B4-BE49-F238E27FC236}">
+                <a16:creationId xmlns:a16="http://schemas.microsoft.com/office/drawing/2014/main" id="{E9AFFCBA-82E8-FEB7-5399-C4F9B246C04A}"/>
+              </a:ext>
+            </a:extLst>
+          </p:cNvPr>
+          <p:cNvSpPr txBox="1"/>
+          <p:nvPr/>
+        </p:nvSpPr>
+        <p:spPr>
+          <a:xfrm>
+            <a:off x="1422400" y="5905500"/>
+            <a:ext cx="9906000" cy="276999"/>
+          </a:xfrm>
+          <a:prstGeom prst="rect">
+            <a:avLst/>
+          </a:prstGeom>
+          <a:noFill/>
+        </p:spPr>
+        <p:txBody>
+          <a:bodyPr vert="horz" wrap="square" lIns="0" tIns="0" rIns="0" bIns="0" rtlCol="0" anchor="t">
+            <a:noAutofit/>
+          </a:bodyPr>
+          <a:lstStyle/>
+          <a:p>
             <a:pPr algn="ctr"/>
             <a:r>
-              <a:rPr lang="en-US" sz="1400" b="1">
+              <a:rPr lang="en-US" sz="1300" b="1">
                 <a:solidFill>
                   <a:srgbClr val="102646"/>
                 </a:solidFill>
@@ -14190,7 +14271,7 @@
     </p:spTree>
     <p:extLst>
       <p:ext uri="{BB962C8B-B14F-4D97-AF65-F5344CB8AC3E}">
-        <p14:creationId xmlns:p14="http://schemas.microsoft.com/office/powerpoint/2010/main" val="2305343054"/>
+        <p14:creationId xmlns:p14="http://schemas.microsoft.com/office/powerpoint/2010/main" val="2278974905"/>
       </p:ext>
     </p:extLst>
   </p:cSld>

</xml_diff>